<commit_message>
removed regression line, because spearman is enough for me now
</commit_message>
<xml_diff>
--- a/project/project_background/Final Project Presentation - Ornit - Cancer Bioinfo March 2026.pptx
+++ b/project/project_background/Final Project Presentation - Ornit - Cancer Bioinfo March 2026.pptx
@@ -3873,7 +3873,229 @@
           <a:lstStyle/>
           <a:p>
             <a:pPr marL="0" algn="r" defTabSz="914400" rtl="1" eaLnBrk="1" latinLnBrk="0" hangingPunct="1"/>
-            <a:endParaRPr lang="en-IL" dirty="0"/>
+            <a:r>
+              <a:rPr lang="he-IL" dirty="0"/>
+              <a:t>כאן לקחתי את </a:t>
+            </a:r>
+            <a:r>
+              <a:rPr lang="he-IL" dirty="0" err="1"/>
+              <a:t>הדטא</a:t>
+            </a:r>
+            <a:r>
+              <a:rPr lang="he-IL" dirty="0"/>
+              <a:t> של </a:t>
+            </a:r>
+            <a:r>
+              <a:rPr lang="he-IL" dirty="0" err="1"/>
+              <a:t>ג׳יני</a:t>
+            </a:r>
+            <a:r>
+              <a:rPr lang="he-IL" dirty="0"/>
+              <a:t> עם פרופיל  tp53 לכל אחד </a:t>
+            </a:r>
+            <a:r>
+              <a:rPr lang="he-IL" dirty="0" err="1"/>
+              <a:t>מהסאמפלים</a:t>
+            </a:r>
+            <a:r>
+              <a:rPr lang="he-IL" dirty="0"/>
+              <a:t> (מוטנט או לא).</a:t>
+            </a:r>
+          </a:p>
+          <a:p>
+            <a:pPr marL="0" algn="r" defTabSz="914400" rtl="1" eaLnBrk="1" latinLnBrk="0" hangingPunct="1"/>
+            <a:endParaRPr lang="he-IL" dirty="0"/>
+          </a:p>
+          <a:p>
+            <a:pPr marL="0" algn="r" defTabSz="914400" rtl="1" eaLnBrk="1" latinLnBrk="0" hangingPunct="1"/>
+            <a:r>
+              <a:rPr lang="he-IL" dirty="0"/>
+              <a:t>ב-</a:t>
+            </a:r>
+            <a:r>
+              <a:rPr lang="en-US" dirty="0"/>
+              <a:t>TP53 CNA values</a:t>
+            </a:r>
+            <a:r>
+              <a:rPr lang="he-IL" dirty="0"/>
+              <a:t>: 0 אומר </a:t>
+            </a:r>
+            <a:r>
+              <a:rPr lang="en-US" dirty="0"/>
+              <a:t>WT</a:t>
+            </a:r>
+            <a:r>
+              <a:rPr lang="he-IL" dirty="0"/>
+              <a:t>, ז״א אין </a:t>
+            </a:r>
+            <a:r>
+              <a:rPr lang="en-US" dirty="0"/>
+              <a:t>copy number change</a:t>
+            </a:r>
+            <a:r>
+              <a:rPr lang="he-IL" dirty="0"/>
+              <a:t>, </a:t>
+            </a:r>
+            <a:r>
+              <a:rPr lang="en-US" dirty="0"/>
+              <a:t>-1</a:t>
+            </a:r>
+            <a:r>
+              <a:rPr lang="he-IL" dirty="0"/>
+              <a:t> זה </a:t>
+            </a:r>
+            <a:r>
+              <a:rPr lang="en-US" dirty="0"/>
+              <a:t>shallow deletion</a:t>
+            </a:r>
+            <a:r>
+              <a:rPr lang="he-IL" dirty="0"/>
+              <a:t>, </a:t>
+            </a:r>
+            <a:r>
+              <a:rPr lang="en-US" dirty="0"/>
+              <a:t>-2</a:t>
+            </a:r>
+            <a:r>
+              <a:rPr lang="he-IL" dirty="0"/>
+              <a:t> זה </a:t>
+            </a:r>
+            <a:r>
+              <a:rPr lang="en-US" dirty="0"/>
+              <a:t>deep deletion</a:t>
+            </a:r>
+            <a:r>
+              <a:rPr lang="he-IL" dirty="0"/>
+              <a:t>, 1 זה </a:t>
+            </a:r>
+            <a:r>
+              <a:rPr lang="en-US" dirty="0"/>
+              <a:t>low amplification</a:t>
+            </a:r>
+            <a:r>
+              <a:rPr lang="he-IL" dirty="0"/>
+              <a:t>, 2 זה </a:t>
+            </a:r>
+            <a:r>
+              <a:rPr lang="en-US" dirty="0"/>
+              <a:t>high amplification</a:t>
+            </a:r>
+            <a:r>
+              <a:rPr lang="he-IL" dirty="0"/>
+              <a:t>. </a:t>
+            </a:r>
+            <a:r>
+              <a:rPr lang="en-US" dirty="0"/>
+              <a:t>NP</a:t>
+            </a:r>
+            <a:r>
+              <a:rPr lang="he-IL" dirty="0"/>
+              <a:t> אומר שזה </a:t>
+            </a:r>
+            <a:r>
+              <a:rPr lang="en-US" dirty="0"/>
+              <a:t>not profiled</a:t>
+            </a:r>
+            <a:r>
+              <a:rPr lang="he-IL" dirty="0"/>
+              <a:t>. אז כאן, כל מה שהוא 0 הוא </a:t>
+            </a:r>
+            <a:r>
+              <a:rPr lang="en-US" dirty="0"/>
+              <a:t>WT</a:t>
+            </a:r>
+            <a:r>
+              <a:rPr lang="he-IL" dirty="0"/>
+              <a:t>. את זה בדקתי מול </a:t>
+            </a:r>
+            <a:r>
+              <a:rPr lang="en-US" dirty="0" err="1"/>
+              <a:t>mutantions.txt</a:t>
+            </a:r>
+            <a:r>
+              <a:rPr lang="he-IL" dirty="0"/>
+              <a:t> </a:t>
+            </a:r>
+            <a:r>
+              <a:rPr lang="he-IL" dirty="0" err="1"/>
+              <a:t>מג׳יני</a:t>
+            </a:r>
+            <a:r>
+              <a:rPr lang="he-IL" dirty="0"/>
+              <a:t>, שם מצוין לכל </a:t>
+            </a:r>
+            <a:r>
+              <a:rPr lang="he-IL" dirty="0" err="1"/>
+              <a:t>סאמפל</a:t>
+            </a:r>
+            <a:r>
+              <a:rPr lang="he-IL" dirty="0"/>
+              <a:t> איזו מוטציה של </a:t>
+            </a:r>
+            <a:r>
+              <a:rPr lang="en-US" dirty="0"/>
+              <a:t>TP53</a:t>
+            </a:r>
+            <a:r>
+              <a:rPr lang="he-IL" dirty="0"/>
+              <a:t> יש לו. </a:t>
+            </a:r>
+            <a:r>
+              <a:rPr lang="en-US" dirty="0"/>
+              <a:t>WT</a:t>
+            </a:r>
+            <a:r>
+              <a:rPr lang="he-IL" dirty="0"/>
+              <a:t> אמיתי זה כשאין לנו מוטציה ואין לנו </a:t>
+            </a:r>
+            <a:r>
+              <a:rPr lang="en-US" dirty="0"/>
+              <a:t>CNA</a:t>
+            </a:r>
+            <a:r>
+              <a:rPr lang="he-IL" dirty="0"/>
+              <a:t>. מוטציה מוגדרת </a:t>
+            </a:r>
+            <a:r>
+              <a:rPr lang="he-IL" dirty="0" err="1"/>
+              <a:t>ככזו</a:t>
+            </a:r>
+            <a:r>
+              <a:rPr lang="he-IL" dirty="0"/>
+              <a:t> אם מצוין ב-</a:t>
+            </a:r>
+            <a:r>
+              <a:rPr lang="en-US" dirty="0" err="1"/>
+              <a:t>mutations.txt</a:t>
+            </a:r>
+            <a:r>
+              <a:rPr lang="he-IL" dirty="0"/>
+              <a:t> שיש פה </a:t>
+            </a:r>
+            <a:r>
+              <a:rPr lang="en-US" dirty="0"/>
+              <a:t>somatic point mutation</a:t>
+            </a:r>
+            <a:r>
+              <a:rPr lang="he-IL" dirty="0"/>
+              <a:t>, לא משנה אם יש לנו </a:t>
+            </a:r>
+            <a:r>
+              <a:rPr lang="en-US" dirty="0"/>
+              <a:t>CNA</a:t>
+            </a:r>
+            <a:r>
+              <a:rPr lang="he-IL" dirty="0"/>
+              <a:t> עליו או לא. אם יש רק </a:t>
+            </a:r>
+            <a:r>
+              <a:rPr lang="en-US" dirty="0"/>
+              <a:t>CNA</a:t>
+            </a:r>
+            <a:r>
+              <a:rPr lang="he-IL" dirty="0"/>
+              <a:t>, אז לא החשבתי את זה כמוטציה.</a:t>
+            </a:r>
           </a:p>
         </p:txBody>
       </p:sp>
@@ -3975,7 +4197,168 @@
           <a:bodyPr/>
           <a:lstStyle/>
           <a:p>
-            <a:endParaRPr lang="en-IL" dirty="0"/>
+            <a:pPr marL="0" algn="r" defTabSz="914400" rtl="1" eaLnBrk="1" latinLnBrk="0" hangingPunct="1"/>
+            <a:r>
+              <a:rPr lang="he-IL" dirty="0"/>
+              <a:t>אז ראיתי </a:t>
+            </a:r>
+            <a:r>
+              <a:rPr lang="he-IL" dirty="0" err="1"/>
+              <a:t>שסאמפלים</a:t>
+            </a:r>
+            <a:r>
+              <a:rPr lang="he-IL" dirty="0"/>
+              <a:t> עם מוטציות ב-</a:t>
+            </a:r>
+            <a:r>
+              <a:rPr lang="en-US" dirty="0"/>
+              <a:t>TP53</a:t>
+            </a:r>
+            <a:r>
+              <a:rPr lang="he-IL" dirty="0"/>
+              <a:t> יש להן יותר כאוס </a:t>
+            </a:r>
+            <a:r>
+              <a:rPr lang="he-IL" dirty="0" err="1"/>
+              <a:t>גנומי</a:t>
+            </a:r>
+            <a:r>
+              <a:rPr lang="he-IL" dirty="0"/>
+              <a:t>, אבל האם יש איזושהי קורלציה בין כמה המוטציה פונקציונאלית לבין הכאוס </a:t>
+            </a:r>
+            <a:r>
+              <a:rPr lang="he-IL" dirty="0" err="1"/>
+              <a:t>הגנומי</a:t>
+            </a:r>
+            <a:r>
+              <a:rPr lang="he-IL" dirty="0"/>
+              <a:t> שמדדנו? ז״א האם ככל שמוטציה פחות פונקציונאלית ככה יש לנו יותר כאוס?</a:t>
+            </a:r>
+          </a:p>
+          <a:p>
+            <a:pPr marL="0" algn="r" defTabSz="914400" rtl="1" eaLnBrk="1" latinLnBrk="0" hangingPunct="1"/>
+            <a:r>
+              <a:rPr lang="he-IL" dirty="0"/>
+              <a:t>את ה-</a:t>
+            </a:r>
+            <a:r>
+              <a:rPr lang="en-US" dirty="0"/>
+              <a:t>EFS</a:t>
+            </a:r>
+            <a:r>
+              <a:rPr lang="he-IL" dirty="0"/>
+              <a:t> הוצאתי מ-</a:t>
+            </a:r>
+            <a:r>
+              <a:rPr lang="en-US" dirty="0" err="1"/>
+              <a:t>Giancomelli</a:t>
+            </a:r>
+            <a:r>
+              <a:rPr lang="he-IL" dirty="0"/>
+              <a:t>.</a:t>
+            </a:r>
+          </a:p>
+          <a:p>
+            <a:pPr marL="0" algn="r" defTabSz="914400" rtl="1" eaLnBrk="1" latinLnBrk="0" hangingPunct="1"/>
+            <a:r>
+              <a:rPr lang="he-IL" dirty="0"/>
+              <a:t>הקו הכחול הוא ה-</a:t>
+            </a:r>
+            <a:r>
+              <a:rPr lang="en-US" dirty="0"/>
+              <a:t>linear regression fit</a:t>
+            </a:r>
+            <a:r>
+              <a:rPr lang="he-IL" dirty="0"/>
+              <a:t>.</a:t>
+            </a:r>
+          </a:p>
+          <a:p>
+            <a:pPr marL="0" algn="r" defTabSz="914400" rtl="1" eaLnBrk="1" latinLnBrk="0" hangingPunct="1"/>
+            <a:r>
+              <a:rPr lang="he-IL" dirty="0"/>
+              <a:t>לקחתי את שם המוטציה (נניח </a:t>
+            </a:r>
+            <a:r>
+              <a:rPr lang="en-US" dirty="0"/>
+              <a:t>R175H</a:t>
+            </a:r>
+            <a:r>
+              <a:rPr lang="he-IL" dirty="0"/>
+              <a:t>) </a:t>
+            </a:r>
+            <a:r>
+              <a:rPr lang="he-IL" dirty="0" err="1"/>
+              <a:t>מג׳יני</a:t>
+            </a:r>
+            <a:r>
+              <a:rPr lang="he-IL" dirty="0"/>
+              <a:t> ובדקתי </a:t>
+            </a:r>
+            <a:r>
+              <a:rPr lang="he-IL" dirty="0" err="1"/>
+              <a:t>בדטא</a:t>
+            </a:r>
+            <a:r>
+              <a:rPr lang="he-IL" dirty="0"/>
+              <a:t> של </a:t>
+            </a:r>
+            <a:r>
+              <a:rPr lang="en-US" dirty="0"/>
+              <a:t>Giacomelli</a:t>
+            </a:r>
+            <a:r>
+              <a:rPr lang="he-IL" dirty="0"/>
+              <a:t> מה ה-</a:t>
+            </a:r>
+            <a:r>
+              <a:rPr lang="en-US" dirty="0"/>
+              <a:t>EFS</a:t>
+            </a:r>
+            <a:r>
+              <a:rPr lang="he-IL" dirty="0"/>
+              <a:t> של המוטציה הזו. </a:t>
+            </a:r>
+          </a:p>
+          <a:p>
+            <a:pPr marL="0" algn="r" defTabSz="914400" rtl="1" eaLnBrk="1" latinLnBrk="0" hangingPunct="1"/>
+            <a:r>
+              <a:rPr lang="he-IL" dirty="0"/>
+              <a:t>הקורלציה קיימת, אבל האפקט הוא די נמוך. יצא לי </a:t>
+            </a:r>
+            <a:r>
+              <a:rPr lang="he-IL" dirty="0" err="1"/>
+              <a:t>סיגניפיקנטי</a:t>
+            </a:r>
+            <a:r>
+              <a:rPr lang="he-IL" dirty="0"/>
+              <a:t> ככל הנראה בגלל כמות </a:t>
+            </a:r>
+            <a:r>
+              <a:rPr lang="he-IL" dirty="0" err="1"/>
+              <a:t>סאמפלים</a:t>
+            </a:r>
+            <a:r>
+              <a:rPr lang="he-IL" dirty="0"/>
+              <a:t> גבוהה, אבל האפקט הביולוגי די נמוך, ז״א כמה </a:t>
+            </a:r>
+            <a:r>
+              <a:rPr lang="en-US" dirty="0"/>
+              <a:t>TP53</a:t>
+            </a:r>
+            <a:r>
+              <a:rPr lang="he-IL" dirty="0"/>
+              <a:t> לא פונקציונלי לא בהכרח חוזה לנו כמה כאוס </a:t>
+            </a:r>
+            <a:r>
+              <a:rPr lang="he-IL" dirty="0" err="1"/>
+              <a:t>גנומי</a:t>
+            </a:r>
+            <a:r>
+              <a:rPr lang="he-IL"/>
+              <a:t> יהיה.</a:t>
+            </a:r>
+            <a:endParaRPr lang="he-IL" dirty="0"/>
           </a:p>
         </p:txBody>
       </p:sp>
@@ -11764,8 +12147,8 @@
         </p:blipFill>
         <p:spPr>
           <a:xfrm>
-            <a:off x="2207461" y="2344398"/>
-            <a:ext cx="7772400" cy="3288323"/>
+            <a:off x="2081147" y="2344398"/>
+            <a:ext cx="8029705" cy="3397183"/>
           </a:xfrm>
           <a:prstGeom prst="rect">
             <a:avLst/>

</xml_diff>

<commit_message>
used tcga instead of msk-impact for an unbiased analysis
</commit_message>
<xml_diff>
--- a/project/project_background/Final Project Presentation - Ornit - Cancer Bioinfo March 2026.pptx
+++ b/project/project_background/Final Project Presentation - Ornit - Cancer Bioinfo March 2026.pptx
@@ -4734,6 +4734,37 @@
               <a:rPr lang="he-IL" dirty="0"/>
               <a:t>. המוטציות ההרסניות ביותר הן גם הנדירות ביותר.</a:t>
             </a:r>
+          </a:p>
+          <a:p>
+            <a:pPr marL="0" algn="r" defTabSz="914400" rtl="1" eaLnBrk="1" latinLnBrk="0" hangingPunct="1"/>
+            <a:r>
+              <a:rPr lang="he-IL" dirty="0"/>
+              <a:t>מה שכן, בגלל שאין הרבה מהמוטציות הנדירות ביותר, אי אפשר להגיד שבהכרח הן הכי הרסניות, כי </a:t>
+            </a:r>
+            <a:r>
+              <a:rPr lang="he-IL" dirty="0" err="1"/>
+              <a:t>הסאמפל</a:t>
+            </a:r>
+            <a:r>
+              <a:rPr lang="he-IL" dirty="0"/>
+              <a:t> </a:t>
+            </a:r>
+            <a:r>
+              <a:rPr lang="he-IL" dirty="0" err="1"/>
+              <a:t>סייז</a:t>
+            </a:r>
+            <a:r>
+              <a:rPr lang="he-IL" dirty="0"/>
+              <a:t> נמוך. ז״א היה מעניין לראות האם התוצאות האלה חוזרות על עצמן כשיש לנו את אותם מספר </a:t>
+            </a:r>
+            <a:r>
+              <a:rPr lang="he-IL" dirty="0" err="1"/>
+              <a:t>סאמפלים</a:t>
+            </a:r>
+            <a:r>
+              <a:rPr lang="he-IL" dirty="0"/>
+              <a:t>.</a:t>
+            </a:r>
             <a:endParaRPr lang="en-IL" dirty="0"/>
           </a:p>
         </p:txBody>
@@ -4842,6 +4873,182 @@
           <a:bodyPr/>
           <a:lstStyle/>
           <a:p>
+            <a:pPr marL="0" algn="r" defTabSz="914400" rtl="1" eaLnBrk="1" latinLnBrk="0" hangingPunct="1"/>
+            <a:r>
+              <a:rPr lang="he-IL" dirty="0"/>
+              <a:t>אחרי זה השאלה האחרונה שרציתי לענות עליה היא האם יש לסוגי סרטן מסוימים נטייה לאפקט חזק יותר של כאוס </a:t>
+            </a:r>
+            <a:r>
+              <a:rPr lang="he-IL" dirty="0" err="1"/>
+              <a:t>גנומי</a:t>
+            </a:r>
+            <a:r>
+              <a:rPr lang="he-IL" dirty="0"/>
+              <a:t>? בצד שמאל בדקתי </a:t>
+            </a:r>
+            <a:r>
+              <a:rPr lang="he-IL" dirty="0" err="1"/>
+              <a:t>מהה</a:t>
+            </a:r>
+            <a:r>
+              <a:rPr lang="he-IL" dirty="0"/>
+              <a:t>-</a:t>
+            </a:r>
+            <a:r>
+              <a:rPr lang="en-US" dirty="0"/>
+              <a:t>Fold Change</a:t>
+            </a:r>
+            <a:r>
+              <a:rPr lang="he-IL" dirty="0"/>
+              <a:t> בין מוטציה ל-</a:t>
+            </a:r>
+            <a:r>
+              <a:rPr lang="en-US" dirty="0"/>
+              <a:t>WT</a:t>
+            </a:r>
+            <a:r>
+              <a:rPr lang="he-IL" dirty="0"/>
+              <a:t>, ז״א ההבדלים הכי גדולים בין מוטציות ל-</a:t>
+            </a:r>
+            <a:r>
+              <a:rPr lang="en-US" dirty="0"/>
+              <a:t>WT</a:t>
+            </a:r>
+            <a:r>
+              <a:rPr lang="he-IL" dirty="0"/>
+              <a:t> קרו בסרטנים שנמצאים גבוה יותר. לקחתי סוגי סרטן עם לפחות 30 </a:t>
+            </a:r>
+            <a:r>
+              <a:rPr lang="he-IL" dirty="0" err="1"/>
+              <a:t>סאמפלים</a:t>
+            </a:r>
+            <a:r>
+              <a:rPr lang="he-IL" dirty="0"/>
+              <a:t>, גם מוטנט וגם ב-</a:t>
+            </a:r>
+            <a:r>
+              <a:rPr lang="en-US" dirty="0"/>
+              <a:t>WT</a:t>
+            </a:r>
+            <a:r>
+              <a:rPr lang="he-IL" dirty="0"/>
+              <a:t> (</a:t>
+            </a:r>
+            <a:r>
+              <a:rPr lang="en-US" dirty="0" err="1"/>
+              <a:t>mann-whitney</a:t>
+            </a:r>
+            <a:r>
+              <a:rPr lang="en-US" dirty="0"/>
+              <a:t> U test</a:t>
+            </a:r>
+            <a:r>
+              <a:rPr lang="he-IL" dirty="0"/>
+              <a:t>, </a:t>
+            </a:r>
+            <a:r>
+              <a:rPr lang="he-IL" dirty="0" err="1"/>
+              <a:t>וה</a:t>
+            </a:r>
+            <a:r>
+              <a:rPr lang="he-IL" dirty="0"/>
+              <a:t>-</a:t>
+            </a:r>
+            <a:r>
+              <a:rPr lang="en-US" dirty="0"/>
+              <a:t>p-values</a:t>
+            </a:r>
+            <a:r>
+              <a:rPr lang="he-IL" dirty="0"/>
+              <a:t> תוקנו ל-</a:t>
+            </a:r>
+            <a:r>
+              <a:rPr lang="en-US" dirty="0"/>
+              <a:t>FDR</a:t>
+            </a:r>
+            <a:r>
+              <a:rPr lang="he-IL" dirty="0"/>
+              <a:t>), את השאר העפתי.</a:t>
+            </a:r>
+          </a:p>
+          <a:p>
+            <a:pPr marL="0" algn="r" defTabSz="914400" rtl="1" eaLnBrk="1" latinLnBrk="0" hangingPunct="1"/>
+            <a:r>
+              <a:rPr lang="he-IL" dirty="0"/>
+              <a:t>בצד הימני בדקתי את ה-</a:t>
+            </a:r>
+            <a:r>
+              <a:rPr lang="en-US" dirty="0"/>
+              <a:t>raw FGA</a:t>
+            </a:r>
+            <a:r>
+              <a:rPr lang="he-IL" dirty="0"/>
+              <a:t> ל-</a:t>
+            </a:r>
+            <a:r>
+              <a:rPr lang="en-US" dirty="0" err="1"/>
+              <a:t>wt</a:t>
+            </a:r>
+            <a:r>
+              <a:rPr lang="he-IL" dirty="0"/>
+              <a:t> ומוטנט עפ״י סוג סרטן. כאן דווקא רואים משהו אחר, למשל סרטני דם (</a:t>
+            </a:r>
+            <a:r>
+              <a:rPr lang="en-US" dirty="0"/>
+              <a:t>blood cancer</a:t>
+            </a:r>
+            <a:r>
+              <a:rPr lang="he-IL" dirty="0"/>
+              <a:t>, </a:t>
+            </a:r>
+            <a:r>
+              <a:rPr lang="en-US" dirty="0"/>
+              <a:t>myelodysplastic syndromes</a:t>
+            </a:r>
+            <a:r>
+              <a:rPr lang="he-IL" dirty="0"/>
+              <a:t> ולוקמיה) אמנם יש להם </a:t>
+            </a:r>
+            <a:r>
+              <a:rPr lang="he-IL" dirty="0" err="1"/>
+              <a:t>פולד</a:t>
+            </a:r>
+            <a:r>
+              <a:rPr lang="he-IL" dirty="0"/>
+              <a:t> </a:t>
+            </a:r>
+            <a:r>
+              <a:rPr lang="he-IL" dirty="0" err="1"/>
+              <a:t>צ׳יינג</a:t>
+            </a:r>
+            <a:r>
+              <a:rPr lang="he-IL" dirty="0"/>
+              <a:t>׳ גבוה לכאורה, אבל בגלל שב-</a:t>
+            </a:r>
+            <a:r>
+              <a:rPr lang="en-US" dirty="0"/>
+              <a:t>WT</a:t>
+            </a:r>
+            <a:r>
+              <a:rPr lang="he-IL" dirty="0"/>
+              <a:t> ה-</a:t>
+            </a:r>
+            <a:r>
+              <a:rPr lang="en-US" dirty="0"/>
+              <a:t>FGA</a:t>
+            </a:r>
+            <a:r>
+              <a:rPr lang="he-IL" dirty="0"/>
+              <a:t> כל כך קרוב ל-0 כל עליה בערכים הופכת להיות משמעותית. לעומת זאת </a:t>
+            </a:r>
+            <a:r>
+              <a:rPr lang="en-US" dirty="0"/>
+              <a:t>solid tumors</a:t>
+            </a:r>
+            <a:r>
+              <a:rPr lang="he-IL" dirty="0"/>
+              <a:t> מראים אפקטים חזקים.</a:t>
+            </a:r>
             <a:endParaRPr lang="en-IL" dirty="0"/>
           </a:p>
         </p:txBody>
@@ -4950,7 +5157,223 @@
           <a:bodyPr/>
           <a:lstStyle/>
           <a:p>
-            <a:endParaRPr lang="en-IL" dirty="0"/>
+            <a:pPr marL="0" algn="r" defTabSz="914400" rtl="1" eaLnBrk="1" latinLnBrk="0" hangingPunct="1"/>
+            <a:r>
+              <a:rPr lang="he-IL" dirty="0"/>
+              <a:t>פה עברנו כבר לאנליזה המשנית, רציתי לבדוק באופן ספציפי אילו גנים נמחקים הכי הרבה ואילו גנים מוגברים הכי הרבה.</a:t>
+            </a:r>
+            <a:endParaRPr lang="en-US" dirty="0"/>
+          </a:p>
+          <a:p>
+            <a:pPr marL="0" algn="r" defTabSz="914400" rtl="1" eaLnBrk="1" latinLnBrk="0" hangingPunct="1"/>
+            <a:r>
+              <a:rPr lang="he-IL" dirty="0"/>
+              <a:t>לקחתי את </a:t>
+            </a:r>
+            <a:r>
+              <a:rPr lang="he-IL" dirty="0" err="1"/>
+              <a:t>הסאמפלים</a:t>
+            </a:r>
+            <a:r>
+              <a:rPr lang="he-IL" dirty="0"/>
+              <a:t> המוטנטים עם ה-</a:t>
+            </a:r>
+            <a:r>
+              <a:rPr lang="en-US" dirty="0"/>
+              <a:t>FGA</a:t>
+            </a:r>
+            <a:r>
+              <a:rPr lang="he-IL" dirty="0"/>
+              <a:t> הכי גבוה </a:t>
+            </a:r>
+            <a:r>
+              <a:rPr lang="he-IL" dirty="0" err="1"/>
+              <a:t>וסאמפלים</a:t>
+            </a:r>
+            <a:r>
+              <a:rPr lang="he-IL" dirty="0"/>
+              <a:t> </a:t>
+            </a:r>
+            <a:r>
+              <a:rPr lang="en-US" dirty="0"/>
+              <a:t>WT</a:t>
+            </a:r>
+            <a:r>
+              <a:rPr lang="he-IL" dirty="0"/>
+              <a:t> עם </a:t>
+            </a:r>
+            <a:r>
+              <a:rPr lang="en-US" dirty="0"/>
+              <a:t>FGA</a:t>
+            </a:r>
+            <a:r>
+              <a:rPr lang="he-IL" dirty="0"/>
+              <a:t> נמוך, ובדקתי מה האחוז של </a:t>
+            </a:r>
+            <a:r>
+              <a:rPr lang="he-IL" dirty="0" err="1"/>
+              <a:t>הסאמפלים</a:t>
+            </a:r>
+            <a:r>
+              <a:rPr lang="he-IL" dirty="0"/>
+              <a:t> עם המוטציות ב-</a:t>
+            </a:r>
+            <a:r>
+              <a:rPr lang="en-US" dirty="0"/>
+              <a:t>TP53</a:t>
+            </a:r>
+            <a:r>
+              <a:rPr lang="he-IL" dirty="0"/>
+              <a:t> עם </a:t>
+            </a:r>
+            <a:r>
+              <a:rPr lang="en-US" dirty="0"/>
+              <a:t>FGA</a:t>
+            </a:r>
+            <a:r>
+              <a:rPr lang="he-IL" dirty="0"/>
+              <a:t> גבוה יש להם גן מסוים שהוא מוגבר או נמחק, פחות האחוז של הגידולים עם </a:t>
+            </a:r>
+            <a:r>
+              <a:rPr lang="en-US" dirty="0"/>
+              <a:t>TP53</a:t>
+            </a:r>
+            <a:r>
+              <a:rPr lang="he-IL" dirty="0"/>
+              <a:t> שהוא </a:t>
+            </a:r>
+            <a:r>
+              <a:rPr lang="en-US" dirty="0"/>
+              <a:t>WT</a:t>
+            </a:r>
+            <a:r>
+              <a:rPr lang="he-IL" dirty="0"/>
+              <a:t> עם </a:t>
+            </a:r>
+            <a:r>
+              <a:rPr lang="en-US" dirty="0"/>
+              <a:t>FGA</a:t>
+            </a:r>
+            <a:r>
+              <a:rPr lang="he-IL" dirty="0"/>
+              <a:t> נמוך (</a:t>
+            </a:r>
+            <a:r>
+              <a:rPr lang="en-US" sz="1200" b="0" i="0" kern="1200" dirty="0" err="1">
+                <a:solidFill>
+                  <a:schemeClr val="tx1"/>
+                </a:solidFill>
+                <a:effectLst/>
+                <a:latin typeface="+mn-lt"/>
+                <a:ea typeface="+mn-ea"/>
+                <a:cs typeface="+mn-cs"/>
+              </a:rPr>
+              <a:t>fisher_exact</a:t>
+            </a:r>
+            <a:r>
+              <a:rPr lang="en-US" sz="1200" b="0" i="0" kern="1200" dirty="0">
+                <a:solidFill>
+                  <a:schemeClr val="tx1"/>
+                </a:solidFill>
+                <a:effectLst/>
+                <a:latin typeface="+mn-lt"/>
+                <a:ea typeface="+mn-ea"/>
+                <a:cs typeface="+mn-cs"/>
+              </a:rPr>
+              <a:t> method</a:t>
+            </a:r>
+            <a:r>
+              <a:rPr lang="he-IL" sz="1200" b="0" i="0" kern="1200" dirty="0">
+                <a:solidFill>
+                  <a:schemeClr val="tx1"/>
+                </a:solidFill>
+                <a:effectLst/>
+                <a:latin typeface="+mn-lt"/>
+                <a:ea typeface="+mn-ea"/>
+                <a:cs typeface="+mn-cs"/>
+              </a:rPr>
+              <a:t>)</a:t>
+            </a:r>
+            <a:endParaRPr lang="en-US" dirty="0"/>
+          </a:p>
+          <a:p>
+            <a:pPr marL="0" algn="r" defTabSz="914400" rtl="1" eaLnBrk="1" latinLnBrk="0" hangingPunct="1"/>
+            <a:r>
+              <a:rPr lang="he-IL" dirty="0"/>
+              <a:t>רואים פה בבירור שיש כאן </a:t>
+            </a:r>
+            <a:r>
+              <a:rPr lang="he-IL" dirty="0" err="1"/>
+              <a:t>אונקוגנים</a:t>
+            </a:r>
+            <a:r>
+              <a:rPr lang="he-IL" dirty="0"/>
+              <a:t> קלאסיים כמו </a:t>
+            </a:r>
+            <a:r>
+              <a:rPr lang="en-US" dirty="0"/>
+              <a:t>MYC</a:t>
+            </a:r>
+            <a:r>
+              <a:rPr lang="he-IL" dirty="0"/>
+              <a:t> לצד </a:t>
+            </a:r>
+            <a:r>
+              <a:rPr lang="he-IL" dirty="0" err="1"/>
+              <a:t>טומר</a:t>
+            </a:r>
+            <a:r>
+              <a:rPr lang="he-IL" dirty="0"/>
+              <a:t> </a:t>
+            </a:r>
+            <a:r>
+              <a:rPr lang="he-IL" dirty="0" err="1"/>
+              <a:t>סופרסורים</a:t>
+            </a:r>
+            <a:r>
+              <a:rPr lang="he-IL" dirty="0"/>
+              <a:t> שנמחקים כמו </a:t>
+            </a:r>
+            <a:r>
+              <a:rPr lang="en-US" dirty="0"/>
+              <a:t>CDKN2A</a:t>
+            </a:r>
+            <a:r>
+              <a:rPr lang="he-IL" dirty="0"/>
+              <a:t> ו-</a:t>
+            </a:r>
+            <a:r>
+              <a:rPr lang="en-US" dirty="0"/>
+              <a:t>PTEN</a:t>
+            </a:r>
+            <a:r>
+              <a:rPr lang="he-IL" dirty="0"/>
+              <a:t> או גנים שמבקרים </a:t>
+            </a:r>
+            <a:r>
+              <a:rPr lang="en-US" dirty="0"/>
+              <a:t>cell cycle</a:t>
+            </a:r>
+            <a:r>
+              <a:rPr lang="he-IL" dirty="0"/>
+              <a:t> כמו </a:t>
+            </a:r>
+            <a:r>
+              <a:rPr lang="en-US" dirty="0"/>
+              <a:t>RB1</a:t>
+            </a:r>
+            <a:r>
+              <a:rPr lang="he-IL" dirty="0"/>
+              <a:t> ו-</a:t>
+            </a:r>
+            <a:r>
+              <a:rPr lang="en-US" dirty="0"/>
+              <a:t>CDKN2B</a:t>
+            </a:r>
+            <a:r>
+              <a:rPr lang="he-IL" dirty="0"/>
+              <a:t>.</a:t>
+            </a:r>
           </a:p>
         </p:txBody>
       </p:sp>
@@ -5058,6 +5481,27 @@
           <a:bodyPr/>
           <a:lstStyle/>
           <a:p>
+            <a:pPr marL="0" algn="r" defTabSz="914400" rtl="1" eaLnBrk="1" latinLnBrk="0" hangingPunct="1"/>
+            <a:r>
+              <a:rPr lang="he-IL" dirty="0"/>
+              <a:t>כאן בעזרת </a:t>
+            </a:r>
+            <a:r>
+              <a:rPr lang="en-US" dirty="0" err="1"/>
+              <a:t>gseapy</a:t>
+            </a:r>
+            <a:r>
+              <a:rPr lang="he-IL" dirty="0"/>
+              <a:t> בדקתי אילו מסלולים מוגברים כתוצאה מכאוס </a:t>
+            </a:r>
+            <a:r>
+              <a:rPr lang="he-IL" dirty="0" err="1"/>
+              <a:t>גנומי</a:t>
+            </a:r>
+            <a:r>
+              <a:rPr lang="he-IL" dirty="0"/>
+              <a:t>. ובהתאמה למה שראינו בשקופית הקודמת, אנחנו רואים </a:t>
+            </a:r>
             <a:endParaRPr lang="en-IL" dirty="0"/>
           </a:p>
         </p:txBody>
@@ -11746,7 +12190,7 @@
           <a:p>
             <a:r>
               <a:rPr lang="en-US" dirty="0"/>
-              <a:t>MSK-IMPACT (53,292 samples, 505 cancer genes).</a:t>
+              <a:t>TCGA Pan-Cancer Atlas (~10K samples, genome-wide).</a:t>
             </a:r>
           </a:p>
           <a:p>
@@ -12790,8 +13234,8 @@
         </p:nvSpPr>
         <p:spPr>
           <a:xfrm>
-            <a:off x="2585456" y="6174992"/>
-            <a:ext cx="7016408" cy="369332"/>
+            <a:off x="2832736" y="6206143"/>
+            <a:ext cx="6521850" cy="369332"/>
           </a:xfrm>
           <a:prstGeom prst="rect">
             <a:avLst/>
@@ -12806,7 +13250,7 @@
           <a:p>
             <a:r>
               <a:rPr lang="en-US" dirty="0"/>
-              <a:t>Hotspot mutations show variable FGA. Not all hotspots behave the same</a:t>
+              <a:t>The loss of TP53 function itself drives genomic instability uniformly.</a:t>
             </a:r>
           </a:p>
         </p:txBody>
@@ -13162,8 +13606,8 @@
         </p:nvSpPr>
         <p:spPr>
           <a:xfrm>
-            <a:off x="958770" y="6250055"/>
-            <a:ext cx="10519611" cy="369332"/>
+            <a:off x="895881" y="5821166"/>
+            <a:ext cx="10395551" cy="923330"/>
           </a:xfrm>
           <a:prstGeom prst="rect">
             <a:avLst/>
@@ -13171,14 +13615,22 @@
           <a:noFill/>
         </p:spPr>
         <p:txBody>
-          <a:bodyPr wrap="none" rtlCol="0">
+          <a:bodyPr wrap="square" rtlCol="0">
             <a:spAutoFit/>
           </a:bodyPr>
           <a:lstStyle/>
           <a:p>
+            <a:pPr algn="ctr"/>
             <a:r>
               <a:rPr lang="en-US" dirty="0"/>
-              <a:t>EFS-FGA correlation varies substantially by cancer type. Some cancers show strong correlation, others none</a:t>
+              <a:t>All top absolute FGA cancers are solid tumors (Ovarian Cancer, Soft Tissue Sarcoma, and Colorectal Cancer).</a:t>
+            </a:r>
+          </a:p>
+          <a:p>
+            <a:pPr algn="ctr"/>
+            <a:r>
+              <a:rPr lang="en-US" dirty="0"/>
+              <a:t>The blood cancers have the highest fold change but tiny absolute FGA values (~0.03–0.07) because their WT baseline is essentially zero.</a:t>
             </a:r>
           </a:p>
         </p:txBody>
@@ -13205,7 +13657,7 @@
         </p:blipFill>
         <p:spPr>
           <a:xfrm>
-            <a:off x="1672354" y="2137559"/>
+            <a:off x="1672352" y="1934359"/>
             <a:ext cx="8842611" cy="3860973"/>
           </a:xfrm>
           <a:prstGeom prst="rect">
@@ -13408,7 +13860,7 @@
             </a:r>
             <a:r>
               <a:rPr lang="en-US" dirty="0" err="1"/>
-              <a:t>cnaS</a:t>
+              <a:t>cna</a:t>
             </a:r>
             <a:r>
               <a:rPr lang="en-US" dirty="0"/>
@@ -13431,8 +13883,8 @@
         </p:nvSpPr>
         <p:spPr>
           <a:xfrm>
-            <a:off x="2908919" y="6035200"/>
-            <a:ext cx="6619313" cy="646331"/>
+            <a:off x="3082043" y="6035200"/>
+            <a:ext cx="6273064" cy="646331"/>
           </a:xfrm>
           <a:prstGeom prst="rect">
             <a:avLst/>
@@ -13445,15 +13897,17 @@
           </a:bodyPr>
           <a:lstStyle/>
           <a:p>
+            <a:pPr algn="ctr"/>
             <a:r>
               <a:rPr lang="en-US" dirty="0"/>
-              <a:t>Amplified genes (left panel) — oncogenes being turned ON</a:t>
-            </a:r>
-          </a:p>
-          <a:p>
+              <a:t>Amplified genes (left panel): oncogenes being turned ON</a:t>
+            </a:r>
+          </a:p>
+          <a:p>
+            <a:pPr algn="ctr"/>
             <a:r>
               <a:rPr lang="en-US" dirty="0"/>
-              <a:t>Deleted genes (right panel) — tumor suppressors being turned OFF</a:t>
+              <a:t>Deleted genes (right panel): tumor suppressors being turned OFF</a:t>
             </a:r>
           </a:p>
         </p:txBody>
@@ -13698,7 +14152,7 @@
         </p:nvSpPr>
         <p:spPr>
           <a:xfrm>
-            <a:off x="1826190" y="5996699"/>
+            <a:off x="1826190" y="6035200"/>
             <a:ext cx="9079595" cy="646331"/>
           </a:xfrm>
           <a:prstGeom prst="rect">
@@ -13712,6 +14166,7 @@
           </a:bodyPr>
           <a:lstStyle/>
           <a:p>
+            <a:pPr algn="ctr"/>
             <a:r>
               <a:rPr lang="en-US" dirty="0"/>
               <a:t>When TP53 breaks and FGA is high, cell cycle control (E2F, G2-M) and growth signaling (PI3K/AKT/mTOR) pathways are the main downstream consequences</a:t>

</xml_diff>

<commit_message>
fixed EFS corr figure
</commit_message>
<xml_diff>
--- a/project/project_background/Final Project Presentation - Ornit - Cancer Bioinfo March 2026.pptx
+++ b/project/project_background/Final Project Presentation - Ornit - Cancer Bioinfo March 2026.pptx
@@ -3268,7 +3268,7 @@
           <a:p>
             <a:fld id="{4FCD6A08-F84D-254F-876D-619DDBFD23F2}" type="datetimeFigureOut">
               <a:rPr lang="en-IL" smtClean="0"/>
-              <a:t>12/03/2026</a:t>
+              <a:t>18/03/2026</a:t>
             </a:fld>
             <a:endParaRPr lang="en-IL"/>
           </a:p>
@@ -3784,6 +3784,7 @@
               <a:rPr lang="he-IL" dirty="0"/>
               <a:t> אמר לי מה נשבר.</a:t>
             </a:r>
+            <a:endParaRPr lang="en-US" dirty="0"/>
           </a:p>
         </p:txBody>
       </p:sp>
@@ -4023,7 +4024,7 @@
             </a:r>
             <a:r>
               <a:rPr lang="he-IL" dirty="0"/>
-              <a:t>, שם מצוין לכל </a:t>
+              <a:t>, ששם הם מציינים לכל </a:t>
             </a:r>
             <a:r>
               <a:rPr lang="he-IL" dirty="0" err="1"/>
@@ -4263,21 +4264,6 @@
             <a:pPr marL="0" algn="r" defTabSz="914400" rtl="1" eaLnBrk="1" latinLnBrk="0" hangingPunct="1"/>
             <a:r>
               <a:rPr lang="he-IL" dirty="0"/>
-              <a:t>הקו הכחול הוא ה-</a:t>
-            </a:r>
-            <a:r>
-              <a:rPr lang="en-US" dirty="0"/>
-              <a:t>linear regression fit</a:t>
-            </a:r>
-            <a:r>
-              <a:rPr lang="he-IL" dirty="0"/>
-              <a:t>.</a:t>
-            </a:r>
-          </a:p>
-          <a:p>
-            <a:pPr marL="0" algn="r" defTabSz="914400" rtl="1" eaLnBrk="1" latinLnBrk="0" hangingPunct="1"/>
-            <a:r>
-              <a:rPr lang="he-IL" dirty="0"/>
               <a:t>לקחתי את שם המוטציה (נניח </a:t>
             </a:r>
             <a:r>
@@ -5500,11 +5486,7 @@
             </a:r>
             <a:r>
               <a:rPr lang="he-IL" dirty="0"/>
-              <a:t>. ובהתאמה למה שראינו בשקופית הקודמת, אנחנו </a:t>
-            </a:r>
-            <a:r>
-              <a:rPr lang="he-IL"/>
-              <a:t>רואים </a:t>
+              <a:t>. ובהתאמה למה שראינו בשקופית הקודמת, אנחנו רואים </a:t>
             </a:r>
             <a:endParaRPr lang="en-IL" dirty="0"/>
           </a:p>
@@ -5614,6 +5596,7 @@
           <a:bodyPr/>
           <a:lstStyle/>
           <a:p>
+            <a:pPr marL="0" algn="r" defTabSz="914400" rtl="1" eaLnBrk="1" latinLnBrk="0" hangingPunct="1"/>
             <a:endParaRPr lang="en-IL" dirty="0"/>
           </a:p>
         </p:txBody>
@@ -5841,7 +5824,7 @@
             </a:r>
             <a:r>
               <a:rPr lang="he-IL" dirty="0"/>
-              <a:t> להסברים שנתתי בפעם הקודמת: </a:t>
+              <a:t> קצר: </a:t>
             </a:r>
             <a:r>
               <a:rPr lang="en-US" dirty="0"/>
@@ -5897,7 +5880,7 @@
             </a:r>
             <a:r>
               <a:rPr lang="he-IL" dirty="0"/>
-              <a:t> נמצא שם ומניע את התהליכים האלו. מוטציות ב-</a:t>
+              <a:t> נמצא שם ומניע או מבקר את התהליכים האלו. מוטציות ב-</a:t>
             </a:r>
             <a:r>
               <a:rPr lang="en-US" dirty="0"/>
@@ -5905,7 +5888,7 @@
             </a:r>
             <a:r>
               <a:rPr lang="he-IL" dirty="0"/>
-              <a:t> יכולות להשפיע על התהליכים האלו, והן יושבות על איזשהו ספקטרום מבחינת הפנוטיפ שהן גורמות לו, ז״א מוטציות שונות ב-</a:t>
+              <a:t> יכולות להשפיע על המסלולים האלו, והן יושבות על איזשהו ספקטרום מבחינת הפנוטיפ שהן גורמות לו, ז״א מוטציות שונות ב-</a:t>
             </a:r>
             <a:r>
               <a:rPr lang="en-US" dirty="0"/>
@@ -5929,10 +5912,26 @@
             <a:endParaRPr lang="he-IL" dirty="0"/>
           </a:p>
           <a:p>
-            <a:pPr marL="0" algn="r" defTabSz="914400" rtl="1" eaLnBrk="1" latinLnBrk="0" hangingPunct="1"/>
+            <a:pPr marL="0" marR="0" lvl="0" indent="0" algn="r" defTabSz="914400" rtl="1" eaLnBrk="1" fontAlgn="auto" latinLnBrk="0" hangingPunct="1">
+              <a:lnSpc>
+                <a:spcPct val="100000"/>
+              </a:lnSpc>
+              <a:spcBef>
+                <a:spcPts val="0"/>
+              </a:spcBef>
+              <a:spcAft>
+                <a:spcPts val="0"/>
+              </a:spcAft>
+              <a:buClrTx/>
+              <a:buSzTx/>
+              <a:buFontTx/>
+              <a:buNone/>
+              <a:tabLst/>
+              <a:defRPr/>
+            </a:pPr>
             <a:r>
               <a:rPr lang="he-IL" dirty="0"/>
-              <a:t>אחד הדברים שאפשר להגיד ש-</a:t>
+              <a:t>אחת ההשערות שלי היא ש-</a:t>
             </a:r>
             <a:r>
               <a:rPr lang="en-US" dirty="0"/>
@@ -5940,7 +5939,7 @@
             </a:r>
             <a:r>
               <a:rPr lang="he-IL" dirty="0"/>
-              <a:t> יכול להוביל אליהם כשהוא פגום זה </a:t>
+              <a:t> פגום יכול להוביל ל-</a:t>
             </a:r>
             <a:r>
               <a:rPr lang="en-US" dirty="0"/>
@@ -5948,8 +5947,20 @@
             </a:r>
             <a:r>
               <a:rPr lang="he-IL" dirty="0"/>
+              <a:t> וכתוצאה מכך לכאוס </a:t>
+            </a:r>
+            <a:r>
+              <a:rPr lang="he-IL" dirty="0" err="1"/>
+              <a:t>גנומי</a:t>
+            </a:r>
+            <a:r>
+              <a:rPr lang="he-IL" dirty="0"/>
               <a:t>.</a:t>
             </a:r>
+          </a:p>
+          <a:p>
+            <a:pPr marL="0" algn="r" defTabSz="914400" rtl="1" eaLnBrk="1" latinLnBrk="0" hangingPunct="1"/>
+            <a:endParaRPr lang="he-IL" dirty="0"/>
           </a:p>
         </p:txBody>
       </p:sp>
@@ -6274,48 +6285,7 @@
           <a:lstStyle/>
           <a:p>
             <a:pPr marL="0" algn="r" defTabSz="914400" rtl="1" eaLnBrk="1" latinLnBrk="0" hangingPunct="1"/>
-            <a:r>
-              <a:rPr lang="he-IL" dirty="0"/>
-              <a:t>שלום לכולם אני </a:t>
-            </a:r>
-            <a:r>
-              <a:rPr lang="he-IL" dirty="0" err="1"/>
-              <a:t>אורנית</a:t>
-            </a:r>
-            <a:r>
-              <a:rPr lang="he-IL" dirty="0"/>
-              <a:t>, ואני הולכת לדבר על הפרויקט שלי שנקרא ... </a:t>
-            </a:r>
-          </a:p>
-          <a:p>
-            <a:pPr marL="0" algn="r" defTabSz="914400" rtl="1" eaLnBrk="1" latinLnBrk="0" hangingPunct="1"/>
-            <a:r>
-              <a:rPr lang="he-IL" dirty="0"/>
-              <a:t>כדי להבין מה הפרויקט הזה אומר, אני צריכה להסביר מה זה </a:t>
-            </a:r>
-            <a:r>
-              <a:rPr lang="en-US" dirty="0"/>
-              <a:t>TP53</a:t>
-            </a:r>
-            <a:r>
-              <a:rPr lang="he-IL" dirty="0"/>
-              <a:t> ו-</a:t>
-            </a:r>
-            <a:r>
-              <a:rPr lang="en-US" dirty="0"/>
-              <a:t>CNV</a:t>
-            </a:r>
-            <a:r>
-              <a:rPr lang="he-IL" dirty="0"/>
-              <a:t>.</a:t>
-            </a:r>
-          </a:p>
-          <a:p>
-            <a:pPr marL="0" algn="r" defTabSz="914400" rtl="1" eaLnBrk="1" latinLnBrk="0" hangingPunct="1"/>
-            <a:r>
-              <a:rPr lang="he-IL" dirty="0"/>
-              <a:t>אלה שני נושאים שמוזכרים לפעמים יחד בהקשר לסרטן ותכף אסביר למה</a:t>
-            </a:r>
+            <a:endParaRPr lang="he-IL" dirty="0"/>
           </a:p>
         </p:txBody>
       </p:sp>
@@ -6470,8 +6440,134 @@
             </a:r>
             <a:r>
               <a:rPr lang="he-IL" dirty="0"/>
-              <a:t>, </a:t>
-            </a:r>
+              <a:t>.</a:t>
+            </a:r>
+            <a:endParaRPr lang="en-US" dirty="0"/>
+          </a:p>
+          <a:p>
+            <a:pPr marL="0" marR="0" lvl="0" indent="0" algn="r" defTabSz="914400" rtl="1" eaLnBrk="1" fontAlgn="auto" latinLnBrk="0" hangingPunct="1">
+              <a:lnSpc>
+                <a:spcPct val="100000"/>
+              </a:lnSpc>
+              <a:spcBef>
+                <a:spcPts val="0"/>
+              </a:spcBef>
+              <a:spcAft>
+                <a:spcPts val="0"/>
+              </a:spcAft>
+              <a:buClrTx/>
+              <a:buSzTx/>
+              <a:buFontTx/>
+              <a:buNone/>
+              <a:tabLst/>
+              <a:defRPr/>
+            </a:pPr>
+            <a:r>
+              <a:rPr lang="en-US" sz="1200" b="1" i="0" kern="1200" dirty="0">
+                <a:solidFill>
+                  <a:schemeClr val="tx1"/>
+                </a:solidFill>
+                <a:effectLst/>
+                <a:latin typeface="+mn-lt"/>
+                <a:ea typeface="+mn-ea"/>
+                <a:cs typeface="+mn-cs"/>
+              </a:rPr>
+              <a:t>FGA = (number of base pairs with copy number gain or loss) / (total base pairs profiled)</a:t>
+            </a:r>
+          </a:p>
+          <a:p>
+            <a:pPr algn="r" rtl="1"/>
+            <a:r>
+              <a:rPr lang="en-US" dirty="0"/>
+              <a:t>FGA</a:t>
+            </a:r>
+            <a:r>
+              <a:rPr lang="he-IL" dirty="0"/>
+              <a:t> בודק מה הגודל של ה-</a:t>
+            </a:r>
+            <a:r>
+              <a:rPr lang="en-US" dirty="0"/>
+              <a:t>fraction</a:t>
+            </a:r>
+            <a:r>
+              <a:rPr lang="he-IL" dirty="0"/>
+              <a:t> מהגנום שיש לו </a:t>
+            </a:r>
+            <a:r>
+              <a:rPr lang="en-US" dirty="0"/>
+              <a:t>CNV</a:t>
+            </a:r>
+            <a:r>
+              <a:rPr lang="he-IL" dirty="0"/>
+              <a:t>.</a:t>
+            </a:r>
+          </a:p>
+          <a:p>
+            <a:pPr algn="r" rtl="1"/>
+            <a:r>
+              <a:rPr lang="en-US" dirty="0"/>
+              <a:t>CNV</a:t>
+            </a:r>
+            <a:r>
+              <a:rPr lang="he-IL" dirty="0"/>
+              <a:t> מתייחס למקרה ספציפי, </a:t>
+            </a:r>
+            <a:r>
+              <a:rPr lang="en-US" dirty="0"/>
+              <a:t>FGA</a:t>
+            </a:r>
+            <a:r>
+              <a:rPr lang="he-IL" dirty="0"/>
+              <a:t> הוא </a:t>
+            </a:r>
+            <a:r>
+              <a:rPr lang="he-IL" dirty="0" err="1"/>
+              <a:t>סקאלאר</a:t>
+            </a:r>
+            <a:r>
+              <a:rPr lang="he-IL" dirty="0"/>
+              <a:t> אחד שמתאר את ה-</a:t>
+            </a:r>
+            <a:r>
+              <a:rPr lang="en-US" dirty="0"/>
+              <a:t>burden</a:t>
+            </a:r>
+            <a:r>
+              <a:rPr lang="he-IL" dirty="0"/>
+              <a:t> של כל האירועים האלו.</a:t>
+            </a:r>
+          </a:p>
+          <a:p>
+            <a:pPr marL="0" marR="0" lvl="0" indent="0" algn="r" defTabSz="914400" rtl="1" eaLnBrk="1" fontAlgn="auto" latinLnBrk="0" hangingPunct="1">
+              <a:lnSpc>
+                <a:spcPct val="100000"/>
+              </a:lnSpc>
+              <a:spcBef>
+                <a:spcPts val="0"/>
+              </a:spcBef>
+              <a:spcAft>
+                <a:spcPts val="0"/>
+              </a:spcAft>
+              <a:buClrTx/>
+              <a:buSzTx/>
+              <a:buFontTx/>
+              <a:buNone/>
+              <a:tabLst/>
+              <a:defRPr/>
+            </a:pPr>
+            <a:endParaRPr lang="en-US" sz="1200" b="0" i="0" kern="1200" dirty="0">
+              <a:solidFill>
+                <a:schemeClr val="tx1"/>
+              </a:solidFill>
+              <a:effectLst/>
+              <a:latin typeface="+mn-lt"/>
+              <a:ea typeface="+mn-ea"/>
+              <a:cs typeface="+mn-cs"/>
+            </a:endParaRPr>
+          </a:p>
+          <a:p>
+            <a:pPr marL="0" algn="r" defTabSz="914400" rtl="1" eaLnBrk="1" latinLnBrk="0" hangingPunct="1"/>
+            <a:endParaRPr lang="he-IL" dirty="0"/>
           </a:p>
         </p:txBody>
       </p:sp>
@@ -6661,88 +6757,63 @@
           <a:p>
             <a:pPr marL="0" algn="r" defTabSz="914400" rtl="1" eaLnBrk="1" latinLnBrk="0" hangingPunct="1"/>
             <a:r>
-              <a:rPr lang="he-IL" sz="1200" b="0" i="0" kern="1200" dirty="0">
-                <a:solidFill>
-                  <a:schemeClr val="tx1"/>
-                </a:solidFill>
-                <a:effectLst/>
-                <a:latin typeface="+mn-lt"/>
-                <a:ea typeface="+mn-ea"/>
-                <a:cs typeface="+mn-cs"/>
-              </a:rPr>
-              <a:t>בשלב הראשון הם סרקו 8,258 וריאנטים של </a:t>
-            </a:r>
-            <a:r>
-              <a:rPr lang="en-US" sz="1200" b="0" i="0" kern="1200" dirty="0">
-                <a:solidFill>
-                  <a:schemeClr val="tx1"/>
-                </a:solidFill>
-                <a:effectLst/>
-                <a:latin typeface="+mn-lt"/>
-                <a:ea typeface="+mn-ea"/>
-                <a:cs typeface="+mn-cs"/>
-              </a:rPr>
-              <a:t>TP53</a:t>
-            </a:r>
-            <a:r>
-              <a:rPr lang="he-IL" sz="1200" b="0" i="0" kern="1200" dirty="0">
-                <a:solidFill>
-                  <a:schemeClr val="tx1"/>
-                </a:solidFill>
-                <a:effectLst/>
-                <a:latin typeface="+mn-lt"/>
-                <a:ea typeface="+mn-ea"/>
-                <a:cs typeface="+mn-cs"/>
-              </a:rPr>
-              <a:t> ע״י הכנסתם לשני קווי תאים </a:t>
-            </a:r>
-            <a:r>
-              <a:rPr lang="he-IL" sz="1200" b="0" i="0" kern="1200" dirty="0" err="1">
-                <a:solidFill>
-                  <a:schemeClr val="tx1"/>
-                </a:solidFill>
-                <a:effectLst/>
-                <a:latin typeface="+mn-lt"/>
-                <a:ea typeface="+mn-ea"/>
-                <a:cs typeface="+mn-cs"/>
-              </a:rPr>
-              <a:t>איזוגניים</a:t>
-            </a:r>
-            <a:r>
-              <a:rPr lang="he-IL" sz="1200" b="0" i="0" kern="1200" dirty="0">
-                <a:solidFill>
-                  <a:schemeClr val="tx1"/>
-                </a:solidFill>
-                <a:effectLst/>
-                <a:latin typeface="+mn-lt"/>
-                <a:ea typeface="+mn-ea"/>
-                <a:cs typeface="+mn-cs"/>
-              </a:rPr>
-              <a:t>: אחד עם </a:t>
-            </a:r>
-            <a:r>
-              <a:rPr lang="en-US" sz="1200" b="0" i="0" kern="1200" dirty="0">
-                <a:solidFill>
-                  <a:schemeClr val="tx1"/>
-                </a:solidFill>
-                <a:effectLst/>
-                <a:latin typeface="+mn-lt"/>
-                <a:ea typeface="+mn-ea"/>
-                <a:cs typeface="+mn-cs"/>
-              </a:rPr>
-              <a:t>p53</a:t>
-            </a:r>
-            <a:r>
-              <a:rPr lang="he-IL" sz="1200" b="0" i="0" kern="1200" dirty="0">
-                <a:solidFill>
-                  <a:schemeClr val="tx1"/>
-                </a:solidFill>
-                <a:effectLst/>
-                <a:latin typeface="+mn-lt"/>
-                <a:ea typeface="+mn-ea"/>
-                <a:cs typeface="+mn-cs"/>
-              </a:rPr>
-              <a:t> תקין ואחד בלי</a:t>
+              <a:rPr lang="he-IL" dirty="0"/>
+              <a:t>כדי למדוד כמה כל מוטציה ב-</a:t>
+            </a:r>
+            <a:r>
+              <a:rPr lang="en-US" dirty="0"/>
+              <a:t>TP53 </a:t>
+            </a:r>
+            <a:r>
+              <a:rPr lang="he-IL" dirty="0"/>
+              <a:t>באמת פוגעת בתפקוד החלבון, השתמשתי בנתונים שלהם מניסוי </a:t>
+            </a:r>
+            <a:r>
+              <a:rPr lang="he-IL" dirty="0" err="1"/>
+              <a:t>קריספר</a:t>
+            </a:r>
+            <a:r>
+              <a:rPr lang="he-IL" dirty="0"/>
+              <a:t> שהם עשו, שבדק ניסויית למעלה מ-8,000 וריאנטים שונים של </a:t>
+            </a:r>
+            <a:r>
+              <a:rPr lang="en-US" dirty="0"/>
+              <a:t>TP53.</a:t>
+            </a:r>
+            <a:br>
+              <a:rPr lang="en-US" dirty="0"/>
+            </a:br>
+            <a:r>
+              <a:rPr lang="he-IL" dirty="0"/>
+              <a:t>הרעיון פשוט: הכניסו כל וריאנט לתאי סרטן ריאה, חלק עם </a:t>
+            </a:r>
+            <a:r>
+              <a:rPr lang="en-US" dirty="0"/>
+              <a:t>p53 </a:t>
+            </a:r>
+            <a:r>
+              <a:rPr lang="he-IL" dirty="0"/>
+              <a:t> תקין, וחלק ללא</a:t>
+            </a:r>
+            <a:r>
+              <a:rPr lang="en-US" dirty="0"/>
+              <a:t> p53 </a:t>
+            </a:r>
+            <a:r>
+              <a:rPr lang="he-IL" dirty="0"/>
+              <a:t>בכלל, ואז חשפו אותם לתרופות שמפעילות את הביטוי של </a:t>
+            </a:r>
+            <a:r>
+              <a:rPr lang="he-IL" dirty="0" err="1"/>
+              <a:t>p</a:t>
+            </a:r>
+            <a:r>
+              <a:rPr lang="en-US" dirty="0"/>
+              <a:t>53</a:t>
+            </a:r>
+            <a:r>
+              <a:rPr lang="he-IL" dirty="0"/>
+              <a:t>.</a:t>
             </a:r>
             <a:endParaRPr lang="en-US" sz="1200" b="0" i="0" kern="1200" dirty="0">
               <a:solidFill>
@@ -6887,7 +6958,7 @@
                 <a:ea typeface="+mn-ea"/>
                 <a:cs typeface="+mn-cs"/>
               </a:rPr>
-              <a:t>בשלב השני הם רצו למדוד את שכיחות האלל הספציפי שהם בודקים. אחרי 12 ימים הם ריצפו את התאים ששרדו כדי לראות אילו אללים נשארו בחיים. לכל אלל חישבו </a:t>
+              <a:t>בשלב השני הם רצו למדוד את שכיחות האלל הספציפי שהם בודקים. אחרי 12 ימים הם ריצפו את התאים ששרדו כדי לראות אילו וריאנטים נשארו בחיים. לכל אלל חישבו </a:t>
             </a:r>
             <a:r>
               <a:rPr lang="en-US" sz="1200" b="0" i="0" kern="1200" dirty="0">
@@ -6911,31 +6982,7 @@
                 <a:ea typeface="+mn-ea"/>
                 <a:cs typeface="+mn-cs"/>
               </a:rPr>
-              <a:t> ביחס לנקודת הזמן הבסיסית, ז״א האם האלל התעשר או הידלל תחת הלחץ, ונרמלו ל-</a:t>
-            </a:r>
-            <a:r>
-              <a:rPr lang="en-US" sz="1200" b="0" i="0" kern="1200" dirty="0">
-                <a:solidFill>
-                  <a:schemeClr val="tx1"/>
-                </a:solidFill>
-                <a:effectLst/>
-                <a:latin typeface="+mn-lt"/>
-                <a:ea typeface="+mn-ea"/>
-                <a:cs typeface="+mn-cs"/>
-              </a:rPr>
-              <a:t>z-scores</a:t>
-            </a:r>
-            <a:r>
-              <a:rPr lang="he-IL" sz="1200" b="0" i="0" kern="1200" dirty="0">
-                <a:solidFill>
-                  <a:schemeClr val="tx1"/>
-                </a:solidFill>
-                <a:effectLst/>
-                <a:latin typeface="+mn-lt"/>
-                <a:ea typeface="+mn-ea"/>
-                <a:cs typeface="+mn-cs"/>
-              </a:rPr>
-              <a:t> כך שכל אלל קיבל ציון יחסי לכל אחד משלושת התנאים</a:t>
+              <a:t> ביחס לנקודת הזמן הבסיסית, ז״א האם האלל התעשר או הידלל תחת הלחץ.</a:t>
             </a:r>
             <a:endParaRPr lang="en-US" sz="1200" b="0" i="0" kern="1200" dirty="0">
               <a:solidFill>
@@ -7072,23 +7119,23 @@
             </a:pPr>
             <a:r>
               <a:rPr lang="he-IL" dirty="0"/>
-              <a:t>בשלב השלישי הם חיברו את כל ה-</a:t>
+              <a:t>בשלב השלישי הם נתנו ציון לכל אחד </a:t>
+            </a:r>
+            <a:r>
+              <a:rPr lang="he-IL" dirty="0" err="1"/>
+              <a:t>מהוריאנטים</a:t>
+            </a:r>
+            <a:r>
+              <a:rPr lang="he-IL" dirty="0"/>
+              <a:t>, אם וריאנט מתנהג כמו </a:t>
             </a:r>
             <a:r>
               <a:rPr lang="en-US" dirty="0"/>
-              <a:t>z-scores</a:t>
+              <a:t>p53</a:t>
             </a:r>
             <a:r>
               <a:rPr lang="he-IL" dirty="0"/>
-              <a:t> כדי </a:t>
-            </a:r>
-            <a:r>
-              <a:rPr lang="he-IL" dirty="0" err="1"/>
-              <a:t>לכבר</a:t>
-            </a:r>
-            <a:r>
-              <a:rPr lang="he-IL" dirty="0"/>
-              <a:t> מספר יחיד לכל אלל, שזהו ה-</a:t>
+              <a:t>, או כאילו הוא לא נמצא, או משהו באמצע. מהשילוב של שלושת המדידות האלה קיבלנו מספר יחיד, שזה ה-</a:t>
             </a:r>
             <a:r>
               <a:rPr lang="en-US" dirty="0"/>
@@ -7096,7 +7143,7 @@
             </a:r>
             <a:r>
               <a:rPr lang="he-IL" dirty="0"/>
-              <a:t> שהשתמשתי בו. ציון נמוך משמע אובדן תפקוד, ציון גבוה = התנהגות דומה ל-</a:t>
+              <a:t> שהשתמשתי בו, שאומר לנו כמה וריאנט של </a:t>
             </a:r>
             <a:r>
               <a:rPr lang="en-US" dirty="0"/>
@@ -7104,7 +7151,39 @@
             </a:r>
             <a:r>
               <a:rPr lang="he-IL" dirty="0"/>
-              <a:t> תקין.</a:t>
+              <a:t> הוא פעיל. ציון נמוך משמע אובדן תפקוד, ציון גבוה = התנהגות דומה ל-</a:t>
+            </a:r>
+            <a:r>
+              <a:rPr lang="en-US" dirty="0"/>
+              <a:t>p53</a:t>
+            </a:r>
+            <a:r>
+              <a:rPr lang="he-IL" dirty="0"/>
+              <a:t> תקין. הערכים הם </a:t>
+            </a:r>
+            <a:r>
+              <a:rPr lang="en-US" dirty="0"/>
+              <a:t>z-score</a:t>
+            </a:r>
+            <a:r>
+              <a:rPr lang="he-IL" dirty="0"/>
+              <a:t>, אז הם יכולים להיות שליליים או חיוביים. אם הערך שלילי מאוד, המוטציה שוברת את </a:t>
+            </a:r>
+            <a:r>
+              <a:rPr lang="en-US" dirty="0"/>
+              <a:t>p53</a:t>
+            </a:r>
+            <a:r>
+              <a:rPr lang="he-IL" dirty="0"/>
+              <a:t>, אם הוא קרוב ל-0, המוטציה משפיעה הרבה ואם הציון הוא חיובי, הוא דומה ל-</a:t>
+            </a:r>
+            <a:r>
+              <a:rPr lang="en-US" dirty="0"/>
+              <a:t>WT</a:t>
+            </a:r>
+            <a:r>
+              <a:rPr lang="he-IL" dirty="0"/>
+              <a:t>.</a:t>
             </a:r>
             <a:endParaRPr lang="en-US" sz="1200" b="0" i="0" kern="1200" dirty="0">
               <a:solidFill>
@@ -7283,76 +7362,8 @@
             </a:r>
             <a:r>
               <a:rPr lang="he-IL" b="0" dirty="0"/>
-              <a:t>), שזה בעצם המדד שאני משתמשת בו כדי להעריך מה ה-</a:t>
-            </a:r>
-            <a:r>
-              <a:rPr lang="en-US" b="0" dirty="0"/>
-              <a:t>CNA</a:t>
-            </a:r>
-            <a:r>
-              <a:rPr lang="he-IL" b="0" dirty="0"/>
-              <a:t> בתא.</a:t>
-            </a:r>
-          </a:p>
-          <a:p>
-            <a:pPr marL="0" marR="0" lvl="0" indent="0" algn="r" defTabSz="914400" rtl="1" eaLnBrk="1" fontAlgn="auto" latinLnBrk="0" hangingPunct="1">
-              <a:lnSpc>
-                <a:spcPct val="100000"/>
-              </a:lnSpc>
-              <a:spcBef>
-                <a:spcPts val="0"/>
-              </a:spcBef>
-              <a:spcAft>
-                <a:spcPts val="0"/>
-              </a:spcAft>
-              <a:buClrTx/>
-              <a:buSzTx/>
-              <a:buFontTx/>
-              <a:buNone/>
-              <a:tabLst/>
-              <a:defRPr/>
-            </a:pPr>
-            <a:endParaRPr lang="he-IL" b="0" dirty="0"/>
-          </a:p>
-          <a:p>
-            <a:pPr marL="0" marR="0" lvl="0" indent="0" algn="r" defTabSz="914400" rtl="1" eaLnBrk="1" fontAlgn="auto" latinLnBrk="0" hangingPunct="1">
-              <a:lnSpc>
-                <a:spcPct val="100000"/>
-              </a:lnSpc>
-              <a:spcBef>
-                <a:spcPts val="0"/>
-              </a:spcBef>
-              <a:spcAft>
-                <a:spcPts val="0"/>
-              </a:spcAft>
-              <a:buClrTx/>
-              <a:buSzTx/>
-              <a:buFontTx/>
-              <a:buNone/>
-              <a:tabLst/>
-              <a:defRPr/>
-            </a:pPr>
-            <a:endParaRPr lang="he-IL" b="0" dirty="0"/>
-          </a:p>
-          <a:p>
-            <a:pPr marL="0" marR="0" lvl="0" indent="0" algn="r" defTabSz="914400" rtl="1" eaLnBrk="1" fontAlgn="auto" latinLnBrk="0" hangingPunct="1">
-              <a:lnSpc>
-                <a:spcPct val="100000"/>
-              </a:lnSpc>
-              <a:spcBef>
-                <a:spcPts val="0"/>
-              </a:spcBef>
-              <a:spcAft>
-                <a:spcPts val="0"/>
-              </a:spcAft>
-              <a:buClrTx/>
-              <a:buSzTx/>
-              <a:buFontTx/>
-              <a:buNone/>
-              <a:tabLst/>
-              <a:defRPr/>
-            </a:pPr>
-            <a:endParaRPr lang="he-IL" b="0" dirty="0"/>
+              <a:t>).</a:t>
+            </a:r>
           </a:p>
           <a:p>
             <a:pPr lvl="1"/>
@@ -7593,7 +7604,31 @@
                 <a:ea typeface="+mn-ea"/>
                 <a:cs typeface="+mn-cs"/>
               </a:rPr>
-              <a:t> שגורמים ליותר חוסר יציבות?</a:t>
+              <a:t> שגורמים ליותר כאוס </a:t>
+            </a:r>
+            <a:r>
+              <a:rPr lang="he-IL" sz="1200" b="0" i="0" kern="1200" dirty="0" err="1">
+                <a:solidFill>
+                  <a:schemeClr val="tx1"/>
+                </a:solidFill>
+                <a:effectLst/>
+                <a:latin typeface="+mn-lt"/>
+                <a:ea typeface="+mn-ea"/>
+                <a:cs typeface="+mn-cs"/>
+              </a:rPr>
+              <a:t>גנומי</a:t>
+            </a:r>
+            <a:r>
+              <a:rPr lang="he-IL" sz="1200" b="0" i="0" kern="1200" dirty="0">
+                <a:solidFill>
+                  <a:schemeClr val="tx1"/>
+                </a:solidFill>
+                <a:effectLst/>
+                <a:latin typeface="+mn-lt"/>
+                <a:ea typeface="+mn-ea"/>
+                <a:cs typeface="+mn-cs"/>
+              </a:rPr>
+              <a:t>?</a:t>
             </a:r>
           </a:p>
           <a:p>
@@ -7729,7 +7764,7 @@
             </a:r>
             <a:r>
               <a:rPr lang="he-IL" dirty="0"/>
-              <a:t> מתוך 271 אלף </a:t>
+              <a:t> יש מתוך 271 אלף </a:t>
             </a:r>
             <a:r>
               <a:rPr lang="he-IL" dirty="0" err="1"/>
@@ -7757,30 +7792,6 @@
             </a:r>
           </a:p>
           <a:p>
-            <a:pPr algn="r"/>
-            <a:r>
-              <a:rPr lang="en-US" sz="1200" b="1" i="0" kern="1200" dirty="0">
-                <a:solidFill>
-                  <a:schemeClr val="tx1"/>
-                </a:solidFill>
-                <a:effectLst/>
-                <a:latin typeface="+mn-lt"/>
-                <a:ea typeface="+mn-ea"/>
-                <a:cs typeface="+mn-cs"/>
-              </a:rPr>
-              <a:t>FGA = (number of base pairs with copy number gain or loss) / (total base pairs profiled)</a:t>
-            </a:r>
-            <a:endParaRPr lang="en-US" sz="1200" b="0" i="0" kern="1200" dirty="0">
-              <a:solidFill>
-                <a:schemeClr val="tx1"/>
-              </a:solidFill>
-              <a:effectLst/>
-              <a:latin typeface="+mn-lt"/>
-              <a:ea typeface="+mn-ea"/>
-              <a:cs typeface="+mn-cs"/>
-            </a:endParaRPr>
-          </a:p>
-          <a:p>
             <a:pPr algn="r" rtl="1"/>
             <a:r>
               <a:rPr lang="he-IL" dirty="0"/>
@@ -7823,7 +7834,7 @@
             </a:r>
             <a:r>
               <a:rPr lang="he-IL" dirty="0" err="1"/>
-              <a:t>סקאלר</a:t>
+              <a:t>סקאלאר</a:t>
             </a:r>
             <a:r>
               <a:rPr lang="he-IL" dirty="0"/>
@@ -7837,10 +7848,6 @@
               <a:rPr lang="he-IL" dirty="0"/>
               <a:t> של כל האירועים האלו.</a:t>
             </a:r>
-          </a:p>
-          <a:p>
-            <a:pPr algn="r"/>
-            <a:endParaRPr lang="he-IL" dirty="0"/>
           </a:p>
         </p:txBody>
       </p:sp>
@@ -8140,7 +8147,7 @@
             <a:fld id="{A37D6D71-8B28-4ED6-B932-04B197003D23}" type="datetimeFigureOut">
               <a:rPr lang="en-US" smtClean="0"/>
               <a:pPr algn="r"/>
-              <a:t>3/12/26</a:t>
+              <a:t>3/18/26</a:t>
             </a:fld>
             <a:endParaRPr lang="en-US" dirty="0"/>
           </a:p>
@@ -8410,7 +8417,7 @@
             <a:fld id="{A37D6D71-8B28-4ED6-B932-04B197003D23}" type="datetimeFigureOut">
               <a:rPr lang="en-US" smtClean="0"/>
               <a:pPr algn="r"/>
-              <a:t>3/12/26</a:t>
+              <a:t>3/18/26</a:t>
             </a:fld>
             <a:endParaRPr lang="en-US" dirty="0"/>
           </a:p>
@@ -8653,7 +8660,7 @@
             <a:fld id="{A37D6D71-8B28-4ED6-B932-04B197003D23}" type="datetimeFigureOut">
               <a:rPr lang="en-US" smtClean="0"/>
               <a:pPr algn="r"/>
-              <a:t>3/12/26</a:t>
+              <a:t>3/18/26</a:t>
             </a:fld>
             <a:endParaRPr lang="en-US" dirty="0"/>
           </a:p>
@@ -8908,7 +8915,7 @@
             <a:fld id="{A37D6D71-8B28-4ED6-B932-04B197003D23}" type="datetimeFigureOut">
               <a:rPr lang="en-US" smtClean="0"/>
               <a:pPr algn="r"/>
-              <a:t>3/15/26</a:t>
+              <a:t>3/18/26</a:t>
             </a:fld>
             <a:endParaRPr lang="en-US" dirty="0"/>
           </a:p>
@@ -9223,7 +9230,7 @@
             <a:fld id="{A37D6D71-8B28-4ED6-B932-04B197003D23}" type="datetimeFigureOut">
               <a:rPr lang="en-US" smtClean="0"/>
               <a:pPr algn="r"/>
-              <a:t>3/12/26</a:t>
+              <a:t>3/18/26</a:t>
             </a:fld>
             <a:endParaRPr lang="en-US" dirty="0"/>
           </a:p>
@@ -9533,7 +9540,7 @@
             <a:fld id="{A37D6D71-8B28-4ED6-B932-04B197003D23}" type="datetimeFigureOut">
               <a:rPr lang="en-US" smtClean="0"/>
               <a:pPr algn="r"/>
-              <a:t>3/12/26</a:t>
+              <a:t>3/18/26</a:t>
             </a:fld>
             <a:endParaRPr lang="en-US" dirty="0"/>
           </a:p>
@@ -9963,7 +9970,7 @@
             <a:fld id="{A37D6D71-8B28-4ED6-B932-04B197003D23}" type="datetimeFigureOut">
               <a:rPr lang="en-US" smtClean="0"/>
               <a:pPr algn="r"/>
-              <a:t>3/12/26</a:t>
+              <a:t>3/18/26</a:t>
             </a:fld>
             <a:endParaRPr lang="en-US" spc="50" dirty="0"/>
           </a:p>
@@ -10129,7 +10136,7 @@
             <a:fld id="{A37D6D71-8B28-4ED6-B932-04B197003D23}" type="datetimeFigureOut">
               <a:rPr lang="en-US" smtClean="0"/>
               <a:pPr algn="r"/>
-              <a:t>3/12/26</a:t>
+              <a:t>3/18/26</a:t>
             </a:fld>
             <a:endParaRPr lang="en-US" dirty="0"/>
           </a:p>
@@ -10232,7 +10239,7 @@
             <a:fld id="{A37D6D71-8B28-4ED6-B932-04B197003D23}" type="datetimeFigureOut">
               <a:rPr lang="en-US" smtClean="0"/>
               <a:pPr algn="r"/>
-              <a:t>3/12/26</a:t>
+              <a:t>3/18/26</a:t>
             </a:fld>
             <a:endParaRPr lang="en-US" dirty="0"/>
           </a:p>
@@ -10618,7 +10625,7 @@
             <a:fld id="{A37D6D71-8B28-4ED6-B932-04B197003D23}" type="datetimeFigureOut">
               <a:rPr lang="en-US" smtClean="0"/>
               <a:pPr algn="r"/>
-              <a:t>3/12/26</a:t>
+              <a:t>3/18/26</a:t>
             </a:fld>
             <a:endParaRPr lang="en-US" dirty="0"/>
           </a:p>
@@ -10915,7 +10922,7 @@
             <a:fld id="{A37D6D71-8B28-4ED6-B932-04B197003D23}" type="datetimeFigureOut">
               <a:rPr lang="en-US" smtClean="0"/>
               <a:pPr algn="r"/>
-              <a:t>3/12/26</a:t>
+              <a:t>3/18/26</a:t>
             </a:fld>
             <a:endParaRPr lang="en-US" spc="50" dirty="0"/>
           </a:p>
@@ -11130,7 +11137,7 @@
             <a:fld id="{A37D6D71-8B28-4ED6-B932-04B197003D23}" type="datetimeFigureOut">
               <a:rPr lang="en-US" smtClean="0"/>
               <a:pPr algn="r"/>
-              <a:t>3/12/26</a:t>
+              <a:t>3/18/26</a:t>
             </a:fld>
             <a:endParaRPr lang="en-US" spc="50" dirty="0"/>
           </a:p>
@@ -11823,8 +11830,8 @@
         </p:nvSpPr>
         <p:spPr>
           <a:xfrm>
-            <a:off x="5051483" y="4034124"/>
-            <a:ext cx="2089033" cy="830997"/>
+            <a:off x="3321651" y="4002227"/>
+            <a:ext cx="5548698" cy="1384995"/>
           </a:xfrm>
           <a:prstGeom prst="rect">
             <a:avLst/>
@@ -11837,8 +11844,20 @@
           </a:bodyPr>
           <a:lstStyle/>
           <a:p>
-            <a:r>
-              <a:rPr lang="en-IL" sz="2400" dirty="0">
+            <a:pPr algn="ctr"/>
+            <a:r>
+              <a:rPr lang="en-IL" sz="2800" dirty="0">
+                <a:solidFill>
+                  <a:schemeClr val="bg1"/>
+                </a:solidFill>
+              </a:rPr>
+              <a:t>Cancer Bioinformatics - Final Project</a:t>
+            </a:r>
+          </a:p>
+          <a:p>
+            <a:pPr algn="ctr"/>
+            <a:r>
+              <a:rPr lang="en-IL" sz="2800" dirty="0">
                 <a:solidFill>
                   <a:schemeClr val="bg1"/>
                 </a:solidFill>
@@ -11847,8 +11866,9 @@
             </a:r>
           </a:p>
           <a:p>
-            <a:r>
-              <a:rPr lang="en-IL" sz="2400" dirty="0">
+            <a:pPr algn="ctr"/>
+            <a:r>
+              <a:rPr lang="en-IL" sz="2800" dirty="0">
                 <a:solidFill>
                   <a:schemeClr val="bg1"/>
                 </a:solidFill>
@@ -11872,7 +11892,7 @@
 </file>
 
 <file path=ppt/slides/slide10.xml><?xml version="1.0" encoding="utf-8"?>
-<p:sld xmlns:a="http://schemas.openxmlformats.org/drawingml/2006/main" xmlns:r="http://schemas.openxmlformats.org/officeDocument/2006/relationships" xmlns:p="http://schemas.openxmlformats.org/presentationml/2006/main">
+<p:sld xmlns:a="http://schemas.openxmlformats.org/drawingml/2006/main" xmlns:r="http://schemas.openxmlformats.org/officeDocument/2006/relationships" xmlns:p="http://schemas.openxmlformats.org/presentationml/2006/main" show="0">
   <p:cSld>
     <p:spTree>
       <p:nvGrpSpPr>
@@ -12624,7 +12644,7 @@
 </file>
 
 <file path=ppt/slides/slide12.xml><?xml version="1.0" encoding="utf-8"?>
-<p:sld xmlns:a="http://schemas.openxmlformats.org/drawingml/2006/main" xmlns:r="http://schemas.openxmlformats.org/officeDocument/2006/relationships" xmlns:p="http://schemas.openxmlformats.org/presentationml/2006/main" show="0">
+<p:sld xmlns:a="http://schemas.openxmlformats.org/drawingml/2006/main" xmlns:r="http://schemas.openxmlformats.org/officeDocument/2006/relationships" xmlns:p="http://schemas.openxmlformats.org/presentationml/2006/main">
   <p:cSld>
     <p:spTree>
       <p:nvGrpSpPr>
@@ -12820,7 +12840,7 @@
         </p:nvSpPr>
         <p:spPr>
           <a:xfrm>
-            <a:off x="1905183" y="6076144"/>
+            <a:off x="1896807" y="6074821"/>
             <a:ext cx="8393708" cy="369332"/>
           </a:xfrm>
           <a:prstGeom prst="rect">
@@ -13683,7 +13703,7 @@
 </file>
 
 <file path=ppt/slides/slide16.xml><?xml version="1.0" encoding="utf-8"?>
-<p:sld xmlns:a="http://schemas.openxmlformats.org/drawingml/2006/main" xmlns:r="http://schemas.openxmlformats.org/officeDocument/2006/relationships" xmlns:p="http://schemas.openxmlformats.org/presentationml/2006/main">
+<p:sld xmlns:a="http://schemas.openxmlformats.org/drawingml/2006/main" xmlns:r="http://schemas.openxmlformats.org/officeDocument/2006/relationships" xmlns:p="http://schemas.openxmlformats.org/presentationml/2006/main" show="0">
   <p:cSld>
     <p:spTree>
       <p:nvGrpSpPr>
@@ -13783,7 +13803,7 @@
         </p:spPr>
         <p:txBody>
           <a:bodyPr vert="horz" lIns="91440" tIns="45720" rIns="91440" bIns="45720" rtlCol="0" anchor="b">
-            <a:normAutofit/>
+            <a:normAutofit fontScale="77500" lnSpcReduction="20000"/>
           </a:bodyPr>
           <a:lstStyle>
             <a:lvl1pPr algn="l" defTabSz="457200" rtl="0" eaLnBrk="1" latinLnBrk="0" hangingPunct="1">
@@ -13860,15 +13880,7 @@
           <a:p>
             <a:r>
               <a:rPr lang="en-US" dirty="0"/>
-              <a:t>WHICH specific </a:t>
-            </a:r>
-            <a:r>
-              <a:rPr lang="en-US" dirty="0" err="1"/>
-              <a:t>cna</a:t>
-            </a:r>
-            <a:r>
-              <a:rPr lang="en-US" dirty="0"/>
-              <a:t> OCCUR WHEN tp53 is mutated?</a:t>
+              <a:t>which known cancer genes co-occur with TP53 loss and high FGA?</a:t>
             </a:r>
           </a:p>
         </p:txBody>
@@ -13960,7 +13972,7 @@
 </file>
 
 <file path=ppt/slides/slide17.xml><?xml version="1.0" encoding="utf-8"?>
-<p:sld xmlns:a="http://schemas.openxmlformats.org/drawingml/2006/main" xmlns:r="http://schemas.openxmlformats.org/officeDocument/2006/relationships" xmlns:p="http://schemas.openxmlformats.org/presentationml/2006/main">
+<p:sld xmlns:a="http://schemas.openxmlformats.org/drawingml/2006/main" xmlns:r="http://schemas.openxmlformats.org/officeDocument/2006/relationships" xmlns:p="http://schemas.openxmlformats.org/presentationml/2006/main" show="0">
   <p:cSld>
     <p:spTree>
       <p:nvGrpSpPr>
@@ -14407,7 +14419,7 @@
           <a:p>
             <a:r>
               <a:rPr lang="en-US" dirty="0"/>
-              <a:t>Binary effect VS. CONTINUOUS EFFECT</a:t>
+              <a:t>Conclusions</a:t>
             </a:r>
           </a:p>
         </p:txBody>
@@ -14751,7 +14763,7 @@
           <a:p>
             <a:r>
               <a:rPr lang="en-US" dirty="0"/>
-              <a:t>The hotspot paradox</a:t>
+              <a:t>Conclusions</a:t>
             </a:r>
           </a:p>
         </p:txBody>
@@ -15624,10 +15636,9 @@
           </a:lstStyle>
           <a:p>
             <a:r>
-              <a:rPr lang="en-US" dirty="0" err="1"/>
-              <a:t>lIMITATIONS</a:t>
-            </a:r>
-            <a:endParaRPr lang="en-US" dirty="0"/>
+              <a:rPr lang="en-US" dirty="0"/>
+              <a:t>Conclusions</a:t>
+            </a:r>
           </a:p>
         </p:txBody>
       </p:sp>
@@ -15927,8 +15938,8 @@
         </p:nvSpPr>
         <p:spPr>
           <a:xfrm>
-            <a:off x="1020801" y="2333767"/>
-            <a:ext cx="9931527" cy="1815882"/>
+            <a:off x="1130236" y="2929190"/>
+            <a:ext cx="9931527" cy="1384995"/>
           </a:xfrm>
           <a:prstGeom prst="rect">
             <a:avLst/>
@@ -15941,21 +15952,10 @@
           </a:bodyPr>
           <a:lstStyle/>
           <a:p>
-            <a:pPr marL="285750" indent="-285750">
-              <a:buFont typeface="Wingdings" pitchFamily="2" charset="2"/>
-              <a:buChar char="Ø"/>
-            </a:pPr>
+            <a:pPr algn="ctr"/>
             <a:r>
               <a:rPr lang="en-US" sz="2800" dirty="0"/>
-              <a:t>TP53 loss </a:t>
-            </a:r>
-            <a:r>
-              <a:rPr lang="en-US" sz="2800" dirty="0" err="1"/>
-              <a:t>drived</a:t>
-            </a:r>
-            <a:r>
-              <a:rPr lang="en-US" sz="2800" dirty="0"/>
-              <a:t> genomic instability as a class effect, which in turn selectively amplifies oncogenic growth pathways, which explains why TP53 mutation is such a universal and aggressive cancer event.</a:t>
+              <a:t>TP53 loss drives genomic instability as a class effect, which in turn selectively amplifies oncogenic growth pathways, which explains why TP53 mutation is such a universal and aggressive cancer event.</a:t>
             </a:r>
           </a:p>
         </p:txBody>
@@ -16144,7 +16144,7 @@
         </p:nvSpPr>
         <p:spPr>
           <a:xfrm>
-            <a:off x="679571" y="2232833"/>
+            <a:off x="679569" y="2054792"/>
             <a:ext cx="5706109" cy="3560733"/>
           </a:xfrm>
         </p:spPr>
@@ -16162,15 +16162,55 @@
           <a:p>
             <a:pPr lvl="1"/>
             <a:r>
+              <a:rPr lang="he-IL" sz="2000" dirty="0"/>
+              <a:t>   </a:t>
+            </a:r>
+            <a:r>
               <a:rPr lang="en-US" sz="2000" dirty="0"/>
-              <a:t>More copies → more RNA → more protein</a:t>
+              <a:t>copies → </a:t>
+            </a:r>
+            <a:r>
+              <a:rPr lang="he-IL" sz="2000" dirty="0"/>
+              <a:t>   </a:t>
+            </a:r>
+            <a:r>
+              <a:rPr lang="en-US" sz="2000" dirty="0"/>
+              <a:t>RNA → </a:t>
+            </a:r>
+            <a:r>
+              <a:rPr lang="he-IL" sz="2000" dirty="0"/>
+              <a:t>   </a:t>
+            </a:r>
+            <a:r>
+              <a:rPr lang="en-US" sz="2000" dirty="0"/>
+              <a:t>protein</a:t>
             </a:r>
           </a:p>
           <a:p>
             <a:pPr lvl="1"/>
             <a:r>
+              <a:rPr lang="he-IL" sz="2000" dirty="0"/>
+              <a:t>   </a:t>
+            </a:r>
+            <a:r>
               <a:rPr lang="en-US" sz="2000" dirty="0"/>
-              <a:t>Fewer copies → less protein</a:t>
+              <a:t>copies → </a:t>
+            </a:r>
+            <a:r>
+              <a:rPr lang="he-IL" sz="2000" dirty="0"/>
+              <a:t> </a:t>
+            </a:r>
+            <a:r>
+              <a:rPr lang="en-US" sz="2000" dirty="0"/>
+              <a:t> </a:t>
+            </a:r>
+            <a:r>
+              <a:rPr lang="he-IL" sz="2000" dirty="0"/>
+              <a:t> </a:t>
+            </a:r>
+            <a:r>
+              <a:rPr lang="en-US" sz="2000" dirty="0"/>
+              <a:t>protein</a:t>
             </a:r>
           </a:p>
           <a:p>
@@ -16281,6 +16321,434 @@
           </a:p>
         </p:txBody>
       </p:sp>
+      <p:sp>
+        <p:nvSpPr>
+          <p:cNvPr id="10" name="TextBox 9">
+            <a:extLst>
+              <a:ext uri="{FF2B5EF4-FFF2-40B4-BE49-F238E27FC236}">
+                <a16:creationId xmlns:a16="http://schemas.microsoft.com/office/drawing/2014/main" id="{3951447A-2D47-8269-33CF-EF6CBA2182A3}"/>
+              </a:ext>
+            </a:extLst>
+          </p:cNvPr>
+          <p:cNvSpPr txBox="1"/>
+          <p:nvPr/>
+        </p:nvSpPr>
+        <p:spPr>
+          <a:xfrm>
+            <a:off x="1982916" y="5446207"/>
+            <a:ext cx="4537570" cy="861774"/>
+          </a:xfrm>
+          <a:prstGeom prst="rect">
+            <a:avLst/>
+          </a:prstGeom>
+          <a:noFill/>
+        </p:spPr>
+        <p:txBody>
+          <a:bodyPr wrap="square" rtlCol="0">
+            <a:spAutoFit/>
+          </a:bodyPr>
+          <a:lstStyle/>
+          <a:p>
+            <a:pPr algn="ctr"/>
+            <a:r>
+              <a:rPr lang="en-US" b="1" dirty="0"/>
+              <a:t>(number of base pairs with</a:t>
+            </a:r>
+            <a:endParaRPr lang="he-IL" b="1" dirty="0"/>
+          </a:p>
+          <a:p>
+            <a:pPr algn="ctr"/>
+            <a:r>
+              <a:rPr lang="en-US" b="1" dirty="0"/>
+              <a:t>copy number gain or loss)</a:t>
+            </a:r>
+            <a:endParaRPr lang="en-US" dirty="0"/>
+          </a:p>
+          <a:p>
+            <a:pPr algn="ctr"/>
+            <a:r>
+              <a:rPr lang="he-IL" sz="1200" dirty="0"/>
+              <a:t>__________________________________________</a:t>
+            </a:r>
+            <a:endParaRPr lang="en-IL" sz="1200" dirty="0"/>
+          </a:p>
+        </p:txBody>
+      </p:sp>
+      <p:sp>
+        <p:nvSpPr>
+          <p:cNvPr id="15" name="TextBox 14">
+            <a:extLst>
+              <a:ext uri="{FF2B5EF4-FFF2-40B4-BE49-F238E27FC236}">
+                <a16:creationId xmlns:a16="http://schemas.microsoft.com/office/drawing/2014/main" id="{A02A50E2-0749-D037-202D-B1C97392B1B0}"/>
+              </a:ext>
+            </a:extLst>
+          </p:cNvPr>
+          <p:cNvSpPr txBox="1"/>
+          <p:nvPr/>
+        </p:nvSpPr>
+        <p:spPr>
+          <a:xfrm>
+            <a:off x="538717" y="5479150"/>
+            <a:ext cx="1280293" cy="1200329"/>
+          </a:xfrm>
+          <a:prstGeom prst="rect">
+            <a:avLst/>
+          </a:prstGeom>
+          <a:noFill/>
+        </p:spPr>
+        <p:txBody>
+          <a:bodyPr wrap="square" rtlCol="0">
+            <a:spAutoFit/>
+          </a:bodyPr>
+          <a:lstStyle/>
+          <a:p>
+            <a:pPr rtl="1"/>
+            <a:r>
+              <a:rPr lang="en-US" b="1" dirty="0">
+                <a:solidFill>
+                  <a:srgbClr val="FF0000"/>
+                </a:solidFill>
+              </a:rPr>
+              <a:t>Fraction Genome Altered (FGA)</a:t>
+            </a:r>
+            <a:endParaRPr lang="en-IL" dirty="0"/>
+          </a:p>
+        </p:txBody>
+      </p:sp>
+      <p:sp>
+        <p:nvSpPr>
+          <p:cNvPr id="16" name="TextBox 15">
+            <a:extLst>
+              <a:ext uri="{FF2B5EF4-FFF2-40B4-BE49-F238E27FC236}">
+                <a16:creationId xmlns:a16="http://schemas.microsoft.com/office/drawing/2014/main" id="{E9E03FD2-8AFA-095B-15B1-E939AF3DF244}"/>
+              </a:ext>
+            </a:extLst>
+          </p:cNvPr>
+          <p:cNvSpPr txBox="1"/>
+          <p:nvPr/>
+        </p:nvSpPr>
+        <p:spPr>
+          <a:xfrm>
+            <a:off x="1816180" y="5894648"/>
+            <a:ext cx="364202" cy="461665"/>
+          </a:xfrm>
+          <a:prstGeom prst="rect">
+            <a:avLst/>
+          </a:prstGeom>
+          <a:noFill/>
+        </p:spPr>
+        <p:txBody>
+          <a:bodyPr wrap="none" rtlCol="0">
+            <a:spAutoFit/>
+          </a:bodyPr>
+          <a:lstStyle/>
+          <a:p>
+            <a:pPr marL="0" algn="r" defTabSz="457200" rtl="1" eaLnBrk="1" latinLnBrk="0" hangingPunct="1"/>
+            <a:r>
+              <a:rPr lang="he-IL" sz="2400" dirty="0"/>
+              <a:t>=</a:t>
+            </a:r>
+            <a:endParaRPr lang="en-IL" sz="2400" dirty="0"/>
+          </a:p>
+        </p:txBody>
+      </p:sp>
+      <p:sp>
+        <p:nvSpPr>
+          <p:cNvPr id="17" name="TextBox 16">
+            <a:extLst>
+              <a:ext uri="{FF2B5EF4-FFF2-40B4-BE49-F238E27FC236}">
+                <a16:creationId xmlns:a16="http://schemas.microsoft.com/office/drawing/2014/main" id="{7664A01E-F97B-1E8C-7323-7A19C70DF8C7}"/>
+              </a:ext>
+            </a:extLst>
+          </p:cNvPr>
+          <p:cNvSpPr txBox="1"/>
+          <p:nvPr/>
+        </p:nvSpPr>
+        <p:spPr>
+          <a:xfrm>
+            <a:off x="2806914" y="6312380"/>
+            <a:ext cx="2889574" cy="369332"/>
+          </a:xfrm>
+          <a:prstGeom prst="rect">
+            <a:avLst/>
+          </a:prstGeom>
+          <a:noFill/>
+        </p:spPr>
+        <p:txBody>
+          <a:bodyPr wrap="none" rtlCol="0">
+            <a:spAutoFit/>
+          </a:bodyPr>
+          <a:lstStyle/>
+          <a:p>
+            <a:pPr algn="r" rtl="1"/>
+            <a:r>
+              <a:rPr lang="en-US" b="1" dirty="0"/>
+              <a:t>(total base pairs profiled)</a:t>
+            </a:r>
+            <a:endParaRPr lang="en-IL" dirty="0"/>
+          </a:p>
+        </p:txBody>
+      </p:sp>
+      <p:sp>
+        <p:nvSpPr>
+          <p:cNvPr id="19" name="Down Arrow 18">
+            <a:extLst>
+              <a:ext uri="{FF2B5EF4-FFF2-40B4-BE49-F238E27FC236}">
+                <a16:creationId xmlns:a16="http://schemas.microsoft.com/office/drawing/2014/main" id="{1615CDF4-29E7-1281-FF3C-8851781293A4}"/>
+              </a:ext>
+            </a:extLst>
+          </p:cNvPr>
+          <p:cNvSpPr/>
+          <p:nvPr/>
+        </p:nvSpPr>
+        <p:spPr>
+          <a:xfrm>
+            <a:off x="1346792" y="4165688"/>
+            <a:ext cx="205561" cy="320392"/>
+          </a:xfrm>
+          <a:prstGeom prst="downArrow">
+            <a:avLst/>
+          </a:prstGeom>
+          <a:solidFill>
+            <a:srgbClr val="FF0000"/>
+          </a:solidFill>
+          <a:ln>
+            <a:noFill/>
+          </a:ln>
+        </p:spPr>
+        <p:style>
+          <a:lnRef idx="2">
+            <a:schemeClr val="accent2">
+              <a:shade val="15000"/>
+            </a:schemeClr>
+          </a:lnRef>
+          <a:fillRef idx="1">
+            <a:schemeClr val="accent2"/>
+          </a:fillRef>
+          <a:effectRef idx="0">
+            <a:schemeClr val="accent2"/>
+          </a:effectRef>
+          <a:fontRef idx="minor">
+            <a:schemeClr val="lt1"/>
+          </a:fontRef>
+        </p:style>
+        <p:txBody>
+          <a:bodyPr rtlCol="0" anchor="ctr"/>
+          <a:lstStyle/>
+          <a:p>
+            <a:pPr marL="0" algn="ctr" defTabSz="457200" rtl="1" eaLnBrk="1" latinLnBrk="0" hangingPunct="1"/>
+            <a:endParaRPr lang="en-IL"/>
+          </a:p>
+        </p:txBody>
+      </p:sp>
+      <p:sp>
+        <p:nvSpPr>
+          <p:cNvPr id="20" name="Down Arrow 19">
+            <a:extLst>
+              <a:ext uri="{FF2B5EF4-FFF2-40B4-BE49-F238E27FC236}">
+                <a16:creationId xmlns:a16="http://schemas.microsoft.com/office/drawing/2014/main" id="{B652A589-60E1-219C-4767-B1457DE37F46}"/>
+              </a:ext>
+            </a:extLst>
+          </p:cNvPr>
+          <p:cNvSpPr/>
+          <p:nvPr/>
+        </p:nvSpPr>
+        <p:spPr>
+          <a:xfrm>
+            <a:off x="2601353" y="4177036"/>
+            <a:ext cx="205561" cy="320392"/>
+          </a:xfrm>
+          <a:prstGeom prst="downArrow">
+            <a:avLst/>
+          </a:prstGeom>
+          <a:solidFill>
+            <a:srgbClr val="FF0000"/>
+          </a:solidFill>
+          <a:ln>
+            <a:noFill/>
+          </a:ln>
+        </p:spPr>
+        <p:style>
+          <a:lnRef idx="2">
+            <a:schemeClr val="accent2">
+              <a:shade val="15000"/>
+            </a:schemeClr>
+          </a:lnRef>
+          <a:fillRef idx="1">
+            <a:schemeClr val="accent2"/>
+          </a:fillRef>
+          <a:effectRef idx="0">
+            <a:schemeClr val="accent2"/>
+          </a:effectRef>
+          <a:fontRef idx="minor">
+            <a:schemeClr val="lt1"/>
+          </a:fontRef>
+        </p:style>
+        <p:txBody>
+          <a:bodyPr rtlCol="0" anchor="ctr"/>
+          <a:lstStyle/>
+          <a:p>
+            <a:pPr marL="0" algn="ctr" defTabSz="457200" rtl="1" eaLnBrk="1" latinLnBrk="0" hangingPunct="1"/>
+            <a:endParaRPr lang="en-IL"/>
+          </a:p>
+        </p:txBody>
+      </p:sp>
+      <p:sp>
+        <p:nvSpPr>
+          <p:cNvPr id="21" name="Down Arrow 20">
+            <a:extLst>
+              <a:ext uri="{FF2B5EF4-FFF2-40B4-BE49-F238E27FC236}">
+                <a16:creationId xmlns:a16="http://schemas.microsoft.com/office/drawing/2014/main" id="{B837372D-F0E1-DD72-35FE-69007F005E83}"/>
+              </a:ext>
+            </a:extLst>
+          </p:cNvPr>
+          <p:cNvSpPr/>
+          <p:nvPr/>
+        </p:nvSpPr>
+        <p:spPr>
+          <a:xfrm rot="10800000">
+            <a:off x="1346791" y="3716619"/>
+            <a:ext cx="205561" cy="320392"/>
+          </a:xfrm>
+          <a:prstGeom prst="downArrow">
+            <a:avLst/>
+          </a:prstGeom>
+          <a:solidFill>
+            <a:srgbClr val="00B050"/>
+          </a:solidFill>
+          <a:ln>
+            <a:noFill/>
+          </a:ln>
+        </p:spPr>
+        <p:style>
+          <a:lnRef idx="2">
+            <a:schemeClr val="accent2">
+              <a:shade val="15000"/>
+            </a:schemeClr>
+          </a:lnRef>
+          <a:fillRef idx="1">
+            <a:schemeClr val="accent2"/>
+          </a:fillRef>
+          <a:effectRef idx="0">
+            <a:schemeClr val="accent2"/>
+          </a:effectRef>
+          <a:fontRef idx="minor">
+            <a:schemeClr val="lt1"/>
+          </a:fontRef>
+        </p:style>
+        <p:txBody>
+          <a:bodyPr rtlCol="0" anchor="ctr"/>
+          <a:lstStyle/>
+          <a:p>
+            <a:pPr marL="0" algn="ctr" defTabSz="457200" rtl="1" eaLnBrk="1" latinLnBrk="0" hangingPunct="1"/>
+            <a:endParaRPr lang="en-IL"/>
+          </a:p>
+        </p:txBody>
+      </p:sp>
+      <p:sp>
+        <p:nvSpPr>
+          <p:cNvPr id="22" name="Down Arrow 21">
+            <a:extLst>
+              <a:ext uri="{FF2B5EF4-FFF2-40B4-BE49-F238E27FC236}">
+                <a16:creationId xmlns:a16="http://schemas.microsoft.com/office/drawing/2014/main" id="{EBBC11A4-FD48-A96F-CA7C-93D4B47CF5A8}"/>
+              </a:ext>
+            </a:extLst>
+          </p:cNvPr>
+          <p:cNvSpPr/>
+          <p:nvPr/>
+        </p:nvSpPr>
+        <p:spPr>
+          <a:xfrm rot="10800000">
+            <a:off x="2601353" y="3694249"/>
+            <a:ext cx="205561" cy="320392"/>
+          </a:xfrm>
+          <a:prstGeom prst="downArrow">
+            <a:avLst/>
+          </a:prstGeom>
+          <a:solidFill>
+            <a:srgbClr val="00B050"/>
+          </a:solidFill>
+          <a:ln>
+            <a:noFill/>
+          </a:ln>
+        </p:spPr>
+        <p:style>
+          <a:lnRef idx="2">
+            <a:schemeClr val="accent2">
+              <a:shade val="15000"/>
+            </a:schemeClr>
+          </a:lnRef>
+          <a:fillRef idx="1">
+            <a:schemeClr val="accent2"/>
+          </a:fillRef>
+          <a:effectRef idx="0">
+            <a:schemeClr val="accent2"/>
+          </a:effectRef>
+          <a:fontRef idx="minor">
+            <a:schemeClr val="lt1"/>
+          </a:fontRef>
+        </p:style>
+        <p:txBody>
+          <a:bodyPr rtlCol="0" anchor="ctr"/>
+          <a:lstStyle/>
+          <a:p>
+            <a:pPr marL="0" algn="ctr" defTabSz="457200" rtl="1" eaLnBrk="1" latinLnBrk="0" hangingPunct="1"/>
+            <a:endParaRPr lang="en-IL"/>
+          </a:p>
+        </p:txBody>
+      </p:sp>
+      <p:sp>
+        <p:nvSpPr>
+          <p:cNvPr id="23" name="Down Arrow 22">
+            <a:extLst>
+              <a:ext uri="{FF2B5EF4-FFF2-40B4-BE49-F238E27FC236}">
+                <a16:creationId xmlns:a16="http://schemas.microsoft.com/office/drawing/2014/main" id="{0A19F019-0476-9785-84CC-F0FF1420E352}"/>
+              </a:ext>
+            </a:extLst>
+          </p:cNvPr>
+          <p:cNvSpPr/>
+          <p:nvPr/>
+        </p:nvSpPr>
+        <p:spPr>
+          <a:xfrm rot="10800000">
+            <a:off x="3753133" y="3716619"/>
+            <a:ext cx="205561" cy="320392"/>
+          </a:xfrm>
+          <a:prstGeom prst="downArrow">
+            <a:avLst/>
+          </a:prstGeom>
+          <a:solidFill>
+            <a:srgbClr val="00B050"/>
+          </a:solidFill>
+          <a:ln>
+            <a:noFill/>
+          </a:ln>
+        </p:spPr>
+        <p:style>
+          <a:lnRef idx="2">
+            <a:schemeClr val="accent2">
+              <a:shade val="15000"/>
+            </a:schemeClr>
+          </a:lnRef>
+          <a:fillRef idx="1">
+            <a:schemeClr val="accent2"/>
+          </a:fillRef>
+          <a:effectRef idx="0">
+            <a:schemeClr val="accent2"/>
+          </a:effectRef>
+          <a:fontRef idx="minor">
+            <a:schemeClr val="lt1"/>
+          </a:fontRef>
+        </p:style>
+        <p:txBody>
+          <a:bodyPr rtlCol="0" anchor="ctr"/>
+          <a:lstStyle/>
+          <a:p>
+            <a:pPr marL="0" algn="ctr" defTabSz="457200" rtl="1" eaLnBrk="1" latinLnBrk="0" hangingPunct="1"/>
+            <a:endParaRPr lang="en-IL"/>
+          </a:p>
+        </p:txBody>
+      </p:sp>
     </p:spTree>
     <p:extLst>
       <p:ext uri="{BB962C8B-B14F-4D97-AF65-F5344CB8AC3E}">
@@ -16291,232 +16759,6 @@
   <p:clrMapOvr>
     <a:masterClrMapping/>
   </p:clrMapOvr>
-  <p:timing>
-    <p:tnLst>
-      <p:par>
-        <p:cTn id="1" dur="indefinite" restart="never" nodeType="tmRoot">
-          <p:childTnLst>
-            <p:seq concurrent="1" nextAc="seek">
-              <p:cTn id="2" dur="indefinite" nodeType="mainSeq">
-                <p:childTnLst>
-                  <p:par>
-                    <p:cTn id="3" fill="hold">
-                      <p:stCondLst>
-                        <p:cond delay="indefinite"/>
-                      </p:stCondLst>
-                      <p:childTnLst>
-                        <p:par>
-                          <p:cTn id="4" fill="hold">
-                            <p:stCondLst>
-                              <p:cond delay="0"/>
-                            </p:stCondLst>
-                            <p:childTnLst>
-                              <p:par>
-                                <p:cTn id="5" presetID="1" presetClass="entr" presetSubtype="0" fill="hold" nodeType="clickEffect">
-                                  <p:stCondLst>
-                                    <p:cond delay="0"/>
-                                  </p:stCondLst>
-                                  <p:childTnLst>
-                                    <p:set>
-                                      <p:cBhvr>
-                                        <p:cTn id="6" dur="1" fill="hold">
-                                          <p:stCondLst>
-                                            <p:cond delay="0"/>
-                                          </p:stCondLst>
-                                        </p:cTn>
-                                        <p:tgtEl>
-                                          <p:spTgt spid="5">
-                                            <p:txEl>
-                                              <p:pRg st="0" end="0"/>
-                                            </p:txEl>
-                                          </p:spTgt>
-                                        </p:tgtEl>
-                                        <p:attrNameLst>
-                                          <p:attrName>style.visibility</p:attrName>
-                                        </p:attrNameLst>
-                                      </p:cBhvr>
-                                      <p:to>
-                                        <p:strVal val="visible"/>
-                                      </p:to>
-                                    </p:set>
-                                  </p:childTnLst>
-                                </p:cTn>
-                              </p:par>
-                            </p:childTnLst>
-                          </p:cTn>
-                        </p:par>
-                      </p:childTnLst>
-                    </p:cTn>
-                  </p:par>
-                  <p:par>
-                    <p:cTn id="7" fill="hold">
-                      <p:stCondLst>
-                        <p:cond delay="indefinite"/>
-                      </p:stCondLst>
-                      <p:childTnLst>
-                        <p:par>
-                          <p:cTn id="8" fill="hold">
-                            <p:stCondLst>
-                              <p:cond delay="0"/>
-                            </p:stCondLst>
-                            <p:childTnLst>
-                              <p:par>
-                                <p:cTn id="9" presetID="1" presetClass="entr" presetSubtype="0" fill="hold" nodeType="clickEffect">
-                                  <p:stCondLst>
-                                    <p:cond delay="0"/>
-                                  </p:stCondLst>
-                                  <p:childTnLst>
-                                    <p:set>
-                                      <p:cBhvr>
-                                        <p:cTn id="10" dur="1" fill="hold">
-                                          <p:stCondLst>
-                                            <p:cond delay="0"/>
-                                          </p:stCondLst>
-                                        </p:cTn>
-                                        <p:tgtEl>
-                                          <p:spTgt spid="5">
-                                            <p:txEl>
-                                              <p:pRg st="1" end="1"/>
-                                            </p:txEl>
-                                          </p:spTgt>
-                                        </p:tgtEl>
-                                        <p:attrNameLst>
-                                          <p:attrName>style.visibility</p:attrName>
-                                        </p:attrNameLst>
-                                      </p:cBhvr>
-                                      <p:to>
-                                        <p:strVal val="visible"/>
-                                      </p:to>
-                                    </p:set>
-                                  </p:childTnLst>
-                                </p:cTn>
-                              </p:par>
-                            </p:childTnLst>
-                          </p:cTn>
-                        </p:par>
-                      </p:childTnLst>
-                    </p:cTn>
-                  </p:par>
-                  <p:par>
-                    <p:cTn id="11" fill="hold">
-                      <p:stCondLst>
-                        <p:cond delay="indefinite"/>
-                      </p:stCondLst>
-                      <p:childTnLst>
-                        <p:par>
-                          <p:cTn id="12" fill="hold">
-                            <p:stCondLst>
-                              <p:cond delay="0"/>
-                            </p:stCondLst>
-                            <p:childTnLst>
-                              <p:par>
-                                <p:cTn id="13" presetID="1" presetClass="entr" presetSubtype="0" fill="hold" nodeType="clickEffect">
-                                  <p:stCondLst>
-                                    <p:cond delay="0"/>
-                                  </p:stCondLst>
-                                  <p:childTnLst>
-                                    <p:set>
-                                      <p:cBhvr>
-                                        <p:cTn id="14" dur="1" fill="hold">
-                                          <p:stCondLst>
-                                            <p:cond delay="0"/>
-                                          </p:stCondLst>
-                                        </p:cTn>
-                                        <p:tgtEl>
-                                          <p:spTgt spid="5">
-                                            <p:txEl>
-                                              <p:pRg st="2" end="2"/>
-                                            </p:txEl>
-                                          </p:spTgt>
-                                        </p:tgtEl>
-                                        <p:attrNameLst>
-                                          <p:attrName>style.visibility</p:attrName>
-                                        </p:attrNameLst>
-                                      </p:cBhvr>
-                                      <p:to>
-                                        <p:strVal val="visible"/>
-                                      </p:to>
-                                    </p:set>
-                                  </p:childTnLst>
-                                </p:cTn>
-                              </p:par>
-                            </p:childTnLst>
-                          </p:cTn>
-                        </p:par>
-                      </p:childTnLst>
-                    </p:cTn>
-                  </p:par>
-                  <p:par>
-                    <p:cTn id="15" fill="hold">
-                      <p:stCondLst>
-                        <p:cond delay="indefinite"/>
-                      </p:stCondLst>
-                      <p:childTnLst>
-                        <p:par>
-                          <p:cTn id="16" fill="hold">
-                            <p:stCondLst>
-                              <p:cond delay="0"/>
-                            </p:stCondLst>
-                            <p:childTnLst>
-                              <p:par>
-                                <p:cTn id="17" presetID="1" presetClass="entr" presetSubtype="0" fill="hold" nodeType="clickEffect">
-                                  <p:stCondLst>
-                                    <p:cond delay="0"/>
-                                  </p:stCondLst>
-                                  <p:childTnLst>
-                                    <p:set>
-                                      <p:cBhvr>
-                                        <p:cTn id="18" dur="1" fill="hold">
-                                          <p:stCondLst>
-                                            <p:cond delay="0"/>
-                                          </p:stCondLst>
-                                        </p:cTn>
-                                        <p:tgtEl>
-                                          <p:spTgt spid="5">
-                                            <p:txEl>
-                                              <p:pRg st="3" end="3"/>
-                                            </p:txEl>
-                                          </p:spTgt>
-                                        </p:tgtEl>
-                                        <p:attrNameLst>
-                                          <p:attrName>style.visibility</p:attrName>
-                                        </p:attrNameLst>
-                                      </p:cBhvr>
-                                      <p:to>
-                                        <p:strVal val="visible"/>
-                                      </p:to>
-                                    </p:set>
-                                  </p:childTnLst>
-                                </p:cTn>
-                              </p:par>
-                            </p:childTnLst>
-                          </p:cTn>
-                        </p:par>
-                      </p:childTnLst>
-                    </p:cTn>
-                  </p:par>
-                </p:childTnLst>
-              </p:cTn>
-              <p:prevCondLst>
-                <p:cond evt="onPrev" delay="0">
-                  <p:tgtEl>
-                    <p:sldTgt/>
-                  </p:tgtEl>
-                </p:cond>
-              </p:prevCondLst>
-              <p:nextCondLst>
-                <p:cond evt="onNext" delay="0">
-                  <p:tgtEl>
-                    <p:sldTgt/>
-                  </p:tgtEl>
-                </p:cond>
-              </p:nextCondLst>
-            </p:seq>
-          </p:childTnLst>
-        </p:cTn>
-      </p:par>
-    </p:tnLst>
-  </p:timing>
 </p:sld>
 </file>
 
@@ -17935,309 +18177,119 @@
           </a:p>
         </p:txBody>
       </p:sp>
-      <p:grpSp>
-        <p:nvGrpSpPr>
-          <p:cNvPr id="24" name="Group 23">
+      <p:sp>
+        <p:nvSpPr>
+          <p:cNvPr id="25" name="TextBox 24">
             <a:extLst>
               <a:ext uri="{FF2B5EF4-FFF2-40B4-BE49-F238E27FC236}">
-                <a16:creationId xmlns:a16="http://schemas.microsoft.com/office/drawing/2014/main" id="{B29E89F7-7DB0-B237-9C99-9CC61285E8E9}"/>
+                <a16:creationId xmlns:a16="http://schemas.microsoft.com/office/drawing/2014/main" id="{DCC035F0-2526-D268-0E3B-75AB79A12D8E}"/>
               </a:ext>
             </a:extLst>
           </p:cNvPr>
-          <p:cNvGrpSpPr/>
+          <p:cNvSpPr txBox="1"/>
           <p:nvPr/>
-        </p:nvGrpSpPr>
-        <p:grpSpPr>
+        </p:nvSpPr>
+        <p:spPr>
           <a:xfrm>
-            <a:off x="8712017" y="4732140"/>
-            <a:ext cx="3276783" cy="1106115"/>
-            <a:chOff x="8921977" y="4001571"/>
-            <a:chExt cx="2926080" cy="1474819"/>
+            <a:off x="8712017" y="5472237"/>
+            <a:ext cx="3276783" cy="400110"/>
           </a:xfrm>
-        </p:grpSpPr>
-        <p:sp>
-          <p:nvSpPr>
-            <p:cNvPr id="25" name="TextBox 24">
-              <a:extLst>
-                <a:ext uri="{FF2B5EF4-FFF2-40B4-BE49-F238E27FC236}">
-                  <a16:creationId xmlns:a16="http://schemas.microsoft.com/office/drawing/2014/main" id="{DCC035F0-2526-D268-0E3B-75AB79A12D8E}"/>
-                </a:ext>
-              </a:extLst>
-            </p:cNvPr>
-            <p:cNvSpPr txBox="1"/>
-            <p:nvPr/>
-          </p:nvSpPr>
-          <p:spPr>
-            <a:xfrm>
-              <a:off x="8921977" y="4001571"/>
-              <a:ext cx="2926080" cy="533480"/>
-            </a:xfrm>
-            <a:prstGeom prst="rect">
-              <a:avLst/>
-            </a:prstGeom>
-            <a:noFill/>
-          </p:spPr>
-          <p:txBody>
-            <a:bodyPr wrap="square" lIns="0" rIns="0" rtlCol="0" anchor="b">
-              <a:spAutoFit/>
-            </a:bodyPr>
-            <a:lstStyle/>
-            <a:p>
-              <a:r>
-                <a:rPr lang="en-US" sz="2000" b="1" noProof="1"/>
-                <a:t>Calculate Functional Score</a:t>
-              </a:r>
-            </a:p>
-          </p:txBody>
-        </p:sp>
-        <p:sp>
-          <p:nvSpPr>
-            <p:cNvPr id="26" name="TextBox 25">
-              <a:extLst>
-                <a:ext uri="{FF2B5EF4-FFF2-40B4-BE49-F238E27FC236}">
-                  <a16:creationId xmlns:a16="http://schemas.microsoft.com/office/drawing/2014/main" id="{668FC290-2159-6BA0-2442-116AB524B9D3}"/>
-                </a:ext>
-              </a:extLst>
-            </p:cNvPr>
-            <p:cNvSpPr txBox="1"/>
-            <p:nvPr/>
-          </p:nvSpPr>
-          <p:spPr>
-            <a:xfrm>
-              <a:off x="8921977" y="4532543"/>
-              <a:ext cx="2926080" cy="943847"/>
-            </a:xfrm>
-            <a:prstGeom prst="rect">
-              <a:avLst/>
-            </a:prstGeom>
-            <a:noFill/>
-          </p:spPr>
-          <p:txBody>
-            <a:bodyPr wrap="square" lIns="0" rIns="0" rtlCol="0" anchor="t">
-              <a:spAutoFit/>
-            </a:bodyPr>
-            <a:lstStyle/>
-            <a:p>
-              <a:r>
-                <a:rPr lang="en-US" sz="1000" noProof="1">
-                  <a:solidFill>
-                    <a:schemeClr val="tx1">
-                      <a:lumMod val="65000"/>
-                      <a:lumOff val="35000"/>
-                    </a:schemeClr>
-                  </a:solidFill>
-                </a:rPr>
-                <a:t>Integrate the three Z-scores using the Combined Phenotype Score formula. This single value per allele - the EFS - reflects the degree to which each TP53 variant retains or loses normal p53 function.</a:t>
-              </a:r>
-            </a:p>
-          </p:txBody>
-        </p:sp>
-      </p:grpSp>
-      <p:grpSp>
-        <p:nvGrpSpPr>
-          <p:cNvPr id="27" name="Group 26">
+          <a:prstGeom prst="rect">
+            <a:avLst/>
+          </a:prstGeom>
+          <a:noFill/>
+        </p:spPr>
+        <p:txBody>
+          <a:bodyPr wrap="square" lIns="0" rIns="0" rtlCol="0" anchor="b">
+            <a:spAutoFit/>
+          </a:bodyPr>
+          <a:lstStyle/>
+          <a:p>
+            <a:r>
+              <a:rPr lang="en-US" sz="2000" b="1" noProof="1"/>
+              <a:t>Calculate Functional Score</a:t>
+            </a:r>
+          </a:p>
+        </p:txBody>
+      </p:sp>
+      <p:sp>
+        <p:nvSpPr>
+          <p:cNvPr id="28" name="TextBox 27">
             <a:extLst>
               <a:ext uri="{FF2B5EF4-FFF2-40B4-BE49-F238E27FC236}">
-                <a16:creationId xmlns:a16="http://schemas.microsoft.com/office/drawing/2014/main" id="{DB6880FB-82C4-842A-3DAF-F2B7882B9BFA}"/>
+                <a16:creationId xmlns:a16="http://schemas.microsoft.com/office/drawing/2014/main" id="{71428924-C3F8-AD23-A029-7B41748237E3}"/>
               </a:ext>
             </a:extLst>
           </p:cNvPr>
-          <p:cNvGrpSpPr/>
+          <p:cNvSpPr txBox="1"/>
           <p:nvPr/>
-        </p:nvGrpSpPr>
-        <p:grpSpPr>
+        </p:nvSpPr>
+        <p:spPr>
           <a:xfrm>
             <a:off x="267478" y="4631438"/>
-            <a:ext cx="3331985" cy="921449"/>
-            <a:chOff x="332936" y="4621561"/>
-            <a:chExt cx="2926080" cy="1228599"/>
+            <a:ext cx="3331985" cy="369331"/>
           </a:xfrm>
-        </p:grpSpPr>
-        <p:sp>
-          <p:nvSpPr>
-            <p:cNvPr id="28" name="TextBox 27">
-              <a:extLst>
-                <a:ext uri="{FF2B5EF4-FFF2-40B4-BE49-F238E27FC236}">
-                  <a16:creationId xmlns:a16="http://schemas.microsoft.com/office/drawing/2014/main" id="{71428924-C3F8-AD23-A029-7B41748237E3}"/>
-                </a:ext>
-              </a:extLst>
-            </p:cNvPr>
-            <p:cNvSpPr txBox="1"/>
-            <p:nvPr/>
-          </p:nvSpPr>
-          <p:spPr>
-            <a:xfrm>
-              <a:off x="332936" y="4621561"/>
-              <a:ext cx="2926080" cy="492442"/>
-            </a:xfrm>
-            <a:prstGeom prst="rect">
-              <a:avLst/>
-            </a:prstGeom>
-            <a:noFill/>
-          </p:spPr>
-          <p:txBody>
-            <a:bodyPr wrap="square" lIns="0" rIns="0" rtlCol="0" anchor="b">
-              <a:spAutoFit/>
-            </a:bodyPr>
-            <a:lstStyle/>
-            <a:p>
-              <a:pPr algn="r"/>
-              <a:r>
-                <a:rPr lang="en-US" b="1" dirty="0"/>
-                <a:t>Quantify Allele Enrichment</a:t>
-              </a:r>
-              <a:endParaRPr lang="en-US" sz="2000" b="1" noProof="1"/>
-            </a:p>
-          </p:txBody>
-        </p:sp>
-        <p:sp>
-          <p:nvSpPr>
-            <p:cNvPr id="29" name="TextBox 28">
-              <a:extLst>
-                <a:ext uri="{FF2B5EF4-FFF2-40B4-BE49-F238E27FC236}">
-                  <a16:creationId xmlns:a16="http://schemas.microsoft.com/office/drawing/2014/main" id="{3A0310DC-5DC9-5D1F-1D32-AD439F276849}"/>
-                </a:ext>
-              </a:extLst>
-            </p:cNvPr>
-            <p:cNvSpPr txBox="1"/>
-            <p:nvPr/>
-          </p:nvSpPr>
-          <p:spPr>
-            <a:xfrm>
-              <a:off x="332936" y="5111496"/>
-              <a:ext cx="2926080" cy="738664"/>
-            </a:xfrm>
-            <a:prstGeom prst="rect">
-              <a:avLst/>
-            </a:prstGeom>
-            <a:noFill/>
-          </p:spPr>
-          <p:txBody>
-            <a:bodyPr wrap="square" lIns="0" rIns="0" rtlCol="0" anchor="t">
-              <a:spAutoFit/>
-            </a:bodyPr>
-            <a:lstStyle/>
-            <a:p>
-              <a:pPr algn="r"/>
-              <a:r>
-                <a:rPr lang="en-US" sz="1000" noProof="1">
-                  <a:solidFill>
-                    <a:schemeClr val="tx1">
-                      <a:lumMod val="65000"/>
-                      <a:lumOff val="35000"/>
-                    </a:schemeClr>
-                  </a:solidFill>
-                </a:rPr>
-                <a:t>Compute log₂ fold-change for each allele relative to the early timepoint. Standardize across alleles to produce a Z-score for each of the three conditions.</a:t>
-              </a:r>
-            </a:p>
-          </p:txBody>
-        </p:sp>
-      </p:grpSp>
-      <p:grpSp>
-        <p:nvGrpSpPr>
-          <p:cNvPr id="30" name="Group 29">
+          <a:prstGeom prst="rect">
+            <a:avLst/>
+          </a:prstGeom>
+          <a:noFill/>
+        </p:spPr>
+        <p:txBody>
+          <a:bodyPr wrap="square" lIns="0" rIns="0" rtlCol="0" anchor="b">
+            <a:spAutoFit/>
+          </a:bodyPr>
+          <a:lstStyle/>
+          <a:p>
+            <a:pPr algn="r"/>
+            <a:r>
+              <a:rPr lang="en-US" b="1" dirty="0"/>
+              <a:t>Quantify Allele Enrichment</a:t>
+            </a:r>
+            <a:endParaRPr lang="en-US" sz="2000" b="1" noProof="1"/>
+          </a:p>
+        </p:txBody>
+      </p:sp>
+      <p:sp>
+        <p:nvSpPr>
+          <p:cNvPr id="31" name="TextBox 30">
             <a:extLst>
               <a:ext uri="{FF2B5EF4-FFF2-40B4-BE49-F238E27FC236}">
-                <a16:creationId xmlns:a16="http://schemas.microsoft.com/office/drawing/2014/main" id="{1202CC10-FB01-DB77-E5DD-9C862A01D79D}"/>
+                <a16:creationId xmlns:a16="http://schemas.microsoft.com/office/drawing/2014/main" id="{7FB8F06D-FC26-5F60-BF33-6284F4203DE4}"/>
               </a:ext>
             </a:extLst>
           </p:cNvPr>
-          <p:cNvGrpSpPr/>
+          <p:cNvSpPr txBox="1"/>
           <p:nvPr/>
-        </p:nvGrpSpPr>
-        <p:grpSpPr>
+        </p:nvSpPr>
+        <p:spPr>
           <a:xfrm>
             <a:off x="1286933" y="2249613"/>
-            <a:ext cx="3854634" cy="967371"/>
-            <a:chOff x="8921977" y="984542"/>
-            <a:chExt cx="2926080" cy="2202911"/>
+            <a:ext cx="3614699" cy="414475"/>
           </a:xfrm>
-        </p:grpSpPr>
-        <p:sp>
-          <p:nvSpPr>
-            <p:cNvPr id="31" name="TextBox 30">
-              <a:extLst>
-                <a:ext uri="{FF2B5EF4-FFF2-40B4-BE49-F238E27FC236}">
-                  <a16:creationId xmlns:a16="http://schemas.microsoft.com/office/drawing/2014/main" id="{7FB8F06D-FC26-5F60-BF33-6284F4203DE4}"/>
-                </a:ext>
-              </a:extLst>
-            </p:cNvPr>
-            <p:cNvSpPr txBox="1"/>
-            <p:nvPr/>
-          </p:nvSpPr>
-          <p:spPr>
-            <a:xfrm>
-              <a:off x="8921977" y="984542"/>
-              <a:ext cx="2743944" cy="943848"/>
-            </a:xfrm>
-            <a:prstGeom prst="rect">
-              <a:avLst/>
-            </a:prstGeom>
-            <a:noFill/>
-          </p:spPr>
-          <p:txBody>
-            <a:bodyPr wrap="square" lIns="0" rIns="0" rtlCol="0" anchor="b">
-              <a:spAutoFit/>
-            </a:bodyPr>
-            <a:lstStyle/>
-            <a:p>
-              <a:r>
-                <a:rPr lang="en-US" sz="2000" b="1" noProof="1">
-                  <a:solidFill>
-                    <a:schemeClr val="accent3">
-                      <a:lumMod val="75000"/>
-                    </a:schemeClr>
-                  </a:solidFill>
-                </a:rPr>
-                <a:t>Screen 8,258 TP53 Variants</a:t>
-              </a:r>
-            </a:p>
-          </p:txBody>
-        </p:sp>
-        <p:sp>
-          <p:nvSpPr>
-            <p:cNvPr id="32" name="TextBox 31">
-              <a:extLst>
-                <a:ext uri="{FF2B5EF4-FFF2-40B4-BE49-F238E27FC236}">
-                  <a16:creationId xmlns:a16="http://schemas.microsoft.com/office/drawing/2014/main" id="{D76451E6-7528-1075-F5FA-4FF144465383}"/>
-                </a:ext>
-              </a:extLst>
-            </p:cNvPr>
-            <p:cNvSpPr txBox="1"/>
-            <p:nvPr/>
-          </p:nvSpPr>
-          <p:spPr>
-            <a:xfrm>
-              <a:off x="8921977" y="1925881"/>
-              <a:ext cx="2926080" cy="1261572"/>
-            </a:xfrm>
-            <a:prstGeom prst="rect">
-              <a:avLst/>
-            </a:prstGeom>
-            <a:noFill/>
-          </p:spPr>
-          <p:txBody>
-            <a:bodyPr wrap="square" lIns="0" rIns="0" rtlCol="0" anchor="t">
-              <a:spAutoFit/>
-            </a:bodyPr>
-            <a:lstStyle/>
-            <a:p>
-              <a:r>
-                <a:rPr lang="en-US" sz="1000" noProof="1">
-                  <a:solidFill>
-                    <a:schemeClr val="tx1">
-                      <a:lumMod val="65000"/>
-                      <a:lumOff val="35000"/>
-                    </a:schemeClr>
-                  </a:solidFill>
-                </a:rPr>
-                <a:t>Run 3 competitive growth screens in isogenic p53WT and p53NULL cells treated with nutlin-3 or etoposide. Collect read counts to quantify allele representation.</a:t>
-              </a:r>
-            </a:p>
-          </p:txBody>
-        </p:sp>
-      </p:grpSp>
+          <a:prstGeom prst="rect">
+            <a:avLst/>
+          </a:prstGeom>
+          <a:noFill/>
+        </p:spPr>
+        <p:txBody>
+          <a:bodyPr wrap="square" lIns="0" rIns="0" rtlCol="0" anchor="b">
+            <a:spAutoFit/>
+          </a:bodyPr>
+          <a:lstStyle/>
+          <a:p>
+            <a:r>
+              <a:rPr lang="en-US" sz="2000" b="1" noProof="1">
+                <a:solidFill>
+                  <a:schemeClr val="accent3">
+                    <a:lumMod val="75000"/>
+                  </a:schemeClr>
+                </a:solidFill>
+              </a:rPr>
+              <a:t>Screen 8,258 TP53 Variants</a:t>
+            </a:r>
+          </a:p>
+        </p:txBody>
+      </p:sp>
       <p:sp>
         <p:nvSpPr>
           <p:cNvPr id="36" name="TextBox 35">
@@ -18316,8 +18368,8 @@
         </p:nvSpPr>
         <p:spPr>
           <a:xfrm>
-            <a:off x="8712017" y="4224828"/>
-            <a:ext cx="3092506" cy="523220"/>
+            <a:off x="9121803" y="4301847"/>
+            <a:ext cx="3092506" cy="1123384"/>
           </a:xfrm>
           <a:prstGeom prst="rect">
             <a:avLst/>
@@ -18333,7 +18385,7 @@
             <a:pPr algn="ctr"/>
             <a:r>
               <a:rPr lang="en-US" sz="1400" dirty="0"/>
-              <a:t>EFS = [Z(</a:t>
+              <a:t>[Z(</a:t>
             </a:r>
             <a:r>
               <a:rPr lang="en-US" sz="1400" dirty="0" err="1"/>
@@ -18349,7 +18401,7 @@
             </a:r>
             <a:r>
               <a:rPr lang="en-US" sz="1400" dirty="0"/>
-              <a:t>) − Z(</a:t>
+              <a:t>) - Z(</a:t>
             </a:r>
             <a:r>
               <a:rPr lang="en-US" sz="1400" dirty="0" err="1"/>
@@ -18357,7 +18409,25 @@
             </a:r>
             <a:r>
               <a:rPr lang="en-US" sz="1400" dirty="0"/>
-              <a:t>)] / 3</a:t>
+              <a:t>)]</a:t>
+            </a:r>
+          </a:p>
+          <a:p>
+            <a:pPr algn="ctr"/>
+            <a:r>
+              <a:rPr lang="en-US" sz="1400" dirty="0"/>
+              <a:t>____________________________</a:t>
+            </a:r>
+          </a:p>
+          <a:p>
+            <a:pPr algn="ctr"/>
+            <a:endParaRPr lang="en-US" sz="1100" dirty="0"/>
+          </a:p>
+          <a:p>
+            <a:pPr algn="ctr"/>
+            <a:r>
+              <a:rPr lang="en-US" sz="1400" dirty="0"/>
+              <a:t>3</a:t>
             </a:r>
           </a:p>
         </p:txBody>
@@ -18411,6 +18481,128 @@
                 <a:cs typeface="Corsiva Hebrew" pitchFamily="2" charset="-79"/>
               </a:rPr>
               <a:t>Background</a:t>
+            </a:r>
+          </a:p>
+        </p:txBody>
+      </p:sp>
+      <p:pic>
+        <p:nvPicPr>
+          <p:cNvPr id="1028" name="Picture 4" descr="Fig. 2: Comprehensive mutational scanning of TP53.">
+            <a:extLst>
+              <a:ext uri="{FF2B5EF4-FFF2-40B4-BE49-F238E27FC236}">
+                <a16:creationId xmlns:a16="http://schemas.microsoft.com/office/drawing/2014/main" id="{B34741D3-1514-3CD8-E18E-B25A3C46E466}"/>
+              </a:ext>
+            </a:extLst>
+          </p:cNvPr>
+          <p:cNvPicPr>
+            <a:picLocks noChangeAspect="1" noChangeArrowheads="1"/>
+          </p:cNvPicPr>
+          <p:nvPr/>
+        </p:nvPicPr>
+        <p:blipFill rotWithShape="1">
+          <a:blip r:embed="rId4">
+            <a:extLst>
+              <a:ext uri="{28A0092B-C50C-407E-A947-70E740481C1C}">
+                <a14:useLocalDpi xmlns:a14="http://schemas.microsoft.com/office/drawing/2010/main" val="0"/>
+              </a:ext>
+            </a:extLst>
+          </a:blip>
+          <a:srcRect l="2784" t="3317" r="71211" b="77069"/>
+          <a:stretch>
+            <a:fillRect/>
+          </a:stretch>
+        </p:blipFill>
+        <p:spPr bwMode="auto">
+          <a:xfrm>
+            <a:off x="8619550" y="2030181"/>
+            <a:ext cx="3112039" cy="1814294"/>
+          </a:xfrm>
+          <a:prstGeom prst="rect">
+            <a:avLst/>
+          </a:prstGeom>
+          <a:noFill/>
+          <a:ln w="12700">
+            <a:solidFill>
+              <a:schemeClr val="accent1"/>
+            </a:solidFill>
+          </a:ln>
+          <a:extLst>
+            <a:ext uri="{909E8E84-426E-40DD-AFC4-6F175D3DCCD1}">
+              <a14:hiddenFill xmlns:a14="http://schemas.microsoft.com/office/drawing/2010/main">
+                <a:solidFill>
+                  <a:srgbClr val="FFFFFF"/>
+                </a:solidFill>
+              </a14:hiddenFill>
+            </a:ext>
+          </a:extLst>
+        </p:spPr>
+      </p:pic>
+      <p:sp>
+        <p:nvSpPr>
+          <p:cNvPr id="3" name="TextBox 2">
+            <a:extLst>
+              <a:ext uri="{FF2B5EF4-FFF2-40B4-BE49-F238E27FC236}">
+                <a16:creationId xmlns:a16="http://schemas.microsoft.com/office/drawing/2014/main" id="{1CDA35C3-4077-C672-BA3D-0AA38FDDB1B7}"/>
+              </a:ext>
+            </a:extLst>
+          </p:cNvPr>
+          <p:cNvSpPr txBox="1"/>
+          <p:nvPr/>
+        </p:nvSpPr>
+        <p:spPr>
+          <a:xfrm>
+            <a:off x="8454706" y="4795246"/>
+            <a:ext cx="514885" cy="369332"/>
+          </a:xfrm>
+          <a:prstGeom prst="rect">
+            <a:avLst/>
+          </a:prstGeom>
+          <a:noFill/>
+        </p:spPr>
+        <p:txBody>
+          <a:bodyPr wrap="none" rtlCol="0">
+            <a:spAutoFit/>
+          </a:bodyPr>
+          <a:lstStyle/>
+          <a:p>
+            <a:r>
+              <a:rPr lang="en-IL" dirty="0"/>
+              <a:t>EFS</a:t>
+            </a:r>
+          </a:p>
+        </p:txBody>
+      </p:sp>
+      <p:sp>
+        <p:nvSpPr>
+          <p:cNvPr id="4" name="TextBox 3">
+            <a:extLst>
+              <a:ext uri="{FF2B5EF4-FFF2-40B4-BE49-F238E27FC236}">
+                <a16:creationId xmlns:a16="http://schemas.microsoft.com/office/drawing/2014/main" id="{59C311CA-F832-98C7-E784-880E33075162}"/>
+              </a:ext>
+            </a:extLst>
+          </p:cNvPr>
+          <p:cNvSpPr txBox="1"/>
+          <p:nvPr/>
+        </p:nvSpPr>
+        <p:spPr>
+          <a:xfrm>
+            <a:off x="8962144" y="4795246"/>
+            <a:ext cx="319318" cy="369332"/>
+          </a:xfrm>
+          <a:prstGeom prst="rect">
+            <a:avLst/>
+          </a:prstGeom>
+          <a:noFill/>
+        </p:spPr>
+        <p:txBody>
+          <a:bodyPr wrap="none" rtlCol="0">
+            <a:spAutoFit/>
+          </a:bodyPr>
+          <a:lstStyle/>
+          <a:p>
+            <a:r>
+              <a:rPr lang="en-IL" dirty="0"/>
+              <a:t>=</a:t>
             </a:r>
           </a:p>
         </p:txBody>
@@ -19372,315 +19564,90 @@
           </a:p>
         </p:txBody>
       </p:sp>
-      <p:grpSp>
-        <p:nvGrpSpPr>
-          <p:cNvPr id="24" name="Group 23">
+      <p:sp>
+        <p:nvSpPr>
+          <p:cNvPr id="28" name="TextBox 27">
             <a:extLst>
               <a:ext uri="{FF2B5EF4-FFF2-40B4-BE49-F238E27FC236}">
-                <a16:creationId xmlns:a16="http://schemas.microsoft.com/office/drawing/2014/main" id="{E29CBCBB-4C1B-2DF0-8EC2-F57BECA89F29}"/>
+                <a16:creationId xmlns:a16="http://schemas.microsoft.com/office/drawing/2014/main" id="{8942A983-A5F6-ABFD-0224-23DB26EE91EE}"/>
               </a:ext>
             </a:extLst>
           </p:cNvPr>
-          <p:cNvGrpSpPr/>
+          <p:cNvSpPr txBox="1"/>
           <p:nvPr/>
-        </p:nvGrpSpPr>
-        <p:grpSpPr>
+        </p:nvSpPr>
+        <p:spPr>
           <a:xfrm>
-            <a:off x="8712017" y="4732140"/>
-            <a:ext cx="3276783" cy="1106115"/>
-            <a:chOff x="8921977" y="4001571"/>
-            <a:chExt cx="2926080" cy="1474819"/>
+            <a:off x="267478" y="4631438"/>
+            <a:ext cx="3331985" cy="369331"/>
           </a:xfrm>
-        </p:grpSpPr>
-        <p:sp>
-          <p:nvSpPr>
-            <p:cNvPr id="25" name="TextBox 24">
-              <a:extLst>
-                <a:ext uri="{FF2B5EF4-FFF2-40B4-BE49-F238E27FC236}">
-                  <a16:creationId xmlns:a16="http://schemas.microsoft.com/office/drawing/2014/main" id="{7C206EAE-24D6-0255-9D94-60DBD39D8975}"/>
-                </a:ext>
-              </a:extLst>
-            </p:cNvPr>
-            <p:cNvSpPr txBox="1"/>
-            <p:nvPr/>
-          </p:nvSpPr>
-          <p:spPr>
-            <a:xfrm>
-              <a:off x="8921977" y="4001571"/>
-              <a:ext cx="2926080" cy="533480"/>
-            </a:xfrm>
-            <a:prstGeom prst="rect">
-              <a:avLst/>
-            </a:prstGeom>
-            <a:noFill/>
-          </p:spPr>
-          <p:txBody>
-            <a:bodyPr wrap="square" lIns="0" rIns="0" rtlCol="0" anchor="b">
-              <a:spAutoFit/>
-            </a:bodyPr>
-            <a:lstStyle/>
-            <a:p>
-              <a:r>
-                <a:rPr lang="en-US" sz="2000" b="1" noProof="1"/>
-                <a:t>Calculate Functional Score</a:t>
-              </a:r>
-            </a:p>
-          </p:txBody>
-        </p:sp>
-        <p:sp>
-          <p:nvSpPr>
-            <p:cNvPr id="26" name="TextBox 25">
-              <a:extLst>
-                <a:ext uri="{FF2B5EF4-FFF2-40B4-BE49-F238E27FC236}">
-                  <a16:creationId xmlns:a16="http://schemas.microsoft.com/office/drawing/2014/main" id="{029CD787-36A6-E36D-D38D-0ADF0E036377}"/>
-                </a:ext>
-              </a:extLst>
-            </p:cNvPr>
-            <p:cNvSpPr txBox="1"/>
-            <p:nvPr/>
-          </p:nvSpPr>
-          <p:spPr>
-            <a:xfrm>
-              <a:off x="8921977" y="4532543"/>
-              <a:ext cx="2926080" cy="943847"/>
-            </a:xfrm>
-            <a:prstGeom prst="rect">
-              <a:avLst/>
-            </a:prstGeom>
-            <a:noFill/>
-          </p:spPr>
-          <p:txBody>
-            <a:bodyPr wrap="square" lIns="0" rIns="0" rtlCol="0" anchor="t">
-              <a:spAutoFit/>
-            </a:bodyPr>
-            <a:lstStyle/>
-            <a:p>
-              <a:r>
-                <a:rPr lang="en-US" sz="1000" noProof="1">
-                  <a:solidFill>
-                    <a:schemeClr val="tx1">
-                      <a:lumMod val="65000"/>
-                      <a:lumOff val="35000"/>
-                    </a:schemeClr>
-                  </a:solidFill>
-                </a:rPr>
-                <a:t>Integrate the three Z-scores using the Combined Phenotype Score formula. This single value per allele - the EFS - reflects the degree to which each TP53 variant retains or loses normal p53 function.</a:t>
-              </a:r>
-            </a:p>
-          </p:txBody>
-        </p:sp>
-      </p:grpSp>
-      <p:grpSp>
-        <p:nvGrpSpPr>
-          <p:cNvPr id="27" name="Group 26">
+          <a:prstGeom prst="rect">
+            <a:avLst/>
+          </a:prstGeom>
+          <a:noFill/>
+        </p:spPr>
+        <p:txBody>
+          <a:bodyPr wrap="square" lIns="0" rIns="0" rtlCol="0" anchor="b">
+            <a:spAutoFit/>
+          </a:bodyPr>
+          <a:lstStyle/>
+          <a:p>
+            <a:pPr algn="r"/>
+            <a:r>
+              <a:rPr lang="en-US" b="1" dirty="0">
+                <a:solidFill>
+                  <a:schemeClr val="accent3">
+                    <a:lumMod val="75000"/>
+                  </a:schemeClr>
+                </a:solidFill>
+              </a:rPr>
+              <a:t>Quantify Allele Enrichment</a:t>
+            </a:r>
+            <a:endParaRPr lang="en-US" sz="2000" b="1" noProof="1">
+              <a:solidFill>
+                <a:schemeClr val="accent3">
+                  <a:lumMod val="75000"/>
+                </a:schemeClr>
+              </a:solidFill>
+            </a:endParaRPr>
+          </a:p>
+        </p:txBody>
+      </p:sp>
+      <p:sp>
+        <p:nvSpPr>
+          <p:cNvPr id="31" name="TextBox 30">
             <a:extLst>
               <a:ext uri="{FF2B5EF4-FFF2-40B4-BE49-F238E27FC236}">
-                <a16:creationId xmlns:a16="http://schemas.microsoft.com/office/drawing/2014/main" id="{21A58634-09AD-7191-8CB1-415349F3F72D}"/>
+                <a16:creationId xmlns:a16="http://schemas.microsoft.com/office/drawing/2014/main" id="{3D260321-9767-EB34-9D32-B3E6B7A5E920}"/>
               </a:ext>
             </a:extLst>
           </p:cNvPr>
-          <p:cNvGrpSpPr/>
+          <p:cNvSpPr txBox="1"/>
           <p:nvPr/>
-        </p:nvGrpSpPr>
-        <p:grpSpPr>
-          <a:xfrm>
-            <a:off x="267478" y="4631438"/>
-            <a:ext cx="3331985" cy="921449"/>
-            <a:chOff x="332936" y="4621561"/>
-            <a:chExt cx="2926080" cy="1228599"/>
-          </a:xfrm>
-        </p:grpSpPr>
-        <p:sp>
-          <p:nvSpPr>
-            <p:cNvPr id="28" name="TextBox 27">
-              <a:extLst>
-                <a:ext uri="{FF2B5EF4-FFF2-40B4-BE49-F238E27FC236}">
-                  <a16:creationId xmlns:a16="http://schemas.microsoft.com/office/drawing/2014/main" id="{8942A983-A5F6-ABFD-0224-23DB26EE91EE}"/>
-                </a:ext>
-              </a:extLst>
-            </p:cNvPr>
-            <p:cNvSpPr txBox="1"/>
-            <p:nvPr/>
-          </p:nvSpPr>
-          <p:spPr>
-            <a:xfrm>
-              <a:off x="332936" y="4621561"/>
-              <a:ext cx="2926080" cy="492442"/>
-            </a:xfrm>
-            <a:prstGeom prst="rect">
-              <a:avLst/>
-            </a:prstGeom>
-            <a:noFill/>
-          </p:spPr>
-          <p:txBody>
-            <a:bodyPr wrap="square" lIns="0" rIns="0" rtlCol="0" anchor="b">
-              <a:spAutoFit/>
-            </a:bodyPr>
-            <a:lstStyle/>
-            <a:p>
-              <a:pPr algn="r"/>
-              <a:r>
-                <a:rPr lang="en-US" b="1" dirty="0">
-                  <a:solidFill>
-                    <a:schemeClr val="accent3">
-                      <a:lumMod val="75000"/>
-                    </a:schemeClr>
-                  </a:solidFill>
-                </a:rPr>
-                <a:t>Quantify Allele Enrichment</a:t>
-              </a:r>
-              <a:endParaRPr lang="en-US" sz="2000" b="1" noProof="1">
-                <a:solidFill>
-                  <a:schemeClr val="accent3">
-                    <a:lumMod val="75000"/>
-                  </a:schemeClr>
-                </a:solidFill>
-              </a:endParaRPr>
-            </a:p>
-          </p:txBody>
-        </p:sp>
-        <p:sp>
-          <p:nvSpPr>
-            <p:cNvPr id="29" name="TextBox 28">
-              <a:extLst>
-                <a:ext uri="{FF2B5EF4-FFF2-40B4-BE49-F238E27FC236}">
-                  <a16:creationId xmlns:a16="http://schemas.microsoft.com/office/drawing/2014/main" id="{8EDD7600-FAC4-457E-B601-644F9AEB4047}"/>
-                </a:ext>
-              </a:extLst>
-            </p:cNvPr>
-            <p:cNvSpPr txBox="1"/>
-            <p:nvPr/>
-          </p:nvSpPr>
-          <p:spPr>
-            <a:xfrm>
-              <a:off x="332936" y="5111496"/>
-              <a:ext cx="2926080" cy="738664"/>
-            </a:xfrm>
-            <a:prstGeom prst="rect">
-              <a:avLst/>
-            </a:prstGeom>
-            <a:noFill/>
-          </p:spPr>
-          <p:txBody>
-            <a:bodyPr wrap="square" lIns="0" rIns="0" rtlCol="0" anchor="t">
-              <a:spAutoFit/>
-            </a:bodyPr>
-            <a:lstStyle/>
-            <a:p>
-              <a:pPr algn="r"/>
-              <a:r>
-                <a:rPr lang="en-US" sz="1000" noProof="1">
-                  <a:solidFill>
-                    <a:schemeClr val="tx1">
-                      <a:lumMod val="65000"/>
-                      <a:lumOff val="35000"/>
-                    </a:schemeClr>
-                  </a:solidFill>
-                </a:rPr>
-                <a:t>Compute log₂ fold-change for each allele relative to the early timepoint. Standardize across alleles to produce a Z-score for each of the three conditions.</a:t>
-              </a:r>
-            </a:p>
-          </p:txBody>
-        </p:sp>
-      </p:grpSp>
-      <p:grpSp>
-        <p:nvGrpSpPr>
-          <p:cNvPr id="30" name="Group 29">
-            <a:extLst>
-              <a:ext uri="{FF2B5EF4-FFF2-40B4-BE49-F238E27FC236}">
-                <a16:creationId xmlns:a16="http://schemas.microsoft.com/office/drawing/2014/main" id="{E171EA8F-DD72-BF8C-191B-170C89212965}"/>
-              </a:ext>
-            </a:extLst>
-          </p:cNvPr>
-          <p:cNvGrpSpPr/>
-          <p:nvPr/>
-        </p:nvGrpSpPr>
-        <p:grpSpPr>
+        </p:nvSpPr>
+        <p:spPr>
           <a:xfrm>
             <a:off x="1286933" y="2249613"/>
-            <a:ext cx="3854634" cy="967371"/>
-            <a:chOff x="8921977" y="984542"/>
-            <a:chExt cx="2926080" cy="2202911"/>
+            <a:ext cx="3614699" cy="414475"/>
           </a:xfrm>
-        </p:grpSpPr>
-        <p:sp>
-          <p:nvSpPr>
-            <p:cNvPr id="31" name="TextBox 30">
-              <a:extLst>
-                <a:ext uri="{FF2B5EF4-FFF2-40B4-BE49-F238E27FC236}">
-                  <a16:creationId xmlns:a16="http://schemas.microsoft.com/office/drawing/2014/main" id="{3D260321-9767-EB34-9D32-B3E6B7A5E920}"/>
-                </a:ext>
-              </a:extLst>
-            </p:cNvPr>
-            <p:cNvSpPr txBox="1"/>
-            <p:nvPr/>
-          </p:nvSpPr>
-          <p:spPr>
-            <a:xfrm>
-              <a:off x="8921977" y="984542"/>
-              <a:ext cx="2743944" cy="943848"/>
-            </a:xfrm>
-            <a:prstGeom prst="rect">
-              <a:avLst/>
-            </a:prstGeom>
-            <a:noFill/>
-          </p:spPr>
-          <p:txBody>
-            <a:bodyPr wrap="square" lIns="0" rIns="0" rtlCol="0" anchor="b">
-              <a:spAutoFit/>
-            </a:bodyPr>
-            <a:lstStyle/>
-            <a:p>
-              <a:r>
-                <a:rPr lang="en-US" sz="2000" b="1" noProof="1"/>
-                <a:t>Screen 8,258 TP53 Variants</a:t>
-              </a:r>
-            </a:p>
-          </p:txBody>
-        </p:sp>
-        <p:sp>
-          <p:nvSpPr>
-            <p:cNvPr id="32" name="TextBox 31">
-              <a:extLst>
-                <a:ext uri="{FF2B5EF4-FFF2-40B4-BE49-F238E27FC236}">
-                  <a16:creationId xmlns:a16="http://schemas.microsoft.com/office/drawing/2014/main" id="{98BB05E3-9081-458B-E9A2-F494333320AC}"/>
-                </a:ext>
-              </a:extLst>
-            </p:cNvPr>
-            <p:cNvSpPr txBox="1"/>
-            <p:nvPr/>
-          </p:nvSpPr>
-          <p:spPr>
-            <a:xfrm>
-              <a:off x="8921977" y="1925881"/>
-              <a:ext cx="2926080" cy="1261572"/>
-            </a:xfrm>
-            <a:prstGeom prst="rect">
-              <a:avLst/>
-            </a:prstGeom>
-            <a:noFill/>
-          </p:spPr>
-          <p:txBody>
-            <a:bodyPr wrap="square" lIns="0" rIns="0" rtlCol="0" anchor="t">
-              <a:spAutoFit/>
-            </a:bodyPr>
-            <a:lstStyle/>
-            <a:p>
-              <a:r>
-                <a:rPr lang="en-US" sz="1000" noProof="1">
-                  <a:solidFill>
-                    <a:schemeClr val="tx1">
-                      <a:lumMod val="65000"/>
-                      <a:lumOff val="35000"/>
-                    </a:schemeClr>
-                  </a:solidFill>
-                </a:rPr>
-                <a:t>Run 3 competitive growth screens in isogenic p53WT and p53NULL cells treated with nutlin-3 or etoposide. Collect read counts to quantify allele representation.</a:t>
-              </a:r>
-            </a:p>
-          </p:txBody>
-        </p:sp>
-      </p:grpSp>
+          <a:prstGeom prst="rect">
+            <a:avLst/>
+          </a:prstGeom>
+          <a:noFill/>
+        </p:spPr>
+        <p:txBody>
+          <a:bodyPr wrap="square" lIns="0" rIns="0" rtlCol="0" anchor="b">
+            <a:spAutoFit/>
+          </a:bodyPr>
+          <a:lstStyle/>
+          <a:p>
+            <a:r>
+              <a:rPr lang="en-US" sz="2000" b="1" noProof="1"/>
+              <a:t>Screen 8,258 TP53 Variants</a:t>
+            </a:r>
+          </a:p>
+        </p:txBody>
+      </p:sp>
       <p:sp>
         <p:nvSpPr>
           <p:cNvPr id="36" name="TextBox 35">
@@ -19742,66 +19709,6 @@
           </a:p>
           <a:p>
             <a:endParaRPr lang="en-IL" dirty="0"/>
-          </a:p>
-        </p:txBody>
-      </p:sp>
-      <p:sp>
-        <p:nvSpPr>
-          <p:cNvPr id="43" name="TextBox 42">
-            <a:extLst>
-              <a:ext uri="{FF2B5EF4-FFF2-40B4-BE49-F238E27FC236}">
-                <a16:creationId xmlns:a16="http://schemas.microsoft.com/office/drawing/2014/main" id="{338E2388-7BE2-2CA4-E9D7-BA57778CFDE0}"/>
-              </a:ext>
-            </a:extLst>
-          </p:cNvPr>
-          <p:cNvSpPr txBox="1"/>
-          <p:nvPr/>
-        </p:nvSpPr>
-        <p:spPr>
-          <a:xfrm>
-            <a:off x="8712017" y="4224828"/>
-            <a:ext cx="3092506" cy="523220"/>
-          </a:xfrm>
-          <a:prstGeom prst="rect">
-            <a:avLst/>
-          </a:prstGeom>
-          <a:noFill/>
-        </p:spPr>
-        <p:txBody>
-          <a:bodyPr wrap="square" rtlCol="0">
-            <a:spAutoFit/>
-          </a:bodyPr>
-          <a:lstStyle/>
-          <a:p>
-            <a:pPr algn="ctr"/>
-            <a:r>
-              <a:rPr lang="en-US" sz="1400" dirty="0"/>
-              <a:t>EFS = [Z(</a:t>
-            </a:r>
-            <a:r>
-              <a:rPr lang="en-US" sz="1400" dirty="0" err="1"/>
-              <a:t>WT+nutlin</a:t>
-            </a:r>
-            <a:r>
-              <a:rPr lang="en-US" sz="1400" dirty="0"/>
-              <a:t>) + Z(</a:t>
-            </a:r>
-            <a:r>
-              <a:rPr lang="en-US" sz="1400" dirty="0" err="1"/>
-              <a:t>NULL+nutlin</a:t>
-            </a:r>
-            <a:r>
-              <a:rPr lang="en-US" sz="1400" dirty="0"/>
-              <a:t>) − Z(</a:t>
-            </a:r>
-            <a:r>
-              <a:rPr lang="en-US" sz="1400" dirty="0" err="1"/>
-              <a:t>NULL+etop</a:t>
-            </a:r>
-            <a:r>
-              <a:rPr lang="en-US" sz="1400" dirty="0"/>
-              <a:t>)] / 3</a:t>
-            </a:r>
           </a:p>
         </p:txBody>
       </p:sp>
@@ -20147,6 +20054,241 @@
                 <a:cs typeface="Corsiva Hebrew" pitchFamily="2" charset="-79"/>
               </a:rPr>
               <a:t>Background</a:t>
+            </a:r>
+          </a:p>
+        </p:txBody>
+      </p:sp>
+      <p:pic>
+        <p:nvPicPr>
+          <p:cNvPr id="2050" name="Picture 2" descr="Fig. 2: Comprehensive mutational scanning of TP53.">
+            <a:extLst>
+              <a:ext uri="{FF2B5EF4-FFF2-40B4-BE49-F238E27FC236}">
+                <a16:creationId xmlns:a16="http://schemas.microsoft.com/office/drawing/2014/main" id="{CF0DE577-6944-CDF6-5AC2-08D75F2FD64E}"/>
+              </a:ext>
+            </a:extLst>
+          </p:cNvPr>
+          <p:cNvPicPr>
+            <a:picLocks noChangeAspect="1" noChangeArrowheads="1"/>
+          </p:cNvPicPr>
+          <p:nvPr/>
+        </p:nvPicPr>
+        <p:blipFill rotWithShape="1">
+          <a:blip r:embed="rId4">
+            <a:extLst>
+              <a:ext uri="{28A0092B-C50C-407E-A947-70E740481C1C}">
+                <a14:useLocalDpi xmlns:a14="http://schemas.microsoft.com/office/drawing/2010/main" val="0"/>
+              </a:ext>
+            </a:extLst>
+          </a:blip>
+          <a:srcRect l="-377" t="28507" r="68816" b="51724"/>
+          <a:stretch>
+            <a:fillRect/>
+          </a:stretch>
+        </p:blipFill>
+        <p:spPr bwMode="auto">
+          <a:xfrm>
+            <a:off x="7990286" y="1978178"/>
+            <a:ext cx="3771741" cy="1826083"/>
+          </a:xfrm>
+          <a:prstGeom prst="rect">
+            <a:avLst/>
+          </a:prstGeom>
+          <a:noFill/>
+          <a:ln w="12700">
+            <a:solidFill>
+              <a:schemeClr val="accent1"/>
+            </a:solidFill>
+          </a:ln>
+          <a:extLst>
+            <a:ext uri="{909E8E84-426E-40DD-AFC4-6F175D3DCCD1}">
+              <a14:hiddenFill xmlns:a14="http://schemas.microsoft.com/office/drawing/2010/main">
+                <a:solidFill>
+                  <a:srgbClr val="FFFFFF"/>
+                </a:solidFill>
+              </a14:hiddenFill>
+            </a:ext>
+          </a:extLst>
+        </p:spPr>
+      </p:pic>
+      <p:sp>
+        <p:nvSpPr>
+          <p:cNvPr id="11" name="TextBox 10">
+            <a:extLst>
+              <a:ext uri="{FF2B5EF4-FFF2-40B4-BE49-F238E27FC236}">
+                <a16:creationId xmlns:a16="http://schemas.microsoft.com/office/drawing/2014/main" id="{0A5BB6FA-4B71-EADA-848F-85CE375EC46F}"/>
+              </a:ext>
+            </a:extLst>
+          </p:cNvPr>
+          <p:cNvSpPr txBox="1"/>
+          <p:nvPr/>
+        </p:nvSpPr>
+        <p:spPr>
+          <a:xfrm>
+            <a:off x="8712017" y="5472237"/>
+            <a:ext cx="3276783" cy="400110"/>
+          </a:xfrm>
+          <a:prstGeom prst="rect">
+            <a:avLst/>
+          </a:prstGeom>
+          <a:noFill/>
+        </p:spPr>
+        <p:txBody>
+          <a:bodyPr wrap="square" lIns="0" rIns="0" rtlCol="0" anchor="b">
+            <a:spAutoFit/>
+          </a:bodyPr>
+          <a:lstStyle/>
+          <a:p>
+            <a:r>
+              <a:rPr lang="en-US" sz="2000" b="1" noProof="1"/>
+              <a:t>Calculate Functional Score</a:t>
+            </a:r>
+          </a:p>
+        </p:txBody>
+      </p:sp>
+      <p:sp>
+        <p:nvSpPr>
+          <p:cNvPr id="12" name="TextBox 11">
+            <a:extLst>
+              <a:ext uri="{FF2B5EF4-FFF2-40B4-BE49-F238E27FC236}">
+                <a16:creationId xmlns:a16="http://schemas.microsoft.com/office/drawing/2014/main" id="{B495DDAB-13AE-21BC-8873-636E480C1934}"/>
+              </a:ext>
+            </a:extLst>
+          </p:cNvPr>
+          <p:cNvSpPr txBox="1"/>
+          <p:nvPr/>
+        </p:nvSpPr>
+        <p:spPr>
+          <a:xfrm>
+            <a:off x="9121803" y="4301847"/>
+            <a:ext cx="3092506" cy="1123384"/>
+          </a:xfrm>
+          <a:prstGeom prst="rect">
+            <a:avLst/>
+          </a:prstGeom>
+          <a:noFill/>
+        </p:spPr>
+        <p:txBody>
+          <a:bodyPr wrap="square" rtlCol="0">
+            <a:spAutoFit/>
+          </a:bodyPr>
+          <a:lstStyle/>
+          <a:p>
+            <a:pPr algn="ctr"/>
+            <a:r>
+              <a:rPr lang="en-US" sz="1400" dirty="0"/>
+              <a:t>[Z(</a:t>
+            </a:r>
+            <a:r>
+              <a:rPr lang="en-US" sz="1400" dirty="0" err="1"/>
+              <a:t>WT+nutlin</a:t>
+            </a:r>
+            <a:r>
+              <a:rPr lang="en-US" sz="1400" dirty="0"/>
+              <a:t>) + Z(</a:t>
+            </a:r>
+            <a:r>
+              <a:rPr lang="en-US" sz="1400" dirty="0" err="1"/>
+              <a:t>NULL+nutlin</a:t>
+            </a:r>
+            <a:r>
+              <a:rPr lang="en-US" sz="1400" dirty="0"/>
+              <a:t>) - Z(</a:t>
+            </a:r>
+            <a:r>
+              <a:rPr lang="en-US" sz="1400" dirty="0" err="1"/>
+              <a:t>NULL+etop</a:t>
+            </a:r>
+            <a:r>
+              <a:rPr lang="en-US" sz="1400" dirty="0"/>
+              <a:t>)]</a:t>
+            </a:r>
+          </a:p>
+          <a:p>
+            <a:pPr algn="ctr"/>
+            <a:r>
+              <a:rPr lang="en-US" sz="1400" dirty="0"/>
+              <a:t>____________________________</a:t>
+            </a:r>
+          </a:p>
+          <a:p>
+            <a:pPr algn="ctr"/>
+            <a:endParaRPr lang="en-US" sz="1100" dirty="0"/>
+          </a:p>
+          <a:p>
+            <a:pPr algn="ctr"/>
+            <a:r>
+              <a:rPr lang="en-US" sz="1400" dirty="0"/>
+              <a:t>3</a:t>
+            </a:r>
+          </a:p>
+        </p:txBody>
+      </p:sp>
+      <p:sp>
+        <p:nvSpPr>
+          <p:cNvPr id="13" name="TextBox 12">
+            <a:extLst>
+              <a:ext uri="{FF2B5EF4-FFF2-40B4-BE49-F238E27FC236}">
+                <a16:creationId xmlns:a16="http://schemas.microsoft.com/office/drawing/2014/main" id="{C3C2DBD0-19DA-6708-B5EE-2462DB06F568}"/>
+              </a:ext>
+            </a:extLst>
+          </p:cNvPr>
+          <p:cNvSpPr txBox="1"/>
+          <p:nvPr/>
+        </p:nvSpPr>
+        <p:spPr>
+          <a:xfrm>
+            <a:off x="8454706" y="4795246"/>
+            <a:ext cx="514885" cy="369332"/>
+          </a:xfrm>
+          <a:prstGeom prst="rect">
+            <a:avLst/>
+          </a:prstGeom>
+          <a:noFill/>
+        </p:spPr>
+        <p:txBody>
+          <a:bodyPr wrap="none" rtlCol="0">
+            <a:spAutoFit/>
+          </a:bodyPr>
+          <a:lstStyle/>
+          <a:p>
+            <a:r>
+              <a:rPr lang="en-IL" dirty="0"/>
+              <a:t>EFS</a:t>
+            </a:r>
+          </a:p>
+        </p:txBody>
+      </p:sp>
+      <p:sp>
+        <p:nvSpPr>
+          <p:cNvPr id="21" name="TextBox 20">
+            <a:extLst>
+              <a:ext uri="{FF2B5EF4-FFF2-40B4-BE49-F238E27FC236}">
+                <a16:creationId xmlns:a16="http://schemas.microsoft.com/office/drawing/2014/main" id="{9A1E7E06-600D-22AB-A470-C6EF9A97C940}"/>
+              </a:ext>
+            </a:extLst>
+          </p:cNvPr>
+          <p:cNvSpPr txBox="1"/>
+          <p:nvPr/>
+        </p:nvSpPr>
+        <p:spPr>
+          <a:xfrm>
+            <a:off x="8962144" y="4795246"/>
+            <a:ext cx="319318" cy="369332"/>
+          </a:xfrm>
+          <a:prstGeom prst="rect">
+            <a:avLst/>
+          </a:prstGeom>
+          <a:noFill/>
+        </p:spPr>
+        <p:txBody>
+          <a:bodyPr wrap="none" rtlCol="0">
+            <a:spAutoFit/>
+          </a:bodyPr>
+          <a:lstStyle/>
+          <a:p>
+            <a:r>
+              <a:rPr lang="en-IL" dirty="0"/>
+              <a:t>=</a:t>
             </a:r>
           </a:p>
         </p:txBody>
@@ -21108,309 +21250,78 @@
           </a:p>
         </p:txBody>
       </p:sp>
-      <p:grpSp>
-        <p:nvGrpSpPr>
-          <p:cNvPr id="24" name="Group 23">
+      <p:sp>
+        <p:nvSpPr>
+          <p:cNvPr id="28" name="TextBox 27">
             <a:extLst>
               <a:ext uri="{FF2B5EF4-FFF2-40B4-BE49-F238E27FC236}">
-                <a16:creationId xmlns:a16="http://schemas.microsoft.com/office/drawing/2014/main" id="{1365890A-AFD2-8795-7757-690D2F59FB90}"/>
+                <a16:creationId xmlns:a16="http://schemas.microsoft.com/office/drawing/2014/main" id="{C068C0E7-73EB-621D-7356-C23796AAF798}"/>
               </a:ext>
             </a:extLst>
           </p:cNvPr>
-          <p:cNvGrpSpPr/>
+          <p:cNvSpPr txBox="1"/>
           <p:nvPr/>
-        </p:nvGrpSpPr>
-        <p:grpSpPr>
+        </p:nvSpPr>
+        <p:spPr>
           <a:xfrm>
-            <a:off x="8712017" y="4732140"/>
-            <a:ext cx="3276783" cy="1106115"/>
-            <a:chOff x="8921977" y="4001571"/>
-            <a:chExt cx="2926080" cy="1474819"/>
+            <a:off x="267478" y="4631438"/>
+            <a:ext cx="3331985" cy="369331"/>
           </a:xfrm>
-        </p:grpSpPr>
-        <p:sp>
-          <p:nvSpPr>
-            <p:cNvPr id="25" name="TextBox 24">
-              <a:extLst>
-                <a:ext uri="{FF2B5EF4-FFF2-40B4-BE49-F238E27FC236}">
-                  <a16:creationId xmlns:a16="http://schemas.microsoft.com/office/drawing/2014/main" id="{3EC68F3A-B7C4-4F8F-BD77-324C6DCFED45}"/>
-                </a:ext>
-              </a:extLst>
-            </p:cNvPr>
-            <p:cNvSpPr txBox="1"/>
-            <p:nvPr/>
-          </p:nvSpPr>
-          <p:spPr>
-            <a:xfrm>
-              <a:off x="8921977" y="4001571"/>
-              <a:ext cx="2926080" cy="533480"/>
-            </a:xfrm>
-            <a:prstGeom prst="rect">
-              <a:avLst/>
-            </a:prstGeom>
-            <a:noFill/>
-          </p:spPr>
-          <p:txBody>
-            <a:bodyPr wrap="square" lIns="0" rIns="0" rtlCol="0" anchor="b">
-              <a:spAutoFit/>
-            </a:bodyPr>
-            <a:lstStyle/>
-            <a:p>
-              <a:r>
-                <a:rPr lang="en-US" sz="2000" b="1" noProof="1">
-                  <a:solidFill>
-                    <a:schemeClr val="accent3">
-                      <a:lumMod val="75000"/>
-                    </a:schemeClr>
-                  </a:solidFill>
-                </a:rPr>
-                <a:t>Calculate Functional Score</a:t>
-              </a:r>
-            </a:p>
-          </p:txBody>
-        </p:sp>
-        <p:sp>
-          <p:nvSpPr>
-            <p:cNvPr id="26" name="TextBox 25">
-              <a:extLst>
-                <a:ext uri="{FF2B5EF4-FFF2-40B4-BE49-F238E27FC236}">
-                  <a16:creationId xmlns:a16="http://schemas.microsoft.com/office/drawing/2014/main" id="{DF53E615-9CE2-D1A4-465B-3280FD9BE951}"/>
-                </a:ext>
-              </a:extLst>
-            </p:cNvPr>
-            <p:cNvSpPr txBox="1"/>
-            <p:nvPr/>
-          </p:nvSpPr>
-          <p:spPr>
-            <a:xfrm>
-              <a:off x="8921977" y="4532543"/>
-              <a:ext cx="2926080" cy="943847"/>
-            </a:xfrm>
-            <a:prstGeom prst="rect">
-              <a:avLst/>
-            </a:prstGeom>
-            <a:noFill/>
-          </p:spPr>
-          <p:txBody>
-            <a:bodyPr wrap="square" lIns="0" rIns="0" rtlCol="0" anchor="t">
-              <a:spAutoFit/>
-            </a:bodyPr>
-            <a:lstStyle/>
-            <a:p>
-              <a:r>
-                <a:rPr lang="en-US" sz="1000" noProof="1">
-                  <a:solidFill>
-                    <a:schemeClr val="tx1">
-                      <a:lumMod val="65000"/>
-                      <a:lumOff val="35000"/>
-                    </a:schemeClr>
-                  </a:solidFill>
-                </a:rPr>
-                <a:t>Integrate the three Z-scores using the Combined Phenotype Score formula. This single value per allele - the EFS - reflects the degree to which each TP53 variant retains or loses normal p53 function.</a:t>
-              </a:r>
-            </a:p>
-          </p:txBody>
-        </p:sp>
-      </p:grpSp>
-      <p:grpSp>
-        <p:nvGrpSpPr>
-          <p:cNvPr id="27" name="Group 26">
+          <a:prstGeom prst="rect">
+            <a:avLst/>
+          </a:prstGeom>
+          <a:noFill/>
+        </p:spPr>
+        <p:txBody>
+          <a:bodyPr wrap="square" lIns="0" rIns="0" rtlCol="0" anchor="b">
+            <a:spAutoFit/>
+          </a:bodyPr>
+          <a:lstStyle/>
+          <a:p>
+            <a:pPr algn="r"/>
+            <a:r>
+              <a:rPr lang="en-US" b="1" dirty="0"/>
+              <a:t>Quantify Allele Enrichment</a:t>
+            </a:r>
+            <a:endParaRPr lang="en-US" sz="2000" b="1" noProof="1"/>
+          </a:p>
+        </p:txBody>
+      </p:sp>
+      <p:sp>
+        <p:nvSpPr>
+          <p:cNvPr id="31" name="TextBox 30">
             <a:extLst>
               <a:ext uri="{FF2B5EF4-FFF2-40B4-BE49-F238E27FC236}">
-                <a16:creationId xmlns:a16="http://schemas.microsoft.com/office/drawing/2014/main" id="{7652938D-04DB-9D68-9651-31AFDB763A1A}"/>
+                <a16:creationId xmlns:a16="http://schemas.microsoft.com/office/drawing/2014/main" id="{C179F1FA-36D8-4879-074A-1A5D6C93F38A}"/>
               </a:ext>
             </a:extLst>
           </p:cNvPr>
-          <p:cNvGrpSpPr/>
+          <p:cNvSpPr txBox="1"/>
           <p:nvPr/>
-        </p:nvGrpSpPr>
-        <p:grpSpPr>
-          <a:xfrm>
-            <a:off x="267478" y="4631438"/>
-            <a:ext cx="3331985" cy="921449"/>
-            <a:chOff x="332936" y="4621561"/>
-            <a:chExt cx="2926080" cy="1228599"/>
-          </a:xfrm>
-        </p:grpSpPr>
-        <p:sp>
-          <p:nvSpPr>
-            <p:cNvPr id="28" name="TextBox 27">
-              <a:extLst>
-                <a:ext uri="{FF2B5EF4-FFF2-40B4-BE49-F238E27FC236}">
-                  <a16:creationId xmlns:a16="http://schemas.microsoft.com/office/drawing/2014/main" id="{C068C0E7-73EB-621D-7356-C23796AAF798}"/>
-                </a:ext>
-              </a:extLst>
-            </p:cNvPr>
-            <p:cNvSpPr txBox="1"/>
-            <p:nvPr/>
-          </p:nvSpPr>
-          <p:spPr>
-            <a:xfrm>
-              <a:off x="332936" y="4621561"/>
-              <a:ext cx="2926080" cy="492442"/>
-            </a:xfrm>
-            <a:prstGeom prst="rect">
-              <a:avLst/>
-            </a:prstGeom>
-            <a:noFill/>
-          </p:spPr>
-          <p:txBody>
-            <a:bodyPr wrap="square" lIns="0" rIns="0" rtlCol="0" anchor="b">
-              <a:spAutoFit/>
-            </a:bodyPr>
-            <a:lstStyle/>
-            <a:p>
-              <a:pPr algn="r"/>
-              <a:r>
-                <a:rPr lang="en-US" b="1" dirty="0"/>
-                <a:t>Quantify Allele Enrichment</a:t>
-              </a:r>
-              <a:endParaRPr lang="en-US" sz="2000" b="1" noProof="1"/>
-            </a:p>
-          </p:txBody>
-        </p:sp>
-        <p:sp>
-          <p:nvSpPr>
-            <p:cNvPr id="29" name="TextBox 28">
-              <a:extLst>
-                <a:ext uri="{FF2B5EF4-FFF2-40B4-BE49-F238E27FC236}">
-                  <a16:creationId xmlns:a16="http://schemas.microsoft.com/office/drawing/2014/main" id="{149841CA-ED50-F40B-3A01-C40EF7A27B1D}"/>
-                </a:ext>
-              </a:extLst>
-            </p:cNvPr>
-            <p:cNvSpPr txBox="1"/>
-            <p:nvPr/>
-          </p:nvSpPr>
-          <p:spPr>
-            <a:xfrm>
-              <a:off x="332936" y="5111496"/>
-              <a:ext cx="2926080" cy="738664"/>
-            </a:xfrm>
-            <a:prstGeom prst="rect">
-              <a:avLst/>
-            </a:prstGeom>
-            <a:noFill/>
-          </p:spPr>
-          <p:txBody>
-            <a:bodyPr wrap="square" lIns="0" rIns="0" rtlCol="0" anchor="t">
-              <a:spAutoFit/>
-            </a:bodyPr>
-            <a:lstStyle/>
-            <a:p>
-              <a:pPr algn="r"/>
-              <a:r>
-                <a:rPr lang="en-US" sz="1000" noProof="1">
-                  <a:solidFill>
-                    <a:schemeClr val="tx1">
-                      <a:lumMod val="65000"/>
-                      <a:lumOff val="35000"/>
-                    </a:schemeClr>
-                  </a:solidFill>
-                </a:rPr>
-                <a:t>Compute log₂ fold-change for each allele relative to the early timepoint. Standardize across alleles to produce a Z-score for each of the three conditions.</a:t>
-              </a:r>
-            </a:p>
-          </p:txBody>
-        </p:sp>
-      </p:grpSp>
-      <p:grpSp>
-        <p:nvGrpSpPr>
-          <p:cNvPr id="30" name="Group 29">
-            <a:extLst>
-              <a:ext uri="{FF2B5EF4-FFF2-40B4-BE49-F238E27FC236}">
-                <a16:creationId xmlns:a16="http://schemas.microsoft.com/office/drawing/2014/main" id="{61E9F560-73EE-83EC-6317-B793527177EE}"/>
-              </a:ext>
-            </a:extLst>
-          </p:cNvPr>
-          <p:cNvGrpSpPr/>
-          <p:nvPr/>
-        </p:nvGrpSpPr>
-        <p:grpSpPr>
+        </p:nvSpPr>
+        <p:spPr>
           <a:xfrm>
             <a:off x="1286933" y="2249613"/>
-            <a:ext cx="3854634" cy="967371"/>
-            <a:chOff x="8921977" y="984542"/>
-            <a:chExt cx="2926080" cy="2202911"/>
+            <a:ext cx="3614699" cy="414475"/>
           </a:xfrm>
-        </p:grpSpPr>
-        <p:sp>
-          <p:nvSpPr>
-            <p:cNvPr id="31" name="TextBox 30">
-              <a:extLst>
-                <a:ext uri="{FF2B5EF4-FFF2-40B4-BE49-F238E27FC236}">
-                  <a16:creationId xmlns:a16="http://schemas.microsoft.com/office/drawing/2014/main" id="{C179F1FA-36D8-4879-074A-1A5D6C93F38A}"/>
-                </a:ext>
-              </a:extLst>
-            </p:cNvPr>
-            <p:cNvSpPr txBox="1"/>
-            <p:nvPr/>
-          </p:nvSpPr>
-          <p:spPr>
-            <a:xfrm>
-              <a:off x="8921977" y="984542"/>
-              <a:ext cx="2743944" cy="943848"/>
-            </a:xfrm>
-            <a:prstGeom prst="rect">
-              <a:avLst/>
-            </a:prstGeom>
-            <a:noFill/>
-          </p:spPr>
-          <p:txBody>
-            <a:bodyPr wrap="square" lIns="0" rIns="0" rtlCol="0" anchor="b">
-              <a:spAutoFit/>
-            </a:bodyPr>
-            <a:lstStyle/>
-            <a:p>
-              <a:r>
-                <a:rPr lang="en-US" sz="2000" b="1" noProof="1"/>
-                <a:t>Screen 8,258 TP53 Variants</a:t>
-              </a:r>
-            </a:p>
-          </p:txBody>
-        </p:sp>
-        <p:sp>
-          <p:nvSpPr>
-            <p:cNvPr id="32" name="TextBox 31">
-              <a:extLst>
-                <a:ext uri="{FF2B5EF4-FFF2-40B4-BE49-F238E27FC236}">
-                  <a16:creationId xmlns:a16="http://schemas.microsoft.com/office/drawing/2014/main" id="{75A1239B-ECEC-42AF-0483-364AF93282AD}"/>
-                </a:ext>
-              </a:extLst>
-            </p:cNvPr>
-            <p:cNvSpPr txBox="1"/>
-            <p:nvPr/>
-          </p:nvSpPr>
-          <p:spPr>
-            <a:xfrm>
-              <a:off x="8921977" y="1925881"/>
-              <a:ext cx="2926080" cy="1261572"/>
-            </a:xfrm>
-            <a:prstGeom prst="rect">
-              <a:avLst/>
-            </a:prstGeom>
-            <a:noFill/>
-          </p:spPr>
-          <p:txBody>
-            <a:bodyPr wrap="square" lIns="0" rIns="0" rtlCol="0" anchor="t">
-              <a:spAutoFit/>
-            </a:bodyPr>
-            <a:lstStyle/>
-            <a:p>
-              <a:r>
-                <a:rPr lang="en-US" sz="1000" noProof="1">
-                  <a:solidFill>
-                    <a:schemeClr val="tx1">
-                      <a:lumMod val="65000"/>
-                      <a:lumOff val="35000"/>
-                    </a:schemeClr>
-                  </a:solidFill>
-                </a:rPr>
-                <a:t>Run 3 competitive growth screens in isogenic p53WT and p53NULL cells treated with nutlin-3 or etoposide. Collect read counts to quantify allele representation.</a:t>
-              </a:r>
-            </a:p>
-          </p:txBody>
-        </p:sp>
-      </p:grpSp>
+          <a:prstGeom prst="rect">
+            <a:avLst/>
+          </a:prstGeom>
+          <a:noFill/>
+        </p:spPr>
+        <p:txBody>
+          <a:bodyPr wrap="square" lIns="0" rIns="0" rtlCol="0" anchor="b">
+            <a:spAutoFit/>
+          </a:bodyPr>
+          <a:lstStyle/>
+          <a:p>
+            <a:r>
+              <a:rPr lang="en-US" sz="2000" b="1" noProof="1"/>
+              <a:t>Screen 8,258 TP53 Variants</a:t>
+            </a:r>
+          </a:p>
+        </p:txBody>
+      </p:sp>
       <p:sp>
         <p:nvSpPr>
           <p:cNvPr id="36" name="TextBox 35">
@@ -21472,66 +21383,6 @@
           </a:p>
           <a:p>
             <a:endParaRPr lang="en-IL" dirty="0"/>
-          </a:p>
-        </p:txBody>
-      </p:sp>
-      <p:sp>
-        <p:nvSpPr>
-          <p:cNvPr id="43" name="TextBox 42">
-            <a:extLst>
-              <a:ext uri="{FF2B5EF4-FFF2-40B4-BE49-F238E27FC236}">
-                <a16:creationId xmlns:a16="http://schemas.microsoft.com/office/drawing/2014/main" id="{C6BC8DFC-F7CE-F022-5C20-BE6977408000}"/>
-              </a:ext>
-            </a:extLst>
-          </p:cNvPr>
-          <p:cNvSpPr txBox="1"/>
-          <p:nvPr/>
-        </p:nvSpPr>
-        <p:spPr>
-          <a:xfrm>
-            <a:off x="8712017" y="4224828"/>
-            <a:ext cx="3092506" cy="523220"/>
-          </a:xfrm>
-          <a:prstGeom prst="rect">
-            <a:avLst/>
-          </a:prstGeom>
-          <a:noFill/>
-        </p:spPr>
-        <p:txBody>
-          <a:bodyPr wrap="square" rtlCol="0">
-            <a:spAutoFit/>
-          </a:bodyPr>
-          <a:lstStyle/>
-          <a:p>
-            <a:pPr algn="ctr"/>
-            <a:r>
-              <a:rPr lang="en-US" sz="1400" dirty="0"/>
-              <a:t>EFS = [Z(</a:t>
-            </a:r>
-            <a:r>
-              <a:rPr lang="en-US" sz="1400" dirty="0" err="1"/>
-              <a:t>WT+nutlin</a:t>
-            </a:r>
-            <a:r>
-              <a:rPr lang="en-US" sz="1400" dirty="0"/>
-              <a:t>) + Z(</a:t>
-            </a:r>
-            <a:r>
-              <a:rPr lang="en-US" sz="1400" dirty="0" err="1"/>
-              <a:t>NULL+nutlin</a:t>
-            </a:r>
-            <a:r>
-              <a:rPr lang="en-US" sz="1400" dirty="0"/>
-              <a:t>) − Z(</a:t>
-            </a:r>
-            <a:r>
-              <a:rPr lang="en-US" sz="1400" dirty="0" err="1"/>
-              <a:t>NULL+etop</a:t>
-            </a:r>
-            <a:r>
-              <a:rPr lang="en-US" sz="1400" dirty="0"/>
-              <a:t>)] / 3</a:t>
-            </a:r>
           </a:p>
         </p:txBody>
       </p:sp>
@@ -21881,6 +21732,245 @@
           </a:p>
         </p:txBody>
       </p:sp>
+      <p:pic>
+        <p:nvPicPr>
+          <p:cNvPr id="3074" name="Picture 2" descr="Fig. 2: Comprehensive mutational scanning of TP53.">
+            <a:extLst>
+              <a:ext uri="{FF2B5EF4-FFF2-40B4-BE49-F238E27FC236}">
+                <a16:creationId xmlns:a16="http://schemas.microsoft.com/office/drawing/2014/main" id="{4A796C30-8577-A525-450C-DAEC0E23AD6E}"/>
+              </a:ext>
+            </a:extLst>
+          </p:cNvPr>
+          <p:cNvPicPr>
+            <a:picLocks noChangeAspect="1" noChangeArrowheads="1"/>
+          </p:cNvPicPr>
+          <p:nvPr/>
+        </p:nvPicPr>
+        <p:blipFill rotWithShape="1">
+          <a:blip r:embed="rId4">
+            <a:extLst>
+              <a:ext uri="{28A0092B-C50C-407E-A947-70E740481C1C}">
+                <a14:useLocalDpi xmlns:a14="http://schemas.microsoft.com/office/drawing/2010/main" val="0"/>
+              </a:ext>
+            </a:extLst>
+          </a:blip>
+          <a:srcRect l="31186" t="83484" r="-628" b="-1789"/>
+          <a:stretch>
+            <a:fillRect/>
+          </a:stretch>
+        </p:blipFill>
+        <p:spPr bwMode="auto">
+          <a:xfrm>
+            <a:off x="7532593" y="2169116"/>
+            <a:ext cx="4229434" cy="861774"/>
+          </a:xfrm>
+          <a:prstGeom prst="rect">
+            <a:avLst/>
+          </a:prstGeom>
+          <a:noFill/>
+          <a:ln w="12700">
+            <a:solidFill>
+              <a:schemeClr val="tx1"/>
+            </a:solidFill>
+          </a:ln>
+          <a:extLst>
+            <a:ext uri="{909E8E84-426E-40DD-AFC4-6F175D3DCCD1}">
+              <a14:hiddenFill xmlns:a14="http://schemas.microsoft.com/office/drawing/2010/main">
+                <a:solidFill>
+                  <a:srgbClr val="FFFFFF"/>
+                </a:solidFill>
+              </a14:hiddenFill>
+            </a:ext>
+          </a:extLst>
+        </p:spPr>
+      </p:pic>
+      <p:sp>
+        <p:nvSpPr>
+          <p:cNvPr id="11" name="TextBox 10">
+            <a:extLst>
+              <a:ext uri="{FF2B5EF4-FFF2-40B4-BE49-F238E27FC236}">
+                <a16:creationId xmlns:a16="http://schemas.microsoft.com/office/drawing/2014/main" id="{52F7814D-2864-116E-71FD-D49FD17CE8AB}"/>
+              </a:ext>
+            </a:extLst>
+          </p:cNvPr>
+          <p:cNvSpPr txBox="1"/>
+          <p:nvPr/>
+        </p:nvSpPr>
+        <p:spPr>
+          <a:xfrm>
+            <a:off x="8712017" y="5472237"/>
+            <a:ext cx="3276783" cy="400110"/>
+          </a:xfrm>
+          <a:prstGeom prst="rect">
+            <a:avLst/>
+          </a:prstGeom>
+          <a:noFill/>
+        </p:spPr>
+        <p:txBody>
+          <a:bodyPr wrap="square" lIns="0" rIns="0" rtlCol="0" anchor="b">
+            <a:spAutoFit/>
+          </a:bodyPr>
+          <a:lstStyle/>
+          <a:p>
+            <a:r>
+              <a:rPr lang="en-US" sz="2000" b="1" noProof="1">
+                <a:solidFill>
+                  <a:srgbClr val="903063"/>
+                </a:solidFill>
+              </a:rPr>
+              <a:t>Calculate Functional Score</a:t>
+            </a:r>
+          </a:p>
+        </p:txBody>
+      </p:sp>
+      <p:sp>
+        <p:nvSpPr>
+          <p:cNvPr id="12" name="TextBox 11">
+            <a:extLst>
+              <a:ext uri="{FF2B5EF4-FFF2-40B4-BE49-F238E27FC236}">
+                <a16:creationId xmlns:a16="http://schemas.microsoft.com/office/drawing/2014/main" id="{C3937F33-FAFC-5F41-1DB1-44F6F9FB5B3D}"/>
+              </a:ext>
+            </a:extLst>
+          </p:cNvPr>
+          <p:cNvSpPr txBox="1"/>
+          <p:nvPr/>
+        </p:nvSpPr>
+        <p:spPr>
+          <a:xfrm>
+            <a:off x="9121803" y="4301847"/>
+            <a:ext cx="3092506" cy="1123384"/>
+          </a:xfrm>
+          <a:prstGeom prst="rect">
+            <a:avLst/>
+          </a:prstGeom>
+          <a:noFill/>
+        </p:spPr>
+        <p:txBody>
+          <a:bodyPr wrap="square" rtlCol="0">
+            <a:spAutoFit/>
+          </a:bodyPr>
+          <a:lstStyle/>
+          <a:p>
+            <a:pPr algn="ctr"/>
+            <a:r>
+              <a:rPr lang="en-US" sz="1400" dirty="0"/>
+              <a:t>[Z(</a:t>
+            </a:r>
+            <a:r>
+              <a:rPr lang="en-US" sz="1400" dirty="0" err="1"/>
+              <a:t>WT+nutlin</a:t>
+            </a:r>
+            <a:r>
+              <a:rPr lang="en-US" sz="1400" dirty="0"/>
+              <a:t>) + Z(</a:t>
+            </a:r>
+            <a:r>
+              <a:rPr lang="en-US" sz="1400" dirty="0" err="1"/>
+              <a:t>NULL+nutlin</a:t>
+            </a:r>
+            <a:r>
+              <a:rPr lang="en-US" sz="1400" dirty="0"/>
+              <a:t>) - Z(</a:t>
+            </a:r>
+            <a:r>
+              <a:rPr lang="en-US" sz="1400" dirty="0" err="1"/>
+              <a:t>NULL+etop</a:t>
+            </a:r>
+            <a:r>
+              <a:rPr lang="en-US" sz="1400" dirty="0"/>
+              <a:t>)]</a:t>
+            </a:r>
+          </a:p>
+          <a:p>
+            <a:pPr algn="ctr"/>
+            <a:r>
+              <a:rPr lang="en-US" sz="1400" dirty="0"/>
+              <a:t>____________________________</a:t>
+            </a:r>
+          </a:p>
+          <a:p>
+            <a:pPr algn="ctr"/>
+            <a:endParaRPr lang="en-US" sz="1100" dirty="0"/>
+          </a:p>
+          <a:p>
+            <a:pPr algn="ctr"/>
+            <a:r>
+              <a:rPr lang="en-US" sz="1400" dirty="0"/>
+              <a:t>3</a:t>
+            </a:r>
+          </a:p>
+        </p:txBody>
+      </p:sp>
+      <p:sp>
+        <p:nvSpPr>
+          <p:cNvPr id="13" name="TextBox 12">
+            <a:extLst>
+              <a:ext uri="{FF2B5EF4-FFF2-40B4-BE49-F238E27FC236}">
+                <a16:creationId xmlns:a16="http://schemas.microsoft.com/office/drawing/2014/main" id="{75673C05-49DD-3F2C-6DF9-6F2930A59569}"/>
+              </a:ext>
+            </a:extLst>
+          </p:cNvPr>
+          <p:cNvSpPr txBox="1"/>
+          <p:nvPr/>
+        </p:nvSpPr>
+        <p:spPr>
+          <a:xfrm>
+            <a:off x="8454706" y="4795246"/>
+            <a:ext cx="514885" cy="369332"/>
+          </a:xfrm>
+          <a:prstGeom prst="rect">
+            <a:avLst/>
+          </a:prstGeom>
+          <a:noFill/>
+        </p:spPr>
+        <p:txBody>
+          <a:bodyPr wrap="none" rtlCol="0">
+            <a:spAutoFit/>
+          </a:bodyPr>
+          <a:lstStyle/>
+          <a:p>
+            <a:r>
+              <a:rPr lang="en-IL" dirty="0"/>
+              <a:t>EFS</a:t>
+            </a:r>
+          </a:p>
+        </p:txBody>
+      </p:sp>
+      <p:sp>
+        <p:nvSpPr>
+          <p:cNvPr id="21" name="TextBox 20">
+            <a:extLst>
+              <a:ext uri="{FF2B5EF4-FFF2-40B4-BE49-F238E27FC236}">
+                <a16:creationId xmlns:a16="http://schemas.microsoft.com/office/drawing/2014/main" id="{B80031CB-6D8D-D75F-F5C7-B4AB49F1FB13}"/>
+              </a:ext>
+            </a:extLst>
+          </p:cNvPr>
+          <p:cNvSpPr txBox="1"/>
+          <p:nvPr/>
+        </p:nvSpPr>
+        <p:spPr>
+          <a:xfrm>
+            <a:off x="8962144" y="4795246"/>
+            <a:ext cx="319318" cy="369332"/>
+          </a:xfrm>
+          <a:prstGeom prst="rect">
+            <a:avLst/>
+          </a:prstGeom>
+          <a:noFill/>
+        </p:spPr>
+        <p:txBody>
+          <a:bodyPr wrap="none" rtlCol="0">
+            <a:spAutoFit/>
+          </a:bodyPr>
+          <a:lstStyle/>
+          <a:p>
+            <a:r>
+              <a:rPr lang="en-IL" dirty="0"/>
+              <a:t>=</a:t>
+            </a:r>
+          </a:p>
+        </p:txBody>
+      </p:sp>
     </p:spTree>
     <p:extLst>
       <p:ext uri="{BB962C8B-B14F-4D97-AF65-F5344CB8AC3E}">
@@ -21972,8 +22062,8 @@
         </p:nvSpPr>
         <p:spPr>
           <a:xfrm>
-            <a:off x="1333373" y="2396326"/>
-            <a:ext cx="9525253" cy="3572037"/>
+            <a:off x="616688" y="2475595"/>
+            <a:ext cx="10958623" cy="3572037"/>
           </a:xfrm>
         </p:spPr>
         <p:txBody>
@@ -21986,10 +22076,42 @@
               <a:buNone/>
             </a:pPr>
             <a:r>
-              <a:rPr lang="en-US" sz="2400" dirty="0"/>
-              <a:t>Patients with TP53 mutations that have the lowest experimental function scores (EFS) will show the highest Fraction Genome Altered (FGA)</a:t>
-            </a:r>
-            <a:endParaRPr lang="en-IL" sz="2400" dirty="0"/>
+              <a:rPr lang="en-US" sz="4000" dirty="0"/>
+              <a:t>Patients with TP53 mutations that have</a:t>
+            </a:r>
+            <a:r>
+              <a:rPr lang="he-IL" sz="4000" dirty="0"/>
+              <a:t> </a:t>
+            </a:r>
+            <a:r>
+              <a:rPr lang="en-US" sz="4000" dirty="0"/>
+              <a:t>the lowest </a:t>
+            </a:r>
+            <a:r>
+              <a:rPr lang="en-US" sz="4000" dirty="0">
+                <a:solidFill>
+                  <a:srgbClr val="00B050"/>
+                </a:solidFill>
+              </a:rPr>
+              <a:t>experimental function scores (EFS) </a:t>
+            </a:r>
+            <a:r>
+              <a:rPr lang="en-US" sz="4000" dirty="0"/>
+              <a:t>will show the highest </a:t>
+            </a:r>
+            <a:r>
+              <a:rPr lang="en-US" sz="4000" dirty="0">
+                <a:solidFill>
+                  <a:srgbClr val="FF0000"/>
+                </a:solidFill>
+              </a:rPr>
+              <a:t>Fraction Genome Altered (FGA)</a:t>
+            </a:r>
+            <a:endParaRPr lang="en-IL" sz="4000" dirty="0">
+              <a:solidFill>
+                <a:srgbClr val="FF0000"/>
+              </a:solidFill>
+            </a:endParaRPr>
           </a:p>
         </p:txBody>
       </p:sp>
@@ -22094,8 +22216,12 @@
           </a:lstStyle>
           <a:p>
             <a:r>
+              <a:rPr lang="en-US" dirty="0" err="1"/>
+              <a:t>iNITIAL</a:t>
+            </a:r>
+            <a:r>
               <a:rPr lang="en-US" dirty="0"/>
-              <a:t>Hypothesis</a:t>
+              <a:t> Hypothesis</a:t>
             </a:r>
             <a:endParaRPr lang="en-IL" dirty="0"/>
           </a:p>
@@ -22458,7 +22584,7 @@
         </p:nvSpPr>
         <p:spPr>
           <a:xfrm>
-            <a:off x="2141709" y="2676259"/>
+            <a:off x="2303060" y="2491881"/>
             <a:ext cx="3821288" cy="3880773"/>
           </a:xfrm>
           <a:prstGeom prst="rect">
@@ -22728,41 +22854,6 @@
             <a:r>
               <a:rPr lang="en-US" dirty="0"/>
               <a:t>65,061 TP53-WT</a:t>
-            </a:r>
-          </a:p>
-        </p:txBody>
-      </p:sp>
-      <p:sp>
-        <p:nvSpPr>
-          <p:cNvPr id="5" name="TextBox 4">
-            <a:extLst>
-              <a:ext uri="{FF2B5EF4-FFF2-40B4-BE49-F238E27FC236}">
-                <a16:creationId xmlns:a16="http://schemas.microsoft.com/office/drawing/2014/main" id="{D6DF2B16-6F47-3D24-4C4D-F99346EBABA1}"/>
-              </a:ext>
-            </a:extLst>
-          </p:cNvPr>
-          <p:cNvSpPr txBox="1"/>
-          <p:nvPr/>
-        </p:nvSpPr>
-        <p:spPr>
-          <a:xfrm>
-            <a:off x="2141709" y="2125487"/>
-            <a:ext cx="1954446" cy="369332"/>
-          </a:xfrm>
-          <a:prstGeom prst="rect">
-            <a:avLst/>
-          </a:prstGeom>
-          <a:noFill/>
-        </p:spPr>
-        <p:txBody>
-          <a:bodyPr wrap="none" rtlCol="0">
-            <a:spAutoFit/>
-          </a:bodyPr>
-          <a:lstStyle/>
-          <a:p>
-            <a:r>
-              <a:rPr lang="en-IL" b="1" dirty="0"/>
-              <a:t>Primary Analysis</a:t>
             </a:r>
           </a:p>
         </p:txBody>

</xml_diff>

<commit_message>
added pdf of presentation
</commit_message>
<xml_diff>
--- a/project/project_background/Final Project Presentation - Ornit - Cancer Bioinfo March 2026.pptx
+++ b/project/project_background/Final Project Presentation - Ornit - Cancer Bioinfo March 2026.pptx
@@ -3264,7 +3264,7 @@
           <a:p>
             <a:fld id="{4FCD6A08-F84D-254F-876D-619DDBFD23F2}" type="datetimeFigureOut">
               <a:rPr lang="en-IL" smtClean="0"/>
-              <a:t>18/03/2026</a:t>
+              <a:t>19/03/2026</a:t>
             </a:fld>
             <a:endParaRPr lang="en-IL"/>
           </a:p>
@@ -3705,6 +3705,17 @@
             <a:pPr marL="0" algn="r" defTabSz="914400" rtl="1" eaLnBrk="1" latinLnBrk="0" hangingPunct="1"/>
             <a:r>
               <a:rPr lang="he-IL" dirty="0"/>
+              <a:t>ונעבור לתוצאות:</a:t>
+            </a:r>
+          </a:p>
+          <a:p>
+            <a:pPr marL="0" algn="r" defTabSz="914400" rtl="1" eaLnBrk="1" latinLnBrk="0" hangingPunct="1"/>
+            <a:endParaRPr lang="he-IL" dirty="0"/>
+          </a:p>
+          <a:p>
+            <a:pPr marL="0" algn="r" defTabSz="914400" rtl="1" eaLnBrk="1" latinLnBrk="0" hangingPunct="1"/>
+            <a:r>
+              <a:rPr lang="he-IL" dirty="0"/>
               <a:t>אז לקחתי את </a:t>
             </a:r>
             <a:r>
@@ -5058,7 +5069,18 @@
             </a:r>
             <a:r>
               <a:rPr lang="he-IL" dirty="0"/>
-              <a:t>. אפשר להגיד שיש לנו כאן איזשהו מודל של </a:t>
+              <a:t>.</a:t>
+            </a:r>
+          </a:p>
+          <a:p>
+            <a:pPr marL="0" algn="r" defTabSz="914400" rtl="1" eaLnBrk="1" latinLnBrk="0" hangingPunct="1"/>
+            <a:endParaRPr lang="he-IL" dirty="0"/>
+          </a:p>
+          <a:p>
+            <a:pPr marL="0" algn="r" defTabSz="914400" rtl="1" eaLnBrk="1" latinLnBrk="0" hangingPunct="1"/>
+            <a:r>
+              <a:rPr lang="he-IL" dirty="0"/>
+              <a:t>אפשר להגיד שיש לנו כאן איזשהו מודל של </a:t>
             </a:r>
             <a:r>
               <a:rPr lang="en-US" dirty="0"/>
@@ -5100,6 +5122,10 @@
               <a:rPr lang="he-IL" dirty="0"/>
               <a:t>.</a:t>
             </a:r>
+          </a:p>
+          <a:p>
+            <a:pPr marL="0" algn="r" defTabSz="914400" rtl="1" eaLnBrk="1" latinLnBrk="0" hangingPunct="1"/>
+            <a:endParaRPr lang="he-IL" dirty="0"/>
           </a:p>
           <a:p>
             <a:pPr marL="0" algn="r" defTabSz="914400" rtl="1" eaLnBrk="1" latinLnBrk="0" hangingPunct="1"/>
@@ -5519,6 +5545,10 @@
           </a:p>
           <a:p>
             <a:pPr marL="0" algn="r" defTabSz="914400" rtl="1" eaLnBrk="1" latinLnBrk="0" hangingPunct="1"/>
+            <a:endParaRPr lang="he-IL" dirty="0"/>
+          </a:p>
+          <a:p>
+            <a:pPr marL="0" algn="r" defTabSz="914400" rtl="1" eaLnBrk="1" latinLnBrk="0" hangingPunct="1"/>
             <a:r>
               <a:rPr lang="he-IL" dirty="0"/>
               <a:t>עוד דבר שהיה נחמד לעשות, זה לבדוק </a:t>
@@ -6048,61 +6078,6 @@
               <a:t> ולא מדובר באחד יחיד.</a:t>
             </a:r>
           </a:p>
-          <a:p>
-            <a:pPr marL="0" algn="r" defTabSz="914400" rtl="1" eaLnBrk="1" latinLnBrk="0" hangingPunct="1"/>
-            <a:endParaRPr lang="he-IL" dirty="0"/>
-          </a:p>
-          <a:p>
-            <a:pPr marL="0" marR="0" lvl="0" indent="0" algn="r" defTabSz="914400" rtl="1" eaLnBrk="1" fontAlgn="auto" latinLnBrk="0" hangingPunct="1">
-              <a:lnSpc>
-                <a:spcPct val="100000"/>
-              </a:lnSpc>
-              <a:spcBef>
-                <a:spcPts val="0"/>
-              </a:spcBef>
-              <a:spcAft>
-                <a:spcPts val="0"/>
-              </a:spcAft>
-              <a:buClrTx/>
-              <a:buSzTx/>
-              <a:buFontTx/>
-              <a:buNone/>
-              <a:tabLst/>
-              <a:defRPr/>
-            </a:pPr>
-            <a:r>
-              <a:rPr lang="he-IL" dirty="0"/>
-              <a:t>אחת ההשערות שלי היא ש-</a:t>
-            </a:r>
-            <a:r>
-              <a:rPr lang="en-US" dirty="0"/>
-              <a:t>TP53</a:t>
-            </a:r>
-            <a:r>
-              <a:rPr lang="he-IL" dirty="0"/>
-              <a:t> פגום יכול להוביל ל-</a:t>
-            </a:r>
-            <a:r>
-              <a:rPr lang="en-US" dirty="0"/>
-              <a:t>Copy number variation</a:t>
-            </a:r>
-            <a:r>
-              <a:rPr lang="he-IL" dirty="0"/>
-              <a:t> וכתוצאה מכך לכאוס </a:t>
-            </a:r>
-            <a:r>
-              <a:rPr lang="he-IL" dirty="0" err="1"/>
-              <a:t>גנומי</a:t>
-            </a:r>
-            <a:r>
-              <a:rPr lang="he-IL" dirty="0"/>
-              <a:t>.</a:t>
-            </a:r>
-          </a:p>
-          <a:p>
-            <a:pPr marL="0" algn="r" defTabSz="914400" rtl="1" eaLnBrk="1" latinLnBrk="0" hangingPunct="1"/>
-            <a:endParaRPr lang="he-IL" dirty="0"/>
-          </a:p>
         </p:txBody>
       </p:sp>
       <p:sp>
@@ -6518,6 +6493,14 @@
             </a:r>
             <a:r>
               <a:rPr lang="he-IL" dirty="0"/>
+              <a:t> ביחס למוטציות </a:t>
+            </a:r>
+            <a:r>
+              <a:rPr lang="en-US" dirty="0"/>
+              <a:t>TP53</a:t>
+            </a:r>
+            <a:r>
+              <a:rPr lang="he-IL" dirty="0"/>
               <a:t>, נעזרתי במאמר של </a:t>
             </a:r>
             <a:r>
@@ -6868,7 +6851,7 @@
             </a:r>
             <a:r>
               <a:rPr lang="he-IL" dirty="0"/>
-              <a:t>, 2) כאילו הוא לא נמצא, 3) או משהו באמצע. מהשילוב של שלושת המדידות האלה קיבלנו מספר יחיד, שזה ה-</a:t>
+              <a:t>, 2) כאילו הוא לא נמצא, 3) או משהו באמצע. מהשילוב של שלוש המדידות האלה קיבלנו מספר יחיד, שזה ה-</a:t>
             </a:r>
             <a:r>
               <a:rPr lang="en-US" dirty="0"/>
@@ -7923,7 +7906,7 @@
             <a:fld id="{A37D6D71-8B28-4ED6-B932-04B197003D23}" type="datetimeFigureOut">
               <a:rPr lang="en-US" smtClean="0"/>
               <a:pPr algn="r"/>
-              <a:t>3/18/26</a:t>
+              <a:t>3/19/26</a:t>
             </a:fld>
             <a:endParaRPr lang="en-US" dirty="0"/>
           </a:p>
@@ -8193,7 +8176,7 @@
             <a:fld id="{A37D6D71-8B28-4ED6-B932-04B197003D23}" type="datetimeFigureOut">
               <a:rPr lang="en-US" smtClean="0"/>
               <a:pPr algn="r"/>
-              <a:t>3/18/26</a:t>
+              <a:t>3/19/26</a:t>
             </a:fld>
             <a:endParaRPr lang="en-US" dirty="0"/>
           </a:p>
@@ -8436,7 +8419,7 @@
             <a:fld id="{A37D6D71-8B28-4ED6-B932-04B197003D23}" type="datetimeFigureOut">
               <a:rPr lang="en-US" smtClean="0"/>
               <a:pPr algn="r"/>
-              <a:t>3/18/26</a:t>
+              <a:t>3/19/26</a:t>
             </a:fld>
             <a:endParaRPr lang="en-US" dirty="0"/>
           </a:p>
@@ -8691,7 +8674,7 @@
             <a:fld id="{A37D6D71-8B28-4ED6-B932-04B197003D23}" type="datetimeFigureOut">
               <a:rPr lang="en-US" smtClean="0"/>
               <a:pPr algn="r"/>
-              <a:t>3/18/26</a:t>
+              <a:t>3/19/26</a:t>
             </a:fld>
             <a:endParaRPr lang="en-US" dirty="0"/>
           </a:p>
@@ -9006,7 +8989,7 @@
             <a:fld id="{A37D6D71-8B28-4ED6-B932-04B197003D23}" type="datetimeFigureOut">
               <a:rPr lang="en-US" smtClean="0"/>
               <a:pPr algn="r"/>
-              <a:t>3/18/26</a:t>
+              <a:t>3/19/26</a:t>
             </a:fld>
             <a:endParaRPr lang="en-US" dirty="0"/>
           </a:p>
@@ -9316,7 +9299,7 @@
             <a:fld id="{A37D6D71-8B28-4ED6-B932-04B197003D23}" type="datetimeFigureOut">
               <a:rPr lang="en-US" smtClean="0"/>
               <a:pPr algn="r"/>
-              <a:t>3/18/26</a:t>
+              <a:t>3/19/26</a:t>
             </a:fld>
             <a:endParaRPr lang="en-US" dirty="0"/>
           </a:p>
@@ -9746,7 +9729,7 @@
             <a:fld id="{A37D6D71-8B28-4ED6-B932-04B197003D23}" type="datetimeFigureOut">
               <a:rPr lang="en-US" smtClean="0"/>
               <a:pPr algn="r"/>
-              <a:t>3/18/26</a:t>
+              <a:t>3/19/26</a:t>
             </a:fld>
             <a:endParaRPr lang="en-US" spc="50" dirty="0"/>
           </a:p>
@@ -9912,7 +9895,7 @@
             <a:fld id="{A37D6D71-8B28-4ED6-B932-04B197003D23}" type="datetimeFigureOut">
               <a:rPr lang="en-US" smtClean="0"/>
               <a:pPr algn="r"/>
-              <a:t>3/18/26</a:t>
+              <a:t>3/19/26</a:t>
             </a:fld>
             <a:endParaRPr lang="en-US" dirty="0"/>
           </a:p>
@@ -10015,7 +9998,7 @@
             <a:fld id="{A37D6D71-8B28-4ED6-B932-04B197003D23}" type="datetimeFigureOut">
               <a:rPr lang="en-US" smtClean="0"/>
               <a:pPr algn="r"/>
-              <a:t>3/18/26</a:t>
+              <a:t>3/19/26</a:t>
             </a:fld>
             <a:endParaRPr lang="en-US" dirty="0"/>
           </a:p>
@@ -10401,7 +10384,7 @@
             <a:fld id="{A37D6D71-8B28-4ED6-B932-04B197003D23}" type="datetimeFigureOut">
               <a:rPr lang="en-US" smtClean="0"/>
               <a:pPr algn="r"/>
-              <a:t>3/18/26</a:t>
+              <a:t>3/19/26</a:t>
             </a:fld>
             <a:endParaRPr lang="en-US" dirty="0"/>
           </a:p>
@@ -10698,7 +10681,7 @@
             <a:fld id="{A37D6D71-8B28-4ED6-B932-04B197003D23}" type="datetimeFigureOut">
               <a:rPr lang="en-US" smtClean="0"/>
               <a:pPr algn="r"/>
-              <a:t>3/18/26</a:t>
+              <a:t>3/19/26</a:t>
             </a:fld>
             <a:endParaRPr lang="en-US" spc="50" dirty="0"/>
           </a:p>
@@ -10913,7 +10896,7 @@
             <a:fld id="{A37D6D71-8B28-4ED6-B932-04B197003D23}" type="datetimeFigureOut">
               <a:rPr lang="en-US" smtClean="0"/>
               <a:pPr algn="r"/>
-              <a:t>3/18/26</a:t>
+              <a:t>3/19/26</a:t>
             </a:fld>
             <a:endParaRPr lang="en-US" spc="50" dirty="0"/>
           </a:p>
@@ -12313,7 +12296,7 @@
         </p:blipFill>
         <p:spPr>
           <a:xfrm>
-            <a:off x="3817096" y="2093428"/>
+            <a:off x="3817096" y="2064852"/>
             <a:ext cx="4553129" cy="3948596"/>
           </a:xfrm>
           <a:prstGeom prst="rect">
@@ -21326,7 +21309,7 @@
         </p:nvSpPr>
         <p:spPr>
           <a:xfrm>
-            <a:off x="6308306" y="1988231"/>
+            <a:off x="6784289" y="2018271"/>
             <a:ext cx="3981164" cy="3880773"/>
           </a:xfrm>
         </p:spPr>
@@ -21387,7 +21370,7 @@
         </p:nvSpPr>
         <p:spPr>
           <a:xfrm>
-            <a:off x="1440834" y="2162599"/>
+            <a:off x="1426547" y="2306927"/>
             <a:ext cx="3821288" cy="3880773"/>
           </a:xfrm>
           <a:prstGeom prst="rect">

</xml_diff>